<commit_message>
feat: add officePPT template files and implement TableManager helper
</commit_message>
<xml_diff>
--- a/templates/officePPT.pptx
+++ b/templates/officePPT.pptx
@@ -787,6 +787,7 @@
     </c:legend>
     <c:plotVisOnly val="1"/>
     <c:dispBlanksAs val="gap"/>
+    <c:showDLblsOverMax val="0"/>
     <c:extLst>
       <c:ext xmlns:c16r3="http://schemas.microsoft.com/office/drawing/2017/03/chart" uri="{56B9EC1D-385E-4148-901F-78D8002777C0}">
         <c16r3:dataDisplayOptions16>
@@ -794,7 +795,6 @@
         </c16r3:dataDisplayOptions16>
       </c:ext>
     </c:extLst>
-    <c:showDLblsOverMax val="0"/>
   </c:chart>
   <c:spPr>
     <a:noFill/>
@@ -1244,6 +1244,7 @@
     </c:legend>
     <c:plotVisOnly val="1"/>
     <c:dispBlanksAs val="gap"/>
+    <c:showDLblsOverMax val="0"/>
     <c:extLst>
       <c:ext xmlns:c16r3="http://schemas.microsoft.com/office/drawing/2017/03/chart" uri="{56B9EC1D-385E-4148-901F-78D8002777C0}">
         <c16r3:dataDisplayOptions16>
@@ -1251,7 +1252,6 @@
         </c16r3:dataDisplayOptions16>
       </c:ext>
     </c:extLst>
-    <c:showDLblsOverMax val="0"/>
   </c:chart>
   <c:spPr>
     <a:noFill/>
@@ -2038,6 +2038,7 @@
     </c:plotArea>
     <c:plotVisOnly val="1"/>
     <c:dispBlanksAs val="gap"/>
+    <c:showDLblsOverMax val="0"/>
     <c:extLst>
       <c:ext xmlns:c16r3="http://schemas.microsoft.com/office/drawing/2017/03/chart" uri="{56B9EC1D-385E-4148-901F-78D8002777C0}">
         <c16r3:dataDisplayOptions16>
@@ -2045,7 +2046,6 @@
         </c16r3:dataDisplayOptions16>
       </c:ext>
     </c:extLst>
-    <c:showDLblsOverMax val="0"/>
   </c:chart>
   <c:spPr>
     <a:noFill/>
@@ -3783,7 +3783,7 @@
           <a:p>
             <a:fld id="{8B1AF6D7-0F32-4F05-B21A-8AF0CB26F94C}" type="datetimeFigureOut">
               <a:rPr lang="en-IN" smtClean="0"/>
-              <a:t>26-06-2026</a:t>
+              <a:t>07-07-2026</a:t>
             </a:fld>
             <a:endParaRPr lang="en-IN"/>
           </a:p>
@@ -4980,7 +4980,7 @@
           <a:p>
             <a:fld id="{0490EA95-AFA9-47FA-B067-612933D1D62E}" type="datetimeFigureOut">
               <a:rPr lang="en-IN" smtClean="0"/>
-              <a:t>26-06-2026</a:t>
+              <a:t>07-07-2026</a:t>
             </a:fld>
             <a:endParaRPr lang="en-IN"/>
           </a:p>
@@ -5180,7 +5180,7 @@
           <a:p>
             <a:fld id="{0490EA95-AFA9-47FA-B067-612933D1D62E}" type="datetimeFigureOut">
               <a:rPr lang="en-IN" smtClean="0"/>
-              <a:t>26-06-2026</a:t>
+              <a:t>07-07-2026</a:t>
             </a:fld>
             <a:endParaRPr lang="en-IN"/>
           </a:p>
@@ -5390,7 +5390,7 @@
           <a:p>
             <a:fld id="{0490EA95-AFA9-47FA-B067-612933D1D62E}" type="datetimeFigureOut">
               <a:rPr lang="en-IN" smtClean="0"/>
-              <a:t>26-06-2026</a:t>
+              <a:t>07-07-2026</a:t>
             </a:fld>
             <a:endParaRPr lang="en-IN"/>
           </a:p>
@@ -5590,7 +5590,7 @@
           <a:p>
             <a:fld id="{0490EA95-AFA9-47FA-B067-612933D1D62E}" type="datetimeFigureOut">
               <a:rPr lang="en-IN" smtClean="0"/>
-              <a:t>26-06-2026</a:t>
+              <a:t>07-07-2026</a:t>
             </a:fld>
             <a:endParaRPr lang="en-IN"/>
           </a:p>
@@ -5880,7 +5880,7 @@
           <a:p>
             <a:fld id="{0490EA95-AFA9-47FA-B067-612933D1D62E}" type="datetimeFigureOut">
               <a:rPr lang="en-IN" smtClean="0"/>
-              <a:t>26-06-2026</a:t>
+              <a:t>07-07-2026</a:t>
             </a:fld>
             <a:endParaRPr lang="en-IN"/>
           </a:p>
@@ -6148,7 +6148,7 @@
           <a:p>
             <a:fld id="{0490EA95-AFA9-47FA-B067-612933D1D62E}" type="datetimeFigureOut">
               <a:rPr lang="en-IN" smtClean="0"/>
-              <a:t>26-06-2026</a:t>
+              <a:t>07-07-2026</a:t>
             </a:fld>
             <a:endParaRPr lang="en-IN"/>
           </a:p>
@@ -6563,7 +6563,7 @@
           <a:p>
             <a:fld id="{0490EA95-AFA9-47FA-B067-612933D1D62E}" type="datetimeFigureOut">
               <a:rPr lang="en-IN" smtClean="0"/>
-              <a:t>26-06-2026</a:t>
+              <a:t>07-07-2026</a:t>
             </a:fld>
             <a:endParaRPr lang="en-IN"/>
           </a:p>
@@ -6705,7 +6705,7 @@
           <a:p>
             <a:fld id="{0490EA95-AFA9-47FA-B067-612933D1D62E}" type="datetimeFigureOut">
               <a:rPr lang="en-IN" smtClean="0"/>
-              <a:t>26-06-2026</a:t>
+              <a:t>07-07-2026</a:t>
             </a:fld>
             <a:endParaRPr lang="en-IN"/>
           </a:p>
@@ -6818,7 +6818,7 @@
           <a:p>
             <a:fld id="{0490EA95-AFA9-47FA-B067-612933D1D62E}" type="datetimeFigureOut">
               <a:rPr lang="en-IN" smtClean="0"/>
-              <a:t>26-06-2026</a:t>
+              <a:t>07-07-2026</a:t>
             </a:fld>
             <a:endParaRPr lang="en-IN"/>
           </a:p>
@@ -7131,7 +7131,7 @@
           <a:p>
             <a:fld id="{0490EA95-AFA9-47FA-B067-612933D1D62E}" type="datetimeFigureOut">
               <a:rPr lang="en-IN" smtClean="0"/>
-              <a:t>26-06-2026</a:t>
+              <a:t>07-07-2026</a:t>
             </a:fld>
             <a:endParaRPr lang="en-IN"/>
           </a:p>
@@ -7420,7 +7420,7 @@
           <a:p>
             <a:fld id="{0490EA95-AFA9-47FA-B067-612933D1D62E}" type="datetimeFigureOut">
               <a:rPr lang="en-IN" smtClean="0"/>
-              <a:t>26-06-2026</a:t>
+              <a:t>07-07-2026</a:t>
             </a:fld>
             <a:endParaRPr lang="en-IN"/>
           </a:p>
@@ -7663,7 +7663,7 @@
           <a:p>
             <a:fld id="{0490EA95-AFA9-47FA-B067-612933D1D62E}" type="datetimeFigureOut">
               <a:rPr lang="en-IN" smtClean="0"/>
-              <a:t>26-06-2026</a:t>
+              <a:t>07-07-2026</a:t>
             </a:fld>
             <a:endParaRPr lang="en-IN"/>
           </a:p>
@@ -9739,6 +9739,415 @@
           </a:p>
         </p:txBody>
       </p:sp>
+      <p:graphicFrame>
+        <p:nvGraphicFramePr>
+          <p:cNvPr id="6" name="Table 1">
+            <a:extLst>
+              <a:ext uri="{FF2B5EF4-FFF2-40B4-BE49-F238E27FC236}">
+                <a16:creationId xmlns:a16="http://schemas.microsoft.com/office/drawing/2014/main" id="{4C88D6E7-DC14-A580-34D5-ED6EE5CB3E5B}"/>
+              </a:ext>
+            </a:extLst>
+          </p:cNvPr>
+          <p:cNvGraphicFramePr>
+            <a:graphicFrameLocks noGrp="1"/>
+          </p:cNvGraphicFramePr>
+          <p:nvPr>
+            <p:extLst>
+              <p:ext uri="{D42A27DB-BD31-4B8C-83A1-F6EECF244321}">
+                <p14:modId xmlns:p14="http://schemas.microsoft.com/office/powerpoint/2010/main" val="966796799"/>
+              </p:ext>
+            </p:extLst>
+          </p:nvPr>
+        </p:nvGraphicFramePr>
+        <p:xfrm>
+          <a:off x="6096000" y="40957"/>
+          <a:ext cx="4113823" cy="640080"/>
+        </p:xfrm>
+        <a:graphic>
+          <a:graphicData uri="http://schemas.openxmlformats.org/drawingml/2006/table">
+            <a:tbl>
+              <a:tblPr firstRow="1" bandRow="1">
+                <a:tableStyleId>{5C22544A-7EE6-4342-B048-85BDC9FD1C3A}</a:tableStyleId>
+              </a:tblPr>
+              <a:tblGrid>
+                <a:gridCol w="587689">
+                  <a:extLst>
+                    <a:ext uri="{9D8B030D-6E8A-4147-A177-3AD203B41FA5}">
+                      <a16:colId xmlns:a16="http://schemas.microsoft.com/office/drawing/2014/main" val="597839494"/>
+                    </a:ext>
+                  </a:extLst>
+                </a:gridCol>
+                <a:gridCol w="587689">
+                  <a:extLst>
+                    <a:ext uri="{9D8B030D-6E8A-4147-A177-3AD203B41FA5}">
+                      <a16:colId xmlns:a16="http://schemas.microsoft.com/office/drawing/2014/main" val="2965758537"/>
+                    </a:ext>
+                  </a:extLst>
+                </a:gridCol>
+                <a:gridCol w="587689">
+                  <a:extLst>
+                    <a:ext uri="{9D8B030D-6E8A-4147-A177-3AD203B41FA5}">
+                      <a16:colId xmlns:a16="http://schemas.microsoft.com/office/drawing/2014/main" val="985599110"/>
+                    </a:ext>
+                  </a:extLst>
+                </a:gridCol>
+                <a:gridCol w="587689">
+                  <a:extLst>
+                    <a:ext uri="{9D8B030D-6E8A-4147-A177-3AD203B41FA5}">
+                      <a16:colId xmlns:a16="http://schemas.microsoft.com/office/drawing/2014/main" val="2503815855"/>
+                    </a:ext>
+                  </a:extLst>
+                </a:gridCol>
+                <a:gridCol w="587689">
+                  <a:extLst>
+                    <a:ext uri="{9D8B030D-6E8A-4147-A177-3AD203B41FA5}">
+                      <a16:colId xmlns:a16="http://schemas.microsoft.com/office/drawing/2014/main" val="1132694783"/>
+                    </a:ext>
+                  </a:extLst>
+                </a:gridCol>
+                <a:gridCol w="587689">
+                  <a:extLst>
+                    <a:ext uri="{9D8B030D-6E8A-4147-A177-3AD203B41FA5}">
+                      <a16:colId xmlns:a16="http://schemas.microsoft.com/office/drawing/2014/main" val="870538356"/>
+                    </a:ext>
+                  </a:extLst>
+                </a:gridCol>
+                <a:gridCol w="587689">
+                  <a:extLst>
+                    <a:ext uri="{9D8B030D-6E8A-4147-A177-3AD203B41FA5}">
+                      <a16:colId xmlns:a16="http://schemas.microsoft.com/office/drawing/2014/main" val="140413072"/>
+                    </a:ext>
+                  </a:extLst>
+                </a:gridCol>
+              </a:tblGrid>
+              <a:tr h="0">
+                <a:tc gridSpan="2">
+                  <a:txBody>
+                    <a:bodyPr/>
+                    <a:lstStyle/>
+                    <a:p>
+                      <a:r>
+                        <a:rPr lang="en-US" sz="600" dirty="0"/>
+                        <a:t>Board </a:t>
+                      </a:r>
+                      <a:r>
+                        <a:rPr lang="en-US" sz="600" dirty="0" err="1"/>
+                        <a:t>Compostion</a:t>
+                      </a:r>
+                      <a:r>
+                        <a:rPr lang="en-US" sz="600" dirty="0"/>
+                        <a:t> Data</a:t>
+                      </a:r>
+                      <a:endParaRPr lang="en-IN" sz="600" dirty="0"/>
+                    </a:p>
+                  </a:txBody>
+                  <a:tcPr/>
+                </a:tc>
+                <a:tc hMerge="1">
+                  <a:txBody>
+                    <a:bodyPr/>
+                    <a:lstStyle/>
+                    <a:p>
+                      <a:endParaRPr lang="en-IN" sz="600" dirty="0"/>
+                    </a:p>
+                  </a:txBody>
+                  <a:tcPr/>
+                </a:tc>
+                <a:tc gridSpan="2">
+                  <a:txBody>
+                    <a:bodyPr/>
+                    <a:lstStyle/>
+                    <a:p>
+                      <a:r>
+                        <a:rPr lang="en-US" sz="600" dirty="0"/>
+                        <a:t>Start Date: MMMM-YYYY</a:t>
+                      </a:r>
+                      <a:endParaRPr lang="en-IN" sz="600" dirty="0"/>
+                    </a:p>
+                  </a:txBody>
+                  <a:tcPr/>
+                </a:tc>
+                <a:tc hMerge="1">
+                  <a:txBody>
+                    <a:bodyPr/>
+                    <a:lstStyle/>
+                    <a:p>
+                      <a:endParaRPr lang="en-IN" sz="600" dirty="0"/>
+                    </a:p>
+                  </a:txBody>
+                  <a:tcPr/>
+                </a:tc>
+                <a:tc gridSpan="3">
+                  <a:txBody>
+                    <a:bodyPr/>
+                    <a:lstStyle/>
+                    <a:p>
+                      <a:pPr marL="0" marR="0" lvl="0" indent="0" algn="l" defTabSz="914400" rtl="0" eaLnBrk="1" fontAlgn="auto" latinLnBrk="0" hangingPunct="1">
+                        <a:lnSpc>
+                          <a:spcPct val="100000"/>
+                        </a:lnSpc>
+                        <a:spcBef>
+                          <a:spcPts val="0"/>
+                        </a:spcBef>
+                        <a:spcAft>
+                          <a:spcPts val="0"/>
+                        </a:spcAft>
+                        <a:buClrTx/>
+                        <a:buSzTx/>
+                        <a:buFontTx/>
+                        <a:buNone/>
+                        <a:tabLst/>
+                        <a:defRPr/>
+                      </a:pPr>
+                      <a:r>
+                        <a:rPr lang="en-US" sz="600" dirty="0"/>
+                        <a:t>End Date: MMMM-YYYY</a:t>
+                      </a:r>
+                      <a:endParaRPr lang="en-IN" sz="600" dirty="0"/>
+                    </a:p>
+                  </a:txBody>
+                  <a:tcPr/>
+                </a:tc>
+                <a:tc hMerge="1">
+                  <a:txBody>
+                    <a:bodyPr/>
+                    <a:lstStyle/>
+                    <a:p>
+                      <a:endParaRPr lang="en-IN" sz="600" dirty="0"/>
+                    </a:p>
+                  </a:txBody>
+                  <a:tcPr/>
+                </a:tc>
+                <a:tc hMerge="1">
+                  <a:txBody>
+                    <a:bodyPr/>
+                    <a:lstStyle/>
+                    <a:p>
+                      <a:endParaRPr lang="en-IN" sz="600" dirty="0"/>
+                    </a:p>
+                  </a:txBody>
+                  <a:tcPr/>
+                </a:tc>
+                <a:extLst>
+                  <a:ext uri="{0D108BD9-81ED-4DB2-BD59-A6C34878D82A}">
+                    <a16:rowId xmlns:a16="http://schemas.microsoft.com/office/drawing/2014/main" val="611380770"/>
+                  </a:ext>
+                </a:extLst>
+              </a:tr>
+              <a:tr h="0">
+                <a:tc>
+                  <a:txBody>
+                    <a:bodyPr/>
+                    <a:lstStyle/>
+                    <a:p>
+                      <a:r>
+                        <a:rPr lang="en-US" sz="600" dirty="0"/>
+                        <a:t>NAME</a:t>
+                      </a:r>
+                      <a:endParaRPr lang="en-IN" sz="600" dirty="0"/>
+                    </a:p>
+                  </a:txBody>
+                  <a:tcPr/>
+                </a:tc>
+                <a:tc>
+                  <a:txBody>
+                    <a:bodyPr/>
+                    <a:lstStyle/>
+                    <a:p>
+                      <a:r>
+                        <a:rPr lang="en-US" sz="600" dirty="0"/>
+                        <a:t>PIF EMPLOYEE</a:t>
+                      </a:r>
+                      <a:endParaRPr lang="en-IN" sz="600" dirty="0"/>
+                    </a:p>
+                  </a:txBody>
+                  <a:tcPr/>
+                </a:tc>
+                <a:tc>
+                  <a:txBody>
+                    <a:bodyPr/>
+                    <a:lstStyle/>
+                    <a:p>
+                      <a:r>
+                        <a:rPr lang="en-US" sz="600" dirty="0"/>
+                        <a:t>OTHER PIF REP.</a:t>
+                      </a:r>
+                      <a:endParaRPr lang="en-IN" sz="600" dirty="0"/>
+                    </a:p>
+                  </a:txBody>
+                  <a:tcPr/>
+                </a:tc>
+                <a:tc>
+                  <a:txBody>
+                    <a:bodyPr/>
+                    <a:lstStyle/>
+                    <a:p>
+                      <a:r>
+                        <a:rPr lang="en-US" sz="600" dirty="0"/>
+                        <a:t>BOARD</a:t>
+                      </a:r>
+                      <a:endParaRPr lang="en-IN" sz="600" dirty="0"/>
+                    </a:p>
+                  </a:txBody>
+                  <a:tcPr/>
+                </a:tc>
+                <a:tc>
+                  <a:txBody>
+                    <a:bodyPr/>
+                    <a:lstStyle/>
+                    <a:p>
+                      <a:r>
+                        <a:rPr lang="en-US" sz="600" dirty="0"/>
+                        <a:t>EXCOM</a:t>
+                      </a:r>
+                      <a:endParaRPr lang="en-IN" sz="600" dirty="0"/>
+                    </a:p>
+                  </a:txBody>
+                  <a:tcPr/>
+                </a:tc>
+                <a:tc>
+                  <a:txBody>
+                    <a:bodyPr/>
+                    <a:lstStyle/>
+                    <a:p>
+                      <a:r>
+                        <a:rPr lang="en-US" sz="600" dirty="0"/>
+                        <a:t>AUDIT</a:t>
+                      </a:r>
+                      <a:endParaRPr lang="en-IN" sz="600" dirty="0"/>
+                    </a:p>
+                  </a:txBody>
+                  <a:tcPr/>
+                </a:tc>
+                <a:tc>
+                  <a:txBody>
+                    <a:bodyPr/>
+                    <a:lstStyle/>
+                    <a:p>
+                      <a:r>
+                        <a:rPr lang="en-US" sz="600" dirty="0"/>
+                        <a:t>NRC</a:t>
+                      </a:r>
+                      <a:endParaRPr lang="en-IN" sz="600" dirty="0"/>
+                    </a:p>
+                  </a:txBody>
+                  <a:tcPr/>
+                </a:tc>
+                <a:extLst>
+                  <a:ext uri="{0D108BD9-81ED-4DB2-BD59-A6C34878D82A}">
+                    <a16:rowId xmlns:a16="http://schemas.microsoft.com/office/drawing/2014/main" val="1077373604"/>
+                  </a:ext>
+                </a:extLst>
+              </a:tr>
+              <a:tr h="0">
+                <a:tc>
+                  <a:txBody>
+                    <a:bodyPr/>
+                    <a:lstStyle/>
+                    <a:p>
+                      <a:r>
+                        <a:rPr lang="en-US" sz="600" dirty="0"/>
+                        <a:t>a</a:t>
+                      </a:r>
+                      <a:endParaRPr lang="en-IN" sz="600" dirty="0"/>
+                    </a:p>
+                  </a:txBody>
+                  <a:tcPr/>
+                </a:tc>
+                <a:tc>
+                  <a:txBody>
+                    <a:bodyPr/>
+                    <a:lstStyle/>
+                    <a:p>
+                      <a:r>
+                        <a:rPr lang="en-US" sz="600" dirty="0"/>
+                        <a:t>A</a:t>
+                      </a:r>
+                      <a:endParaRPr lang="en-IN" sz="600" dirty="0"/>
+                    </a:p>
+                  </a:txBody>
+                  <a:tcPr/>
+                </a:tc>
+                <a:tc>
+                  <a:txBody>
+                    <a:bodyPr/>
+                    <a:lstStyle/>
+                    <a:p>
+                      <a:r>
+                        <a:rPr lang="en-US" sz="600" dirty="0"/>
+                        <a:t>A</a:t>
+                      </a:r>
+                      <a:endParaRPr lang="en-IN" sz="600" dirty="0"/>
+                    </a:p>
+                  </a:txBody>
+                  <a:tcPr/>
+                </a:tc>
+                <a:tc>
+                  <a:txBody>
+                    <a:bodyPr/>
+                    <a:lstStyle/>
+                    <a:p>
+                      <a:r>
+                        <a:rPr lang="en-US" sz="600" dirty="0"/>
+                        <a:t>A</a:t>
+                      </a:r>
+                      <a:endParaRPr lang="en-IN" sz="600" dirty="0"/>
+                    </a:p>
+                  </a:txBody>
+                  <a:tcPr/>
+                </a:tc>
+                <a:tc>
+                  <a:txBody>
+                    <a:bodyPr/>
+                    <a:lstStyle/>
+                    <a:p>
+                      <a:r>
+                        <a:rPr lang="en-US" sz="600" dirty="0"/>
+                        <a:t>A</a:t>
+                      </a:r>
+                      <a:endParaRPr lang="en-IN" sz="600" dirty="0"/>
+                    </a:p>
+                  </a:txBody>
+                  <a:tcPr/>
+                </a:tc>
+                <a:tc>
+                  <a:txBody>
+                    <a:bodyPr/>
+                    <a:lstStyle/>
+                    <a:p>
+                      <a:r>
+                        <a:rPr lang="en-US" sz="600" dirty="0"/>
+                        <a:t>A</a:t>
+                      </a:r>
+                      <a:endParaRPr lang="en-IN" sz="600" dirty="0"/>
+                    </a:p>
+                  </a:txBody>
+                  <a:tcPr/>
+                </a:tc>
+                <a:tc>
+                  <a:txBody>
+                    <a:bodyPr/>
+                    <a:lstStyle/>
+                    <a:p>
+                      <a:r>
+                        <a:rPr lang="en-US" sz="600" dirty="0"/>
+                        <a:t>a</a:t>
+                      </a:r>
+                      <a:endParaRPr lang="en-IN" sz="600" dirty="0"/>
+                    </a:p>
+                  </a:txBody>
+                  <a:tcPr/>
+                </a:tc>
+                <a:extLst>
+                  <a:ext uri="{0D108BD9-81ED-4DB2-BD59-A6C34878D82A}">
+                    <a16:rowId xmlns:a16="http://schemas.microsoft.com/office/drawing/2014/main" val="609257130"/>
+                  </a:ext>
+                </a:extLst>
+              </a:tr>
+            </a:tbl>
+          </a:graphicData>
+        </a:graphic>
+      </p:graphicFrame>
     </p:spTree>
     <p:extLst>
       <p:ext uri="{BB962C8B-B14F-4D97-AF65-F5344CB8AC3E}">
@@ -11110,12 +11519,6 @@
 </file>
 
 <file path=customXml/item1.xml><?xml version="1.0" encoding="utf-8"?>
-<sisl xmlns:xsd="http://www.w3.org/2001/XMLSchema" xmlns:xsi="http://www.w3.org/2001/XMLSchema-instance" xmlns="http://www.boldonjames.com/2008/01/sie/internal/label" sislVersion="0" policy="4f3ffa34-8ea5-4d04-9688-c0eeb614b05f" origin="userSelected">
-  <element uid="id_classification_nonbusiness" value=""/>
-</sisl>
-</file>
-
-<file path=customXml/item2.xml><?xml version="1.0" encoding="utf-8"?>
 <WrappedLabelInfo xmlns:xsd="http://www.w3.org/2001/XMLSchema" xmlns:xsi="http://www.w3.org/2001/XMLSchema-instance" xmlns="http://www.boldonjames.com/2016/02/Classifier/internal/wrappedLabelInfo">
   <Value>
         PD94bWwgdmVyc2lvbj0iMS4wIiBlbmNvZGluZz0idXMtYXNjaWkiPz48TGFiZWxJbmZvWG1sUGFydCB4bWxuczp4c2Q9Imh0dHA6Ly93d3cudzMub3JnLzIwMDEvWE1MU2NoZW1hIiB4bWxuczp4c2k9Imh0dHA6Ly93d3cudzMub3JnLzIwMDEvWE1MU2NoZW1hLWluc3RhbmNlIiB4bWxucz0iaHR0cDovL3d3dy5ib2xkb25qYW1lcy5jb20vMjAxNi8wMi9DbGFzc2lmaWVyL2ludGVybmFsL2xhYmVsSW5mbyI+PGVsaD5zS0dRS1drK1lkdW5pR1dnWEZKaXhOaHZncEpxN1VHWTwvZWxoPjxjb25maWc+UElGX1BST0Q8L2NvbmZpZz48cG9sPlBJRl9QUk9EPC9wb2w+PHN1bW1hcnk+UHVibGljPC9zdW1tYXJ5PjxhcHA+UG93ZXJQb2ludDwvYXBwPjxTaWduYXR1cmVWYWxpZD5mYWxzZTwvU2lnbmF0dXJlVmFsaWQ+PC9MYWJlbEluZm9YbWxQYXJ0Pg==</Value>
@@ -11146,16 +11549,13 @@
 </WrappedLabelInfo>
 </file>
 
-<file path=customXml/itemProps1.xml><?xml version="1.0" encoding="utf-8"?>
-<ds:datastoreItem xmlns:ds="http://schemas.openxmlformats.org/officeDocument/2006/customXml" ds:itemID="{1F932E4C-D55E-4037-A535-9777C851BCE7}">
-  <ds:schemaRefs>
-    <ds:schemaRef ds:uri="http://www.w3.org/2001/XMLSchema"/>
-    <ds:schemaRef ds:uri="http://www.boldonjames.com/2008/01/sie/internal/label"/>
-  </ds:schemaRefs>
-</ds:datastoreItem>
+<file path=customXml/item2.xml><?xml version="1.0" encoding="utf-8"?>
+<sisl xmlns:xsd="http://www.w3.org/2001/XMLSchema" xmlns:xsi="http://www.w3.org/2001/XMLSchema-instance" xmlns="http://www.boldonjames.com/2008/01/sie/internal/label" sislVersion="0" policy="4f3ffa34-8ea5-4d04-9688-c0eeb614b05f" origin="userSelected">
+  <element uid="id_classification_nonbusiness" value=""/>
+</sisl>
 </file>
 
-<file path=customXml/itemProps2.xml><?xml version="1.0" encoding="utf-8"?>
+<file path=customXml/itemProps1.xml><?xml version="1.0" encoding="utf-8"?>
 <ds:datastoreItem xmlns:ds="http://schemas.openxmlformats.org/officeDocument/2006/customXml" ds:itemID="{DA1CAF05-4605-4D79-B2CD-2732286DB1E6}">
   <ds:schemaRefs>
     <ds:schemaRef ds:uri="http://www.w3.org/2001/XMLSchema"/>
@@ -11164,4 +11564,13 @@
     <ds:schemaRef ds:uri=""/>
   </ds:schemaRefs>
 </ds:datastoreItem>
+</file>
+
+<file path=customXml/itemProps2.xml><?xml version="1.0" encoding="utf-8"?>
+<ds:datastoreItem xmlns:ds="http://schemas.openxmlformats.org/officeDocument/2006/customXml" ds:itemID="{1F932E4C-D55E-4037-A535-9777C851BCE7}">
+  <ds:schemaRefs>
+    <ds:schemaRef ds:uri="http://www.w3.org/2001/XMLSchema"/>
+    <ds:schemaRef ds:uri="http://www.boldonjames.com/2008/01/sie/internal/label"/>
+  </ds:schemaRefs>
+</ds:datastoreItem>
 </file>
</xml_diff>

<commit_message>
feat: implement Chart and Table managers and add support for new PPTX template structures
</commit_message>
<xml_diff>
--- a/templates/officePPT.pptx
+++ b/templates/officePPT.pptx
@@ -3783,7 +3783,7 @@
           <a:p>
             <a:fld id="{8B1AF6D7-0F32-4F05-B21A-8AF0CB26F94C}" type="datetimeFigureOut">
               <a:rPr lang="en-IN" smtClean="0"/>
-              <a:t>07-07-2026</a:t>
+              <a:t>08-07-2026</a:t>
             </a:fld>
             <a:endParaRPr lang="en-IN"/>
           </a:p>
@@ -4980,7 +4980,7 @@
           <a:p>
             <a:fld id="{0490EA95-AFA9-47FA-B067-612933D1D62E}" type="datetimeFigureOut">
               <a:rPr lang="en-IN" smtClean="0"/>
-              <a:t>07-07-2026</a:t>
+              <a:t>08-07-2026</a:t>
             </a:fld>
             <a:endParaRPr lang="en-IN"/>
           </a:p>
@@ -5180,7 +5180,7 @@
           <a:p>
             <a:fld id="{0490EA95-AFA9-47FA-B067-612933D1D62E}" type="datetimeFigureOut">
               <a:rPr lang="en-IN" smtClean="0"/>
-              <a:t>07-07-2026</a:t>
+              <a:t>08-07-2026</a:t>
             </a:fld>
             <a:endParaRPr lang="en-IN"/>
           </a:p>
@@ -5390,7 +5390,7 @@
           <a:p>
             <a:fld id="{0490EA95-AFA9-47FA-B067-612933D1D62E}" type="datetimeFigureOut">
               <a:rPr lang="en-IN" smtClean="0"/>
-              <a:t>07-07-2026</a:t>
+              <a:t>08-07-2026</a:t>
             </a:fld>
             <a:endParaRPr lang="en-IN"/>
           </a:p>
@@ -5590,7 +5590,7 @@
           <a:p>
             <a:fld id="{0490EA95-AFA9-47FA-B067-612933D1D62E}" type="datetimeFigureOut">
               <a:rPr lang="en-IN" smtClean="0"/>
-              <a:t>07-07-2026</a:t>
+              <a:t>08-07-2026</a:t>
             </a:fld>
             <a:endParaRPr lang="en-IN"/>
           </a:p>
@@ -5880,7 +5880,7 @@
           <a:p>
             <a:fld id="{0490EA95-AFA9-47FA-B067-612933D1D62E}" type="datetimeFigureOut">
               <a:rPr lang="en-IN" smtClean="0"/>
-              <a:t>07-07-2026</a:t>
+              <a:t>08-07-2026</a:t>
             </a:fld>
             <a:endParaRPr lang="en-IN"/>
           </a:p>
@@ -6148,7 +6148,7 @@
           <a:p>
             <a:fld id="{0490EA95-AFA9-47FA-B067-612933D1D62E}" type="datetimeFigureOut">
               <a:rPr lang="en-IN" smtClean="0"/>
-              <a:t>07-07-2026</a:t>
+              <a:t>08-07-2026</a:t>
             </a:fld>
             <a:endParaRPr lang="en-IN"/>
           </a:p>
@@ -6563,7 +6563,7 @@
           <a:p>
             <a:fld id="{0490EA95-AFA9-47FA-B067-612933D1D62E}" type="datetimeFigureOut">
               <a:rPr lang="en-IN" smtClean="0"/>
-              <a:t>07-07-2026</a:t>
+              <a:t>08-07-2026</a:t>
             </a:fld>
             <a:endParaRPr lang="en-IN"/>
           </a:p>
@@ -6705,7 +6705,7 @@
           <a:p>
             <a:fld id="{0490EA95-AFA9-47FA-B067-612933D1D62E}" type="datetimeFigureOut">
               <a:rPr lang="en-IN" smtClean="0"/>
-              <a:t>07-07-2026</a:t>
+              <a:t>08-07-2026</a:t>
             </a:fld>
             <a:endParaRPr lang="en-IN"/>
           </a:p>
@@ -6818,7 +6818,7 @@
           <a:p>
             <a:fld id="{0490EA95-AFA9-47FA-B067-612933D1D62E}" type="datetimeFigureOut">
               <a:rPr lang="en-IN" smtClean="0"/>
-              <a:t>07-07-2026</a:t>
+              <a:t>08-07-2026</a:t>
             </a:fld>
             <a:endParaRPr lang="en-IN"/>
           </a:p>
@@ -7131,7 +7131,7 @@
           <a:p>
             <a:fld id="{0490EA95-AFA9-47FA-B067-612933D1D62E}" type="datetimeFigureOut">
               <a:rPr lang="en-IN" smtClean="0"/>
-              <a:t>07-07-2026</a:t>
+              <a:t>08-07-2026</a:t>
             </a:fld>
             <a:endParaRPr lang="en-IN"/>
           </a:p>
@@ -7420,7 +7420,7 @@
           <a:p>
             <a:fld id="{0490EA95-AFA9-47FA-B067-612933D1D62E}" type="datetimeFigureOut">
               <a:rPr lang="en-IN" smtClean="0"/>
-              <a:t>07-07-2026</a:t>
+              <a:t>08-07-2026</a:t>
             </a:fld>
             <a:endParaRPr lang="en-IN"/>
           </a:p>
@@ -7663,7 +7663,7 @@
           <a:p>
             <a:fld id="{0490EA95-AFA9-47FA-B067-612933D1D62E}" type="datetimeFigureOut">
               <a:rPr lang="en-IN" smtClean="0"/>
-              <a:t>07-07-2026</a:t>
+              <a:t>08-07-2026</a:t>
             </a:fld>
             <a:endParaRPr lang="en-IN"/>
           </a:p>
@@ -8193,10 +8193,10 @@
       </p:graphicFrame>
       <p:sp>
         <p:nvSpPr>
-          <p:cNvPr id="5" name="Footer Placeholder 4">
+          <p:cNvPr id="4" name="Footer Placeholder 3">
             <a:extLst>
               <a:ext uri="{FF2B5EF4-FFF2-40B4-BE49-F238E27FC236}">
-                <a16:creationId xmlns:a16="http://schemas.microsoft.com/office/drawing/2014/main" id="{A4EB2420-B09B-4DFD-B28E-37DDE47DFA71}"/>
+                <a16:creationId xmlns:a16="http://schemas.microsoft.com/office/drawing/2014/main" id="{2E80303B-D788-4D39-A1D0-32C5F90213D0}"/>
               </a:ext>
             </a:extLst>
           </p:cNvPr>
@@ -8320,10 +8320,10 @@
       </p:graphicFrame>
       <p:sp>
         <p:nvSpPr>
-          <p:cNvPr id="4" name="Footer Placeholder 3">
+          <p:cNvPr id="3" name="Footer Placeholder 2">
             <a:extLst>
               <a:ext uri="{FF2B5EF4-FFF2-40B4-BE49-F238E27FC236}">
-                <a16:creationId xmlns:a16="http://schemas.microsoft.com/office/drawing/2014/main" id="{0A82AB87-F5C6-4A29-A383-B9C3449C5CAE}"/>
+                <a16:creationId xmlns:a16="http://schemas.microsoft.com/office/drawing/2014/main" id="{4AB522F2-E5A7-4F5D-999D-810C8CB35B71}"/>
               </a:ext>
             </a:extLst>
           </p:cNvPr>
@@ -9319,10 +9319,10 @@
       </p:sp>
       <p:sp>
         <p:nvSpPr>
-          <p:cNvPr id="13" name="Footer Placeholder 12">
+          <p:cNvPr id="12" name="Footer Placeholder 11">
             <a:extLst>
               <a:ext uri="{FF2B5EF4-FFF2-40B4-BE49-F238E27FC236}">
-                <a16:creationId xmlns:a16="http://schemas.microsoft.com/office/drawing/2014/main" id="{6F8B634C-829C-4055-8907-6A01C93C3E7F}"/>
+                <a16:creationId xmlns:a16="http://schemas.microsoft.com/office/drawing/2014/main" id="{1672FF25-2EE4-4CCB-8E91-567C30CA9325}"/>
               </a:ext>
             </a:extLst>
           </p:cNvPr>
@@ -9563,10 +9563,10 @@
       </p:sp>
       <p:sp>
         <p:nvSpPr>
-          <p:cNvPr id="7" name="Footer Placeholder 6">
+          <p:cNvPr id="6" name="Footer Placeholder 5">
             <a:extLst>
               <a:ext uri="{FF2B5EF4-FFF2-40B4-BE49-F238E27FC236}">
-                <a16:creationId xmlns:a16="http://schemas.microsoft.com/office/drawing/2014/main" id="{010F6015-4DD0-471D-A60C-AB6C888A6AD0}"/>
+                <a16:creationId xmlns:a16="http://schemas.microsoft.com/office/drawing/2014/main" id="{6D551B71-AFB5-4983-9668-CCD00F9D7E49}"/>
               </a:ext>
             </a:extLst>
           </p:cNvPr>
@@ -9708,12 +9708,1629 @@
           </a:p>
         </p:txBody>
       </p:sp>
+      <p:graphicFrame>
+        <p:nvGraphicFramePr>
+          <p:cNvPr id="5" name="Board Data">
+            <a:extLst>
+              <a:ext uri="{FF2B5EF4-FFF2-40B4-BE49-F238E27FC236}">
+                <a16:creationId xmlns:a16="http://schemas.microsoft.com/office/drawing/2014/main" id="{200C1D5F-0C2A-486C-A767-14A24E5AA098}"/>
+              </a:ext>
+            </a:extLst>
+          </p:cNvPr>
+          <p:cNvGraphicFramePr>
+            <a:graphicFrameLocks noGrp="1"/>
+          </p:cNvGraphicFramePr>
+          <p:nvPr>
+            <p:extLst>
+              <p:ext uri="{D42A27DB-BD31-4B8C-83A1-F6EECF244321}">
+                <p14:modId xmlns:p14="http://schemas.microsoft.com/office/powerpoint/2010/main" val="131546633"/>
+              </p:ext>
+            </p:extLst>
+          </p:nvPr>
+        </p:nvGraphicFramePr>
+        <p:xfrm>
+          <a:off x="6941467" y="136525"/>
+          <a:ext cx="4334512" cy="457200"/>
+        </p:xfrm>
+        <a:graphic>
+          <a:graphicData uri="http://schemas.openxmlformats.org/drawingml/2006/table">
+            <a:tbl>
+              <a:tblPr firstRow="1">
+                <a:tableStyleId>{5C22544A-7EE6-4342-B048-85BDC9FD1C3A}</a:tableStyleId>
+              </a:tblPr>
+              <a:tblGrid>
+                <a:gridCol w="619216">
+                  <a:extLst>
+                    <a:ext uri="{9D8B030D-6E8A-4147-A177-3AD203B41FA5}">
+                      <a16:colId xmlns:a16="http://schemas.microsoft.com/office/drawing/2014/main" val="2710512592"/>
+                    </a:ext>
+                  </a:extLst>
+                </a:gridCol>
+                <a:gridCol w="1152494">
+                  <a:extLst>
+                    <a:ext uri="{9D8B030D-6E8A-4147-A177-3AD203B41FA5}">
+                      <a16:colId xmlns:a16="http://schemas.microsoft.com/office/drawing/2014/main" val="3519371818"/>
+                    </a:ext>
+                  </a:extLst>
+                </a:gridCol>
+                <a:gridCol w="738554">
+                  <a:extLst>
+                    <a:ext uri="{9D8B030D-6E8A-4147-A177-3AD203B41FA5}">
+                      <a16:colId xmlns:a16="http://schemas.microsoft.com/office/drawing/2014/main" val="4260604003"/>
+                    </a:ext>
+                  </a:extLst>
+                </a:gridCol>
+                <a:gridCol w="580292">
+                  <a:extLst>
+                    <a:ext uri="{9D8B030D-6E8A-4147-A177-3AD203B41FA5}">
+                      <a16:colId xmlns:a16="http://schemas.microsoft.com/office/drawing/2014/main" val="958991336"/>
+                    </a:ext>
+                  </a:extLst>
+                </a:gridCol>
+                <a:gridCol w="457200">
+                  <a:extLst>
+                    <a:ext uri="{9D8B030D-6E8A-4147-A177-3AD203B41FA5}">
+                      <a16:colId xmlns:a16="http://schemas.microsoft.com/office/drawing/2014/main" val="4239024402"/>
+                    </a:ext>
+                  </a:extLst>
+                </a:gridCol>
+                <a:gridCol w="474785">
+                  <a:extLst>
+                    <a:ext uri="{9D8B030D-6E8A-4147-A177-3AD203B41FA5}">
+                      <a16:colId xmlns:a16="http://schemas.microsoft.com/office/drawing/2014/main" val="505228023"/>
+                    </a:ext>
+                  </a:extLst>
+                </a:gridCol>
+                <a:gridCol w="311971">
+                  <a:extLst>
+                    <a:ext uri="{9D8B030D-6E8A-4147-A177-3AD203B41FA5}">
+                      <a16:colId xmlns:a16="http://schemas.microsoft.com/office/drawing/2014/main" val="3014002297"/>
+                    </a:ext>
+                  </a:extLst>
+                </a:gridCol>
+              </a:tblGrid>
+              <a:tr h="182880">
+                <a:tc gridSpan="2">
+                  <a:txBody>
+                    <a:bodyPr/>
+                    <a:lstStyle/>
+                    <a:p>
+                      <a:pPr algn="l">
+                        <a:lnSpc>
+                          <a:spcPts val="1300"/>
+                        </a:lnSpc>
+                      </a:pPr>
+                      <a:r>
+                        <a:rPr lang="en-US" sz="600" b="0" i="0" dirty="0">
+                          <a:solidFill>
+                            <a:schemeClr val="bg1"/>
+                          </a:solidFill>
+                          <a:latin typeface="Fund Regular" pitchFamily="2" charset="-78"/>
+                          <a:cs typeface="Fund Regular" pitchFamily="2" charset="-78"/>
+                        </a:rPr>
+                        <a:t>BOARD COMPOSITION DATA</a:t>
+                      </a:r>
+                    </a:p>
+                  </a:txBody>
+                  <a:tcPr marL="36000" marR="36000" marT="0" marB="0" anchor="ctr">
+                    <a:lnL w="3175" cap="flat" cmpd="sng" algn="ctr">
+                      <a:solidFill>
+                        <a:schemeClr val="bg1"/>
+                      </a:solidFill>
+                      <a:prstDash val="solid"/>
+                      <a:round/>
+                      <a:headEnd type="none" w="med" len="med"/>
+                      <a:tailEnd type="none" w="med" len="med"/>
+                    </a:lnL>
+                    <a:lnR w="3175" cap="flat" cmpd="sng" algn="ctr">
+                      <a:solidFill>
+                        <a:schemeClr val="bg1"/>
+                      </a:solidFill>
+                      <a:prstDash val="solid"/>
+                      <a:round/>
+                      <a:headEnd type="none" w="med" len="med"/>
+                      <a:tailEnd type="none" w="med" len="med"/>
+                    </a:lnR>
+                    <a:lnT w="3175" cap="flat" cmpd="sng" algn="ctr">
+                      <a:solidFill>
+                        <a:schemeClr val="bg1"/>
+                      </a:solidFill>
+                      <a:prstDash val="solid"/>
+                      <a:round/>
+                      <a:headEnd type="none" w="med" len="med"/>
+                      <a:tailEnd type="none" w="med" len="med"/>
+                    </a:lnT>
+                    <a:lnB w="3175" cap="flat" cmpd="sng" algn="ctr">
+                      <a:solidFill>
+                        <a:schemeClr val="bg1"/>
+                      </a:solidFill>
+                      <a:prstDash val="solid"/>
+                      <a:round/>
+                      <a:headEnd type="none" w="med" len="med"/>
+                      <a:tailEnd type="none" w="med" len="med"/>
+                    </a:lnB>
+                    <a:lnTlToBr w="12700" cmpd="sng">
+                      <a:noFill/>
+                      <a:prstDash val="solid"/>
+                    </a:lnTlToBr>
+                    <a:lnBlToTr w="12700" cmpd="sng">
+                      <a:noFill/>
+                      <a:prstDash val="solid"/>
+                    </a:lnBlToTr>
+                    <a:solidFill>
+                      <a:schemeClr val="tx2"/>
+                    </a:solidFill>
+                  </a:tcPr>
+                </a:tc>
+                <a:tc hMerge="1">
+                  <a:txBody>
+                    <a:bodyPr/>
+                    <a:lstStyle/>
+                    <a:p>
+                      <a:pPr>
+                        <a:lnSpc>
+                          <a:spcPts val="1300"/>
+                        </a:lnSpc>
+                      </a:pPr>
+                      <a:endParaRPr lang="en-US" sz="1200" dirty="0">
+                        <a:solidFill>
+                          <a:schemeClr val="bg1"/>
+                        </a:solidFill>
+                        <a:latin typeface="Sakkal Majalla" panose="02000000000000000000" pitchFamily="2" charset="-78"/>
+                        <a:cs typeface="Sakkal Majalla" panose="02000000000000000000" pitchFamily="2" charset="-78"/>
+                      </a:endParaRPr>
+                    </a:p>
+                  </a:txBody>
+                  <a:tcPr marL="36000" marR="36000" marT="0" marB="0" anchor="ctr">
+                    <a:lnL w="3175" cap="flat" cmpd="sng" algn="ctr">
+                      <a:solidFill>
+                        <a:schemeClr val="bg1"/>
+                      </a:solidFill>
+                      <a:prstDash val="solid"/>
+                      <a:round/>
+                      <a:headEnd type="none" w="med" len="med"/>
+                      <a:tailEnd type="none" w="med" len="med"/>
+                    </a:lnL>
+                    <a:lnR w="3175" cap="flat" cmpd="sng" algn="ctr">
+                      <a:solidFill>
+                        <a:schemeClr val="bg1"/>
+                      </a:solidFill>
+                      <a:prstDash val="solid"/>
+                      <a:round/>
+                      <a:headEnd type="none" w="med" len="med"/>
+                      <a:tailEnd type="none" w="med" len="med"/>
+                    </a:lnR>
+                    <a:lnT w="3175" cap="flat" cmpd="sng" algn="ctr">
+                      <a:solidFill>
+                        <a:schemeClr val="bg1"/>
+                      </a:solidFill>
+                      <a:prstDash val="solid"/>
+                      <a:round/>
+                      <a:headEnd type="none" w="med" len="med"/>
+                      <a:tailEnd type="none" w="med" len="med"/>
+                    </a:lnT>
+                    <a:lnB w="3175" cap="flat" cmpd="sng" algn="ctr">
+                      <a:solidFill>
+                        <a:schemeClr val="bg1"/>
+                      </a:solidFill>
+                      <a:prstDash val="solid"/>
+                      <a:round/>
+                      <a:headEnd type="none" w="med" len="med"/>
+                      <a:tailEnd type="none" w="med" len="med"/>
+                    </a:lnB>
+                    <a:lnTlToBr w="12700" cmpd="sng">
+                      <a:noFill/>
+                      <a:prstDash val="solid"/>
+                    </a:lnTlToBr>
+                    <a:lnBlToTr w="12700" cmpd="sng">
+                      <a:noFill/>
+                      <a:prstDash val="solid"/>
+                    </a:lnBlToTr>
+                    <a:solidFill>
+                      <a:schemeClr val="tx2"/>
+                    </a:solidFill>
+                  </a:tcPr>
+                </a:tc>
+                <a:tc gridSpan="2">
+                  <a:txBody>
+                    <a:bodyPr/>
+                    <a:lstStyle/>
+                    <a:p>
+                      <a:pPr algn="l">
+                        <a:lnSpc>
+                          <a:spcPts val="1300"/>
+                        </a:lnSpc>
+                      </a:pPr>
+                      <a:r>
+                        <a:rPr lang="en-US" sz="600" b="0" i="0" kern="1200" dirty="0">
+                          <a:solidFill>
+                            <a:schemeClr val="bg1"/>
+                          </a:solidFill>
+                          <a:latin typeface="Fund Regular" pitchFamily="2" charset="-78"/>
+                          <a:ea typeface="+mn-ea"/>
+                          <a:cs typeface="Fund Regular" pitchFamily="2" charset="-78"/>
+                        </a:rPr>
+                        <a:t>START DATE: MMMM-YYYY</a:t>
+                      </a:r>
+                      <a:endParaRPr lang="en-US" sz="600" dirty="0">
+                        <a:solidFill>
+                          <a:schemeClr val="bg1"/>
+                        </a:solidFill>
+                        <a:latin typeface="Sakkal Majalla" panose="02000000000000000000" pitchFamily="2" charset="-78"/>
+                        <a:cs typeface="Sakkal Majalla" panose="02000000000000000000" pitchFamily="2" charset="-78"/>
+                      </a:endParaRPr>
+                    </a:p>
+                  </a:txBody>
+                  <a:tcPr marL="36000" marR="36000" marT="0" marB="0" anchor="ctr">
+                    <a:lnL w="3175" cap="flat" cmpd="sng" algn="ctr">
+                      <a:solidFill>
+                        <a:schemeClr val="bg1"/>
+                      </a:solidFill>
+                      <a:prstDash val="solid"/>
+                      <a:round/>
+                      <a:headEnd type="none" w="med" len="med"/>
+                      <a:tailEnd type="none" w="med" len="med"/>
+                    </a:lnL>
+                    <a:lnR w="3175" cap="flat" cmpd="sng" algn="ctr">
+                      <a:solidFill>
+                        <a:schemeClr val="bg1"/>
+                      </a:solidFill>
+                      <a:prstDash val="solid"/>
+                      <a:round/>
+                      <a:headEnd type="none" w="med" len="med"/>
+                      <a:tailEnd type="none" w="med" len="med"/>
+                    </a:lnR>
+                    <a:lnT w="3175" cap="flat" cmpd="sng" algn="ctr">
+                      <a:solidFill>
+                        <a:schemeClr val="bg1"/>
+                      </a:solidFill>
+                      <a:prstDash val="solid"/>
+                      <a:round/>
+                      <a:headEnd type="none" w="med" len="med"/>
+                      <a:tailEnd type="none" w="med" len="med"/>
+                    </a:lnT>
+                    <a:lnB w="3175" cap="flat" cmpd="sng" algn="ctr">
+                      <a:solidFill>
+                        <a:schemeClr val="bg1"/>
+                      </a:solidFill>
+                      <a:prstDash val="solid"/>
+                      <a:round/>
+                      <a:headEnd type="none" w="med" len="med"/>
+                      <a:tailEnd type="none" w="med" len="med"/>
+                    </a:lnB>
+                    <a:lnTlToBr w="12700" cmpd="sng">
+                      <a:noFill/>
+                      <a:prstDash val="solid"/>
+                    </a:lnTlToBr>
+                    <a:lnBlToTr w="12700" cmpd="sng">
+                      <a:noFill/>
+                      <a:prstDash val="solid"/>
+                    </a:lnBlToTr>
+                    <a:solidFill>
+                      <a:schemeClr val="tx2"/>
+                    </a:solidFill>
+                  </a:tcPr>
+                </a:tc>
+                <a:tc hMerge="1">
+                  <a:txBody>
+                    <a:bodyPr/>
+                    <a:lstStyle/>
+                    <a:p>
+                      <a:pPr>
+                        <a:lnSpc>
+                          <a:spcPts val="1300"/>
+                        </a:lnSpc>
+                      </a:pPr>
+                      <a:endParaRPr lang="en-US" sz="1200" dirty="0">
+                        <a:solidFill>
+                          <a:schemeClr val="bg1"/>
+                        </a:solidFill>
+                        <a:latin typeface="Sakkal Majalla" panose="02000000000000000000" pitchFamily="2" charset="-78"/>
+                        <a:cs typeface="Sakkal Majalla" panose="02000000000000000000" pitchFamily="2" charset="-78"/>
+                      </a:endParaRPr>
+                    </a:p>
+                  </a:txBody>
+                  <a:tcPr marL="36000" marR="36000" marT="0" marB="0" anchor="ctr">
+                    <a:lnL w="3175" cap="flat" cmpd="sng" algn="ctr">
+                      <a:solidFill>
+                        <a:schemeClr val="bg1"/>
+                      </a:solidFill>
+                      <a:prstDash val="solid"/>
+                      <a:round/>
+                      <a:headEnd type="none" w="med" len="med"/>
+                      <a:tailEnd type="none" w="med" len="med"/>
+                    </a:lnL>
+                    <a:lnR w="3175" cap="flat" cmpd="sng" algn="ctr">
+                      <a:solidFill>
+                        <a:schemeClr val="bg1"/>
+                      </a:solidFill>
+                      <a:prstDash val="solid"/>
+                      <a:round/>
+                      <a:headEnd type="none" w="med" len="med"/>
+                      <a:tailEnd type="none" w="med" len="med"/>
+                    </a:lnR>
+                    <a:lnT w="3175" cap="flat" cmpd="sng" algn="ctr">
+                      <a:solidFill>
+                        <a:schemeClr val="bg1"/>
+                      </a:solidFill>
+                      <a:prstDash val="solid"/>
+                      <a:round/>
+                      <a:headEnd type="none" w="med" len="med"/>
+                      <a:tailEnd type="none" w="med" len="med"/>
+                    </a:lnT>
+                    <a:lnB w="3175" cap="flat" cmpd="sng" algn="ctr">
+                      <a:solidFill>
+                        <a:schemeClr val="bg1"/>
+                      </a:solidFill>
+                      <a:prstDash val="solid"/>
+                      <a:round/>
+                      <a:headEnd type="none" w="med" len="med"/>
+                      <a:tailEnd type="none" w="med" len="med"/>
+                    </a:lnB>
+                    <a:lnTlToBr w="12700" cmpd="sng">
+                      <a:noFill/>
+                      <a:prstDash val="solid"/>
+                    </a:lnTlToBr>
+                    <a:lnBlToTr w="12700" cmpd="sng">
+                      <a:noFill/>
+                      <a:prstDash val="solid"/>
+                    </a:lnBlToTr>
+                    <a:solidFill>
+                      <a:schemeClr val="tx2"/>
+                    </a:solidFill>
+                  </a:tcPr>
+                </a:tc>
+                <a:tc gridSpan="3">
+                  <a:txBody>
+                    <a:bodyPr/>
+                    <a:lstStyle/>
+                    <a:p>
+                      <a:pPr algn="l">
+                        <a:lnSpc>
+                          <a:spcPts val="1300"/>
+                        </a:lnSpc>
+                      </a:pPr>
+                      <a:r>
+                        <a:rPr kumimoji="0" lang="en-US" sz="600" b="0" i="0" u="none" strike="noStrike" kern="1200" cap="none" spc="0" normalizeH="0" baseline="0" noProof="0" dirty="0">
+                          <a:ln>
+                            <a:noFill/>
+                          </a:ln>
+                          <a:solidFill>
+                            <a:srgbClr val="FFFFFF"/>
+                          </a:solidFill>
+                          <a:effectLst/>
+                          <a:uLnTx/>
+                          <a:uFillTx/>
+                          <a:latin typeface="Fund Regular" pitchFamily="2" charset="-78"/>
+                          <a:ea typeface="+mn-ea"/>
+                          <a:cs typeface="Fund Regular" pitchFamily="2" charset="-78"/>
+                        </a:rPr>
+                        <a:t>END DATE: MMMM-YYYY</a:t>
+                      </a:r>
+                      <a:endParaRPr lang="en-US" sz="600" dirty="0">
+                        <a:solidFill>
+                          <a:schemeClr val="bg1"/>
+                        </a:solidFill>
+                        <a:latin typeface="Sakkal Majalla" panose="02000000000000000000" pitchFamily="2" charset="-78"/>
+                        <a:cs typeface="Sakkal Majalla" panose="02000000000000000000" pitchFamily="2" charset="-78"/>
+                      </a:endParaRPr>
+                    </a:p>
+                  </a:txBody>
+                  <a:tcPr marL="36000" marR="36000" marT="0" marB="0" anchor="ctr">
+                    <a:lnL w="3175" cap="flat" cmpd="sng" algn="ctr">
+                      <a:solidFill>
+                        <a:schemeClr val="bg1"/>
+                      </a:solidFill>
+                      <a:prstDash val="solid"/>
+                      <a:round/>
+                      <a:headEnd type="none" w="med" len="med"/>
+                      <a:tailEnd type="none" w="med" len="med"/>
+                    </a:lnL>
+                    <a:lnR w="3175" cap="flat" cmpd="sng" algn="ctr">
+                      <a:solidFill>
+                        <a:schemeClr val="bg1"/>
+                      </a:solidFill>
+                      <a:prstDash val="solid"/>
+                      <a:round/>
+                      <a:headEnd type="none" w="med" len="med"/>
+                      <a:tailEnd type="none" w="med" len="med"/>
+                    </a:lnR>
+                    <a:lnT w="3175" cap="flat" cmpd="sng" algn="ctr">
+                      <a:solidFill>
+                        <a:schemeClr val="bg1"/>
+                      </a:solidFill>
+                      <a:prstDash val="solid"/>
+                      <a:round/>
+                      <a:headEnd type="none" w="med" len="med"/>
+                      <a:tailEnd type="none" w="med" len="med"/>
+                    </a:lnT>
+                    <a:lnB w="3175" cap="flat" cmpd="sng" algn="ctr">
+                      <a:solidFill>
+                        <a:schemeClr val="bg1"/>
+                      </a:solidFill>
+                      <a:prstDash val="solid"/>
+                      <a:round/>
+                      <a:headEnd type="none" w="med" len="med"/>
+                      <a:tailEnd type="none" w="med" len="med"/>
+                    </a:lnB>
+                    <a:lnTlToBr w="12700" cmpd="sng">
+                      <a:noFill/>
+                      <a:prstDash val="solid"/>
+                    </a:lnTlToBr>
+                    <a:lnBlToTr w="12700" cmpd="sng">
+                      <a:noFill/>
+                      <a:prstDash val="solid"/>
+                    </a:lnBlToTr>
+                    <a:solidFill>
+                      <a:schemeClr val="tx2"/>
+                    </a:solidFill>
+                  </a:tcPr>
+                </a:tc>
+                <a:tc hMerge="1">
+                  <a:txBody>
+                    <a:bodyPr/>
+                    <a:lstStyle/>
+                    <a:p>
+                      <a:pPr>
+                        <a:lnSpc>
+                          <a:spcPts val="1300"/>
+                        </a:lnSpc>
+                      </a:pPr>
+                      <a:endParaRPr lang="en-US" sz="1200" dirty="0">
+                        <a:solidFill>
+                          <a:schemeClr val="bg1"/>
+                        </a:solidFill>
+                        <a:latin typeface="Sakkal Majalla" panose="02000000000000000000" pitchFamily="2" charset="-78"/>
+                        <a:cs typeface="Sakkal Majalla" panose="02000000000000000000" pitchFamily="2" charset="-78"/>
+                      </a:endParaRPr>
+                    </a:p>
+                  </a:txBody>
+                  <a:tcPr marL="36000" marR="36000" marT="0" marB="0" anchor="ctr">
+                    <a:lnL w="3175" cap="flat" cmpd="sng" algn="ctr">
+                      <a:solidFill>
+                        <a:schemeClr val="bg1"/>
+                      </a:solidFill>
+                      <a:prstDash val="solid"/>
+                      <a:round/>
+                      <a:headEnd type="none" w="med" len="med"/>
+                      <a:tailEnd type="none" w="med" len="med"/>
+                    </a:lnL>
+                    <a:lnR w="3175" cap="flat" cmpd="sng" algn="ctr">
+                      <a:solidFill>
+                        <a:schemeClr val="bg1"/>
+                      </a:solidFill>
+                      <a:prstDash val="solid"/>
+                      <a:round/>
+                      <a:headEnd type="none" w="med" len="med"/>
+                      <a:tailEnd type="none" w="med" len="med"/>
+                    </a:lnR>
+                    <a:lnT w="3175" cap="flat" cmpd="sng" algn="ctr">
+                      <a:solidFill>
+                        <a:schemeClr val="bg1"/>
+                      </a:solidFill>
+                      <a:prstDash val="solid"/>
+                      <a:round/>
+                      <a:headEnd type="none" w="med" len="med"/>
+                      <a:tailEnd type="none" w="med" len="med"/>
+                    </a:lnT>
+                    <a:lnB w="3175" cap="flat" cmpd="sng" algn="ctr">
+                      <a:solidFill>
+                        <a:schemeClr val="bg1"/>
+                      </a:solidFill>
+                      <a:prstDash val="solid"/>
+                      <a:round/>
+                      <a:headEnd type="none" w="med" len="med"/>
+                      <a:tailEnd type="none" w="med" len="med"/>
+                    </a:lnB>
+                    <a:lnTlToBr w="12700" cmpd="sng">
+                      <a:noFill/>
+                      <a:prstDash val="solid"/>
+                    </a:lnTlToBr>
+                    <a:lnBlToTr w="12700" cmpd="sng">
+                      <a:noFill/>
+                      <a:prstDash val="solid"/>
+                    </a:lnBlToTr>
+                    <a:solidFill>
+                      <a:schemeClr val="tx2"/>
+                    </a:solidFill>
+                  </a:tcPr>
+                </a:tc>
+                <a:tc hMerge="1">
+                  <a:txBody>
+                    <a:bodyPr/>
+                    <a:lstStyle/>
+                    <a:p>
+                      <a:pPr>
+                        <a:lnSpc>
+                          <a:spcPts val="1300"/>
+                        </a:lnSpc>
+                      </a:pPr>
+                      <a:endParaRPr lang="en-US" sz="1200" dirty="0">
+                        <a:solidFill>
+                          <a:schemeClr val="bg1"/>
+                        </a:solidFill>
+                        <a:latin typeface="Sakkal Majalla" panose="02000000000000000000" pitchFamily="2" charset="-78"/>
+                        <a:cs typeface="Sakkal Majalla" panose="02000000000000000000" pitchFamily="2" charset="-78"/>
+                      </a:endParaRPr>
+                    </a:p>
+                  </a:txBody>
+                  <a:tcPr marL="36000" marR="36000" marT="0" marB="0" anchor="ctr">
+                    <a:lnL w="3175" cap="flat" cmpd="sng" algn="ctr">
+                      <a:solidFill>
+                        <a:schemeClr val="bg1"/>
+                      </a:solidFill>
+                      <a:prstDash val="solid"/>
+                      <a:round/>
+                      <a:headEnd type="none" w="med" len="med"/>
+                      <a:tailEnd type="none" w="med" len="med"/>
+                    </a:lnL>
+                    <a:lnR w="3175" cap="flat" cmpd="sng" algn="ctr">
+                      <a:solidFill>
+                        <a:schemeClr val="bg1"/>
+                      </a:solidFill>
+                      <a:prstDash val="solid"/>
+                      <a:round/>
+                      <a:headEnd type="none" w="med" len="med"/>
+                      <a:tailEnd type="none" w="med" len="med"/>
+                    </a:lnR>
+                    <a:lnT w="3175" cap="flat" cmpd="sng" algn="ctr">
+                      <a:solidFill>
+                        <a:schemeClr val="bg1"/>
+                      </a:solidFill>
+                      <a:prstDash val="solid"/>
+                      <a:round/>
+                      <a:headEnd type="none" w="med" len="med"/>
+                      <a:tailEnd type="none" w="med" len="med"/>
+                    </a:lnT>
+                    <a:lnB w="3175" cap="flat" cmpd="sng" algn="ctr">
+                      <a:solidFill>
+                        <a:schemeClr val="bg1"/>
+                      </a:solidFill>
+                      <a:prstDash val="solid"/>
+                      <a:round/>
+                      <a:headEnd type="none" w="med" len="med"/>
+                      <a:tailEnd type="none" w="med" len="med"/>
+                    </a:lnB>
+                    <a:lnTlToBr w="12700" cmpd="sng">
+                      <a:noFill/>
+                      <a:prstDash val="solid"/>
+                    </a:lnTlToBr>
+                    <a:lnBlToTr w="12700" cmpd="sng">
+                      <a:noFill/>
+                      <a:prstDash val="solid"/>
+                    </a:lnBlToTr>
+                    <a:solidFill>
+                      <a:schemeClr val="tx2"/>
+                    </a:solidFill>
+                  </a:tcPr>
+                </a:tc>
+                <a:extLst>
+                  <a:ext uri="{0D108BD9-81ED-4DB2-BD59-A6C34878D82A}">
+                    <a16:rowId xmlns:a16="http://schemas.microsoft.com/office/drawing/2014/main" val="3944166192"/>
+                  </a:ext>
+                </a:extLst>
+              </a:tr>
+              <a:tr h="142016">
+                <a:tc>
+                  <a:txBody>
+                    <a:bodyPr/>
+                    <a:lstStyle/>
+                    <a:p>
+                      <a:pPr algn="l">
+                        <a:lnSpc>
+                          <a:spcPts val="1200"/>
+                        </a:lnSpc>
+                      </a:pPr>
+                      <a:r>
+                        <a:rPr lang="en-US" sz="600" b="0" i="0" dirty="0">
+                          <a:solidFill>
+                            <a:schemeClr val="tx2"/>
+                          </a:solidFill>
+                          <a:latin typeface="Fund Regular" pitchFamily="2" charset="-78"/>
+                          <a:cs typeface="Fund Regular" pitchFamily="2" charset="-78"/>
+                        </a:rPr>
+                        <a:t>NAME</a:t>
+                      </a:r>
+                    </a:p>
+                  </a:txBody>
+                  <a:tcPr marL="36000" marR="36000" marT="0" marB="0" anchor="ctr">
+                    <a:lnL w="12700" cap="flat" cmpd="sng" algn="ctr">
+                      <a:noFill/>
+                      <a:prstDash val="solid"/>
+                      <a:round/>
+                      <a:headEnd type="none" w="med" len="med"/>
+                      <a:tailEnd type="none" w="med" len="med"/>
+                    </a:lnL>
+                    <a:lnR w="12700" cap="flat" cmpd="sng" algn="ctr">
+                      <a:noFill/>
+                      <a:prstDash val="solid"/>
+                      <a:round/>
+                      <a:headEnd type="none" w="med" len="med"/>
+                      <a:tailEnd type="none" w="med" len="med"/>
+                    </a:lnR>
+                    <a:lnT w="3175" cap="flat" cmpd="sng" algn="ctr">
+                      <a:solidFill>
+                        <a:schemeClr val="bg1"/>
+                      </a:solidFill>
+                      <a:prstDash val="solid"/>
+                      <a:round/>
+                      <a:headEnd type="none" w="med" len="med"/>
+                      <a:tailEnd type="none" w="med" len="med"/>
+                    </a:lnT>
+                    <a:lnB w="6350" cap="flat" cmpd="sng" algn="ctr">
+                      <a:solidFill>
+                        <a:schemeClr val="bg1">
+                          <a:lumMod val="85000"/>
+                        </a:schemeClr>
+                      </a:solidFill>
+                      <a:prstDash val="solid"/>
+                      <a:round/>
+                      <a:headEnd type="none" w="med" len="med"/>
+                      <a:tailEnd type="none" w="med" len="med"/>
+                    </a:lnB>
+                    <a:lnTlToBr w="12700" cmpd="sng">
+                      <a:noFill/>
+                      <a:prstDash val="solid"/>
+                    </a:lnTlToBr>
+                    <a:lnBlToTr w="12700" cmpd="sng">
+                      <a:noFill/>
+                      <a:prstDash val="solid"/>
+                    </a:lnBlToTr>
+                    <a:solidFill>
+                      <a:schemeClr val="bg1">
+                        <a:lumMod val="95000"/>
+                      </a:schemeClr>
+                    </a:solidFill>
+                  </a:tcPr>
+                </a:tc>
+                <a:tc>
+                  <a:txBody>
+                    <a:bodyPr/>
+                    <a:lstStyle/>
+                    <a:p>
+                      <a:pPr algn="l">
+                        <a:lnSpc>
+                          <a:spcPts val="1200"/>
+                        </a:lnSpc>
+                      </a:pPr>
+                      <a:r>
+                        <a:rPr lang="en-US" sz="600" b="0" i="0" dirty="0">
+                          <a:solidFill>
+                            <a:schemeClr val="tx2"/>
+                          </a:solidFill>
+                          <a:latin typeface="Fund Regular" pitchFamily="2" charset="-78"/>
+                          <a:cs typeface="Fund Regular" pitchFamily="2" charset="-78"/>
+                        </a:rPr>
+                        <a:t>PIF EMPLOYEE</a:t>
+                      </a:r>
+                    </a:p>
+                  </a:txBody>
+                  <a:tcPr marL="36000" marR="36000" marT="0" marB="0" anchor="ctr">
+                    <a:lnL w="12700" cap="flat" cmpd="sng" algn="ctr">
+                      <a:noFill/>
+                      <a:prstDash val="solid"/>
+                      <a:round/>
+                      <a:headEnd type="none" w="med" len="med"/>
+                      <a:tailEnd type="none" w="med" len="med"/>
+                    </a:lnL>
+                    <a:lnR w="12700" cap="flat" cmpd="sng" algn="ctr">
+                      <a:noFill/>
+                      <a:prstDash val="solid"/>
+                      <a:round/>
+                      <a:headEnd type="none" w="med" len="med"/>
+                      <a:tailEnd type="none" w="med" len="med"/>
+                    </a:lnR>
+                    <a:lnT w="3175" cap="flat" cmpd="sng" algn="ctr">
+                      <a:solidFill>
+                        <a:schemeClr val="bg1"/>
+                      </a:solidFill>
+                      <a:prstDash val="solid"/>
+                      <a:round/>
+                      <a:headEnd type="none" w="med" len="med"/>
+                      <a:tailEnd type="none" w="med" len="med"/>
+                    </a:lnT>
+                    <a:lnB w="6350" cap="flat" cmpd="sng" algn="ctr">
+                      <a:solidFill>
+                        <a:schemeClr val="bg1">
+                          <a:lumMod val="85000"/>
+                        </a:schemeClr>
+                      </a:solidFill>
+                      <a:prstDash val="solid"/>
+                      <a:round/>
+                      <a:headEnd type="none" w="med" len="med"/>
+                      <a:tailEnd type="none" w="med" len="med"/>
+                    </a:lnB>
+                    <a:lnTlToBr w="12700" cmpd="sng">
+                      <a:noFill/>
+                      <a:prstDash val="solid"/>
+                    </a:lnTlToBr>
+                    <a:lnBlToTr w="12700" cmpd="sng">
+                      <a:noFill/>
+                      <a:prstDash val="solid"/>
+                    </a:lnBlToTr>
+                    <a:solidFill>
+                      <a:schemeClr val="bg1">
+                        <a:lumMod val="95000"/>
+                      </a:schemeClr>
+                    </a:solidFill>
+                  </a:tcPr>
+                </a:tc>
+                <a:tc>
+                  <a:txBody>
+                    <a:bodyPr/>
+                    <a:lstStyle/>
+                    <a:p>
+                      <a:pPr algn="l">
+                        <a:lnSpc>
+                          <a:spcPts val="1200"/>
+                        </a:lnSpc>
+                      </a:pPr>
+                      <a:r>
+                        <a:rPr lang="en-US" sz="600" b="0" i="0" dirty="0">
+                          <a:solidFill>
+                            <a:schemeClr val="tx2"/>
+                          </a:solidFill>
+                          <a:latin typeface="Fund Regular" pitchFamily="2" charset="-78"/>
+                          <a:cs typeface="Fund Regular" pitchFamily="2" charset="-78"/>
+                        </a:rPr>
+                        <a:t>OTHER PIF REP.</a:t>
+                      </a:r>
+                    </a:p>
+                  </a:txBody>
+                  <a:tcPr marL="36000" marR="36000" marT="0" marB="0" anchor="ctr">
+                    <a:lnL w="12700" cap="flat" cmpd="sng" algn="ctr">
+                      <a:noFill/>
+                      <a:prstDash val="solid"/>
+                      <a:round/>
+                      <a:headEnd type="none" w="med" len="med"/>
+                      <a:tailEnd type="none" w="med" len="med"/>
+                    </a:lnL>
+                    <a:lnR w="12700" cap="flat" cmpd="sng" algn="ctr">
+                      <a:noFill/>
+                      <a:prstDash val="solid"/>
+                      <a:round/>
+                      <a:headEnd type="none" w="med" len="med"/>
+                      <a:tailEnd type="none" w="med" len="med"/>
+                    </a:lnR>
+                    <a:lnT w="3175" cap="flat" cmpd="sng" algn="ctr">
+                      <a:solidFill>
+                        <a:schemeClr val="bg1"/>
+                      </a:solidFill>
+                      <a:prstDash val="solid"/>
+                      <a:round/>
+                      <a:headEnd type="none" w="med" len="med"/>
+                      <a:tailEnd type="none" w="med" len="med"/>
+                    </a:lnT>
+                    <a:lnB w="6350" cap="flat" cmpd="sng" algn="ctr">
+                      <a:solidFill>
+                        <a:schemeClr val="bg1">
+                          <a:lumMod val="85000"/>
+                        </a:schemeClr>
+                      </a:solidFill>
+                      <a:prstDash val="solid"/>
+                      <a:round/>
+                      <a:headEnd type="none" w="med" len="med"/>
+                      <a:tailEnd type="none" w="med" len="med"/>
+                    </a:lnB>
+                    <a:lnTlToBr w="12700" cmpd="sng">
+                      <a:noFill/>
+                      <a:prstDash val="solid"/>
+                    </a:lnTlToBr>
+                    <a:lnBlToTr w="12700" cmpd="sng">
+                      <a:noFill/>
+                      <a:prstDash val="solid"/>
+                    </a:lnBlToTr>
+                    <a:solidFill>
+                      <a:schemeClr val="bg1">
+                        <a:lumMod val="95000"/>
+                      </a:schemeClr>
+                    </a:solidFill>
+                  </a:tcPr>
+                </a:tc>
+                <a:tc>
+                  <a:txBody>
+                    <a:bodyPr/>
+                    <a:lstStyle/>
+                    <a:p>
+                      <a:pPr algn="l">
+                        <a:lnSpc>
+                          <a:spcPts val="1200"/>
+                        </a:lnSpc>
+                      </a:pPr>
+                      <a:r>
+                        <a:rPr lang="en-US" sz="600" b="0" i="0" dirty="0">
+                          <a:solidFill>
+                            <a:schemeClr val="tx2"/>
+                          </a:solidFill>
+                          <a:latin typeface="Fund Regular" pitchFamily="2" charset="-78"/>
+                          <a:cs typeface="Fund Regular" pitchFamily="2" charset="-78"/>
+                        </a:rPr>
+                        <a:t>BOARD</a:t>
+                      </a:r>
+                    </a:p>
+                  </a:txBody>
+                  <a:tcPr marL="36000" marR="36000" marT="0" marB="0" anchor="ctr">
+                    <a:lnL w="12700" cmpd="sng">
+                      <a:noFill/>
+                    </a:lnL>
+                    <a:lnR w="12700" cap="flat" cmpd="sng" algn="ctr">
+                      <a:noFill/>
+                      <a:prstDash val="solid"/>
+                      <a:round/>
+                      <a:headEnd type="none" w="med" len="med"/>
+                      <a:tailEnd type="none" w="med" len="med"/>
+                    </a:lnR>
+                    <a:lnT w="3175" cap="flat" cmpd="sng" algn="ctr">
+                      <a:solidFill>
+                        <a:schemeClr val="bg1"/>
+                      </a:solidFill>
+                      <a:prstDash val="solid"/>
+                      <a:round/>
+                      <a:headEnd type="none" w="med" len="med"/>
+                      <a:tailEnd type="none" w="med" len="med"/>
+                    </a:lnT>
+                    <a:lnB w="6350" cap="flat" cmpd="sng" algn="ctr">
+                      <a:solidFill>
+                        <a:schemeClr val="bg1">
+                          <a:lumMod val="85000"/>
+                        </a:schemeClr>
+                      </a:solidFill>
+                      <a:prstDash val="solid"/>
+                      <a:round/>
+                      <a:headEnd type="none" w="med" len="med"/>
+                      <a:tailEnd type="none" w="med" len="med"/>
+                    </a:lnB>
+                    <a:lnTlToBr w="12700" cmpd="sng">
+                      <a:noFill/>
+                      <a:prstDash val="solid"/>
+                    </a:lnTlToBr>
+                    <a:lnBlToTr w="12700" cmpd="sng">
+                      <a:noFill/>
+                      <a:prstDash val="solid"/>
+                    </a:lnBlToTr>
+                    <a:solidFill>
+                      <a:schemeClr val="bg1">
+                        <a:lumMod val="95000"/>
+                      </a:schemeClr>
+                    </a:solidFill>
+                  </a:tcPr>
+                </a:tc>
+                <a:tc>
+                  <a:txBody>
+                    <a:bodyPr/>
+                    <a:lstStyle/>
+                    <a:p>
+                      <a:pPr algn="l">
+                        <a:lnSpc>
+                          <a:spcPts val="1200"/>
+                        </a:lnSpc>
+                      </a:pPr>
+                      <a:r>
+                        <a:rPr lang="en-US" sz="600" b="0" i="0" dirty="0">
+                          <a:solidFill>
+                            <a:schemeClr val="tx2"/>
+                          </a:solidFill>
+                          <a:latin typeface="Fund Regular" pitchFamily="2" charset="-78"/>
+                          <a:cs typeface="Fund Regular" pitchFamily="2" charset="-78"/>
+                        </a:rPr>
+                        <a:t>EXCOM</a:t>
+                      </a:r>
+                    </a:p>
+                  </a:txBody>
+                  <a:tcPr marL="36000" marR="36000" marT="0" marB="0" anchor="ctr">
+                    <a:lnL w="12700" cap="flat" cmpd="sng" algn="ctr">
+                      <a:noFill/>
+                      <a:prstDash val="solid"/>
+                      <a:round/>
+                      <a:headEnd type="none" w="med" len="med"/>
+                      <a:tailEnd type="none" w="med" len="med"/>
+                    </a:lnL>
+                    <a:lnR w="12700" cap="flat" cmpd="sng" algn="ctr">
+                      <a:noFill/>
+                      <a:prstDash val="solid"/>
+                      <a:round/>
+                      <a:headEnd type="none" w="med" len="med"/>
+                      <a:tailEnd type="none" w="med" len="med"/>
+                    </a:lnR>
+                    <a:lnT w="3175" cap="flat" cmpd="sng" algn="ctr">
+                      <a:solidFill>
+                        <a:schemeClr val="bg1"/>
+                      </a:solidFill>
+                      <a:prstDash val="solid"/>
+                      <a:round/>
+                      <a:headEnd type="none" w="med" len="med"/>
+                      <a:tailEnd type="none" w="med" len="med"/>
+                    </a:lnT>
+                    <a:lnB w="6350" cap="flat" cmpd="sng" algn="ctr">
+                      <a:solidFill>
+                        <a:schemeClr val="bg1">
+                          <a:lumMod val="85000"/>
+                        </a:schemeClr>
+                      </a:solidFill>
+                      <a:prstDash val="solid"/>
+                      <a:round/>
+                      <a:headEnd type="none" w="med" len="med"/>
+                      <a:tailEnd type="none" w="med" len="med"/>
+                    </a:lnB>
+                    <a:lnTlToBr w="12700" cmpd="sng">
+                      <a:noFill/>
+                      <a:prstDash val="solid"/>
+                    </a:lnTlToBr>
+                    <a:lnBlToTr w="12700" cmpd="sng">
+                      <a:noFill/>
+                      <a:prstDash val="solid"/>
+                    </a:lnBlToTr>
+                    <a:solidFill>
+                      <a:schemeClr val="bg1">
+                        <a:lumMod val="95000"/>
+                      </a:schemeClr>
+                    </a:solidFill>
+                  </a:tcPr>
+                </a:tc>
+                <a:tc>
+                  <a:txBody>
+                    <a:bodyPr/>
+                    <a:lstStyle/>
+                    <a:p>
+                      <a:pPr algn="l">
+                        <a:lnSpc>
+                          <a:spcPts val="1200"/>
+                        </a:lnSpc>
+                      </a:pPr>
+                      <a:r>
+                        <a:rPr lang="en-US" sz="600" b="0" i="0" dirty="0">
+                          <a:solidFill>
+                            <a:schemeClr val="tx2"/>
+                          </a:solidFill>
+                          <a:latin typeface="Fund Regular" pitchFamily="2" charset="-78"/>
+                          <a:cs typeface="Fund Regular" pitchFamily="2" charset="-78"/>
+                        </a:rPr>
+                        <a:t>AUDIT</a:t>
+                      </a:r>
+                    </a:p>
+                  </a:txBody>
+                  <a:tcPr marL="36000" marR="36000" marT="0" marB="0" anchor="ctr">
+                    <a:lnL w="12700" cap="flat" cmpd="sng" algn="ctr">
+                      <a:noFill/>
+                      <a:prstDash val="solid"/>
+                      <a:round/>
+                      <a:headEnd type="none" w="med" len="med"/>
+                      <a:tailEnd type="none" w="med" len="med"/>
+                    </a:lnL>
+                    <a:lnR w="12700" cap="flat" cmpd="sng" algn="ctr">
+                      <a:noFill/>
+                      <a:prstDash val="solid"/>
+                      <a:round/>
+                      <a:headEnd type="none" w="med" len="med"/>
+                      <a:tailEnd type="none" w="med" len="med"/>
+                    </a:lnR>
+                    <a:lnT w="3175" cap="flat" cmpd="sng" algn="ctr">
+                      <a:solidFill>
+                        <a:schemeClr val="bg1"/>
+                      </a:solidFill>
+                      <a:prstDash val="solid"/>
+                      <a:round/>
+                      <a:headEnd type="none" w="med" len="med"/>
+                      <a:tailEnd type="none" w="med" len="med"/>
+                    </a:lnT>
+                    <a:lnB w="6350" cap="flat" cmpd="sng" algn="ctr">
+                      <a:solidFill>
+                        <a:schemeClr val="bg1">
+                          <a:lumMod val="85000"/>
+                        </a:schemeClr>
+                      </a:solidFill>
+                      <a:prstDash val="solid"/>
+                      <a:round/>
+                      <a:headEnd type="none" w="med" len="med"/>
+                      <a:tailEnd type="none" w="med" len="med"/>
+                    </a:lnB>
+                    <a:lnTlToBr w="12700" cmpd="sng">
+                      <a:noFill/>
+                      <a:prstDash val="solid"/>
+                    </a:lnTlToBr>
+                    <a:lnBlToTr w="12700" cmpd="sng">
+                      <a:noFill/>
+                      <a:prstDash val="solid"/>
+                    </a:lnBlToTr>
+                    <a:solidFill>
+                      <a:schemeClr val="bg1">
+                        <a:lumMod val="95000"/>
+                      </a:schemeClr>
+                    </a:solidFill>
+                  </a:tcPr>
+                </a:tc>
+                <a:tc>
+                  <a:txBody>
+                    <a:bodyPr/>
+                    <a:lstStyle/>
+                    <a:p>
+                      <a:pPr algn="l">
+                        <a:lnSpc>
+                          <a:spcPts val="1200"/>
+                        </a:lnSpc>
+                      </a:pPr>
+                      <a:r>
+                        <a:rPr lang="en-US" sz="600" b="0" i="0" dirty="0">
+                          <a:solidFill>
+                            <a:schemeClr val="tx2"/>
+                          </a:solidFill>
+                          <a:latin typeface="Fund Regular" pitchFamily="2" charset="-78"/>
+                          <a:cs typeface="Fund Regular" pitchFamily="2" charset="-78"/>
+                        </a:rPr>
+                        <a:t>NRC</a:t>
+                      </a:r>
+                    </a:p>
+                  </a:txBody>
+                  <a:tcPr marL="36000" marR="36000" marT="0" marB="0" anchor="ctr">
+                    <a:lnL w="12700" cap="flat" cmpd="sng" algn="ctr">
+                      <a:noFill/>
+                      <a:prstDash val="solid"/>
+                      <a:round/>
+                      <a:headEnd type="none" w="med" len="med"/>
+                      <a:tailEnd type="none" w="med" len="med"/>
+                    </a:lnL>
+                    <a:lnR w="12700" cap="flat" cmpd="sng" algn="ctr">
+                      <a:noFill/>
+                      <a:prstDash val="solid"/>
+                      <a:round/>
+                      <a:headEnd type="none" w="med" len="med"/>
+                      <a:tailEnd type="none" w="med" len="med"/>
+                    </a:lnR>
+                    <a:lnT w="3175" cap="flat" cmpd="sng" algn="ctr">
+                      <a:solidFill>
+                        <a:schemeClr val="bg1"/>
+                      </a:solidFill>
+                      <a:prstDash val="solid"/>
+                      <a:round/>
+                      <a:headEnd type="none" w="med" len="med"/>
+                      <a:tailEnd type="none" w="med" len="med"/>
+                    </a:lnT>
+                    <a:lnB w="6350" cap="flat" cmpd="sng" algn="ctr">
+                      <a:solidFill>
+                        <a:schemeClr val="bg1">
+                          <a:lumMod val="85000"/>
+                        </a:schemeClr>
+                      </a:solidFill>
+                      <a:prstDash val="solid"/>
+                      <a:round/>
+                      <a:headEnd type="none" w="med" len="med"/>
+                      <a:tailEnd type="none" w="med" len="med"/>
+                    </a:lnB>
+                    <a:lnTlToBr w="12700" cmpd="sng">
+                      <a:noFill/>
+                      <a:prstDash val="solid"/>
+                    </a:lnTlToBr>
+                    <a:lnBlToTr w="12700" cmpd="sng">
+                      <a:noFill/>
+                      <a:prstDash val="solid"/>
+                    </a:lnBlToTr>
+                    <a:solidFill>
+                      <a:schemeClr val="bg1">
+                        <a:lumMod val="95000"/>
+                      </a:schemeClr>
+                    </a:solidFill>
+                  </a:tcPr>
+                </a:tc>
+                <a:extLst>
+                  <a:ext uri="{0D108BD9-81ED-4DB2-BD59-A6C34878D82A}">
+                    <a16:rowId xmlns:a16="http://schemas.microsoft.com/office/drawing/2014/main" val="2147178351"/>
+                  </a:ext>
+                </a:extLst>
+              </a:tr>
+              <a:tr h="132304">
+                <a:tc>
+                  <a:txBody>
+                    <a:bodyPr/>
+                    <a:lstStyle/>
+                    <a:p>
+                      <a:pPr algn="l">
+                        <a:lnSpc>
+                          <a:spcPts val="1200"/>
+                        </a:lnSpc>
+                      </a:pPr>
+                      <a:r>
+                        <a:rPr lang="en-US" sz="600" b="0" i="0" dirty="0">
+                          <a:solidFill>
+                            <a:schemeClr val="tx1"/>
+                          </a:solidFill>
+                          <a:latin typeface="Fund Light" pitchFamily="2" charset="-78"/>
+                          <a:cs typeface="Fund Light" pitchFamily="2" charset="-78"/>
+                        </a:rPr>
+                        <a:t>Member #1</a:t>
+                      </a:r>
+                    </a:p>
+                  </a:txBody>
+                  <a:tcPr marL="36000" marR="36000" marT="0" marB="0" anchor="ctr">
+                    <a:lnL w="12700" cap="flat" cmpd="sng" algn="ctr">
+                      <a:noFill/>
+                      <a:prstDash val="solid"/>
+                      <a:round/>
+                      <a:headEnd type="none" w="med" len="med"/>
+                      <a:tailEnd type="none" w="med" len="med"/>
+                    </a:lnL>
+                    <a:lnR w="12700" cap="flat" cmpd="sng" algn="ctr">
+                      <a:noFill/>
+                      <a:prstDash val="solid"/>
+                      <a:round/>
+                      <a:headEnd type="none" w="med" len="med"/>
+                      <a:tailEnd type="none" w="med" len="med"/>
+                    </a:lnR>
+                    <a:lnT w="6350" cap="flat" cmpd="sng" algn="ctr">
+                      <a:solidFill>
+                        <a:schemeClr val="bg1">
+                          <a:lumMod val="85000"/>
+                        </a:schemeClr>
+                      </a:solidFill>
+                      <a:prstDash val="solid"/>
+                      <a:round/>
+                      <a:headEnd type="none" w="med" len="med"/>
+                      <a:tailEnd type="none" w="med" len="med"/>
+                    </a:lnT>
+                    <a:lnB w="6350" cap="flat" cmpd="sng" algn="ctr">
+                      <a:solidFill>
+                        <a:schemeClr val="bg1">
+                          <a:lumMod val="85000"/>
+                        </a:schemeClr>
+                      </a:solidFill>
+                      <a:prstDash val="solid"/>
+                      <a:round/>
+                      <a:headEnd type="none" w="med" len="med"/>
+                      <a:tailEnd type="none" w="med" len="med"/>
+                    </a:lnB>
+                    <a:lnTlToBr w="12700" cmpd="sng">
+                      <a:noFill/>
+                      <a:prstDash val="solid"/>
+                    </a:lnTlToBr>
+                    <a:lnBlToTr w="12700" cmpd="sng">
+                      <a:noFill/>
+                      <a:prstDash val="solid"/>
+                    </a:lnBlToTr>
+                    <a:noFill/>
+                  </a:tcPr>
+                </a:tc>
+                <a:tc>
+                  <a:txBody>
+                    <a:bodyPr/>
+                    <a:lstStyle/>
+                    <a:p>
+                      <a:pPr algn="l">
+                        <a:lnSpc>
+                          <a:spcPts val="1200"/>
+                        </a:lnSpc>
+                      </a:pPr>
+                      <a:r>
+                        <a:rPr lang="en-US" sz="600" b="0" i="0" dirty="0">
+                          <a:solidFill>
+                            <a:schemeClr val="tx1"/>
+                          </a:solidFill>
+                          <a:latin typeface="Fund Light" pitchFamily="2" charset="-78"/>
+                          <a:cs typeface="Fund Light" pitchFamily="2" charset="-78"/>
+                        </a:rPr>
+                        <a:t>No</a:t>
+                      </a:r>
+                    </a:p>
+                  </a:txBody>
+                  <a:tcPr marL="36000" marR="36000" marT="0" marB="0" anchor="ctr">
+                    <a:lnL w="12700" cap="flat" cmpd="sng" algn="ctr">
+                      <a:noFill/>
+                      <a:prstDash val="solid"/>
+                      <a:round/>
+                      <a:headEnd type="none" w="med" len="med"/>
+                      <a:tailEnd type="none" w="med" len="med"/>
+                    </a:lnL>
+                    <a:lnR w="12700" cap="flat" cmpd="sng" algn="ctr">
+                      <a:noFill/>
+                      <a:prstDash val="solid"/>
+                      <a:round/>
+                      <a:headEnd type="none" w="med" len="med"/>
+                      <a:tailEnd type="none" w="med" len="med"/>
+                    </a:lnR>
+                    <a:lnT w="6350" cap="flat" cmpd="sng" algn="ctr">
+                      <a:solidFill>
+                        <a:schemeClr val="bg1">
+                          <a:lumMod val="85000"/>
+                        </a:schemeClr>
+                      </a:solidFill>
+                      <a:prstDash val="solid"/>
+                      <a:round/>
+                      <a:headEnd type="none" w="med" len="med"/>
+                      <a:tailEnd type="none" w="med" len="med"/>
+                    </a:lnT>
+                    <a:lnB w="6350" cap="flat" cmpd="sng" algn="ctr">
+                      <a:solidFill>
+                        <a:schemeClr val="bg1">
+                          <a:lumMod val="85000"/>
+                        </a:schemeClr>
+                      </a:solidFill>
+                      <a:prstDash val="solid"/>
+                      <a:round/>
+                      <a:headEnd type="none" w="med" len="med"/>
+                      <a:tailEnd type="none" w="med" len="med"/>
+                    </a:lnB>
+                    <a:lnTlToBr w="12700" cmpd="sng">
+                      <a:noFill/>
+                      <a:prstDash val="solid"/>
+                    </a:lnTlToBr>
+                    <a:lnBlToTr w="12700" cmpd="sng">
+                      <a:noFill/>
+                      <a:prstDash val="solid"/>
+                    </a:lnBlToTr>
+                    <a:noFill/>
+                  </a:tcPr>
+                </a:tc>
+                <a:tc>
+                  <a:txBody>
+                    <a:bodyPr/>
+                    <a:lstStyle/>
+                    <a:p>
+                      <a:pPr algn="l">
+                        <a:lnSpc>
+                          <a:spcPts val="1200"/>
+                        </a:lnSpc>
+                      </a:pPr>
+                      <a:r>
+                        <a:rPr lang="en-US" sz="600" b="0" i="0">
+                          <a:solidFill>
+                            <a:schemeClr val="tx1"/>
+                          </a:solidFill>
+                          <a:latin typeface="Fund Light" pitchFamily="2" charset="-78"/>
+                          <a:cs typeface="Fund Light" pitchFamily="2" charset="-78"/>
+                        </a:rPr>
+                        <a:t>Yes</a:t>
+                      </a:r>
+                      <a:endParaRPr lang="en-US" sz="600" b="0" i="0" dirty="0">
+                        <a:solidFill>
+                          <a:schemeClr val="tx1"/>
+                        </a:solidFill>
+                        <a:latin typeface="Fund Light" pitchFamily="2" charset="-78"/>
+                        <a:cs typeface="Fund Light" pitchFamily="2" charset="-78"/>
+                      </a:endParaRPr>
+                    </a:p>
+                  </a:txBody>
+                  <a:tcPr marL="36000" marR="36000" marT="0" marB="0" anchor="ctr">
+                    <a:lnL w="12700" cap="flat" cmpd="sng" algn="ctr">
+                      <a:noFill/>
+                      <a:prstDash val="solid"/>
+                      <a:round/>
+                      <a:headEnd type="none" w="med" len="med"/>
+                      <a:tailEnd type="none" w="med" len="med"/>
+                    </a:lnL>
+                    <a:lnR w="12700" cap="flat" cmpd="sng" algn="ctr">
+                      <a:noFill/>
+                      <a:prstDash val="solid"/>
+                      <a:round/>
+                      <a:headEnd type="none" w="med" len="med"/>
+                      <a:tailEnd type="none" w="med" len="med"/>
+                    </a:lnR>
+                    <a:lnT w="6350" cap="flat" cmpd="sng" algn="ctr">
+                      <a:solidFill>
+                        <a:schemeClr val="bg1">
+                          <a:lumMod val="85000"/>
+                        </a:schemeClr>
+                      </a:solidFill>
+                      <a:prstDash val="solid"/>
+                      <a:round/>
+                      <a:headEnd type="none" w="med" len="med"/>
+                      <a:tailEnd type="none" w="med" len="med"/>
+                    </a:lnT>
+                    <a:lnB w="6350" cap="flat" cmpd="sng" algn="ctr">
+                      <a:solidFill>
+                        <a:schemeClr val="bg1">
+                          <a:lumMod val="85000"/>
+                        </a:schemeClr>
+                      </a:solidFill>
+                      <a:prstDash val="solid"/>
+                      <a:round/>
+                      <a:headEnd type="none" w="med" len="med"/>
+                      <a:tailEnd type="none" w="med" len="med"/>
+                    </a:lnB>
+                    <a:lnTlToBr w="12700" cmpd="sng">
+                      <a:noFill/>
+                      <a:prstDash val="solid"/>
+                    </a:lnTlToBr>
+                    <a:lnBlToTr w="12700" cmpd="sng">
+                      <a:noFill/>
+                      <a:prstDash val="solid"/>
+                    </a:lnBlToTr>
+                    <a:noFill/>
+                  </a:tcPr>
+                </a:tc>
+                <a:tc>
+                  <a:txBody>
+                    <a:bodyPr/>
+                    <a:lstStyle/>
+                    <a:p>
+                      <a:pPr marL="0" algn="l" defTabSz="914400" rtl="0" eaLnBrk="1" latinLnBrk="0" hangingPunct="1">
+                        <a:lnSpc>
+                          <a:spcPts val="1200"/>
+                        </a:lnSpc>
+                      </a:pPr>
+                      <a:r>
+                        <a:rPr lang="en-US" sz="600" b="0" i="0" kern="1200" dirty="0">
+                          <a:solidFill>
+                            <a:schemeClr val="tx1"/>
+                          </a:solidFill>
+                          <a:latin typeface="Fund Light" pitchFamily="2" charset="-78"/>
+                          <a:ea typeface="+mn-ea"/>
+                          <a:cs typeface="Fund Light" pitchFamily="2" charset="-78"/>
+                        </a:rPr>
+                        <a:t>q</a:t>
+                      </a:r>
+                    </a:p>
+                  </a:txBody>
+                  <a:tcPr marL="36000" marR="36000" marT="0" marB="0" anchor="b">
+                    <a:lnL w="12700" cmpd="sng">
+                      <a:noFill/>
+                    </a:lnL>
+                    <a:lnR w="12700" cap="flat" cmpd="sng" algn="ctr">
+                      <a:noFill/>
+                      <a:prstDash val="solid"/>
+                      <a:round/>
+                      <a:headEnd type="none" w="med" len="med"/>
+                      <a:tailEnd type="none" w="med" len="med"/>
+                    </a:lnR>
+                    <a:lnT w="6350" cap="flat" cmpd="sng" algn="ctr">
+                      <a:solidFill>
+                        <a:schemeClr val="bg1">
+                          <a:lumMod val="85000"/>
+                        </a:schemeClr>
+                      </a:solidFill>
+                      <a:prstDash val="solid"/>
+                      <a:round/>
+                      <a:headEnd type="none" w="med" len="med"/>
+                      <a:tailEnd type="none" w="med" len="med"/>
+                    </a:lnT>
+                    <a:lnB w="6350" cap="flat" cmpd="sng" algn="ctr">
+                      <a:solidFill>
+                        <a:schemeClr val="bg1">
+                          <a:lumMod val="85000"/>
+                        </a:schemeClr>
+                      </a:solidFill>
+                      <a:prstDash val="solid"/>
+                      <a:round/>
+                      <a:headEnd type="none" w="med" len="med"/>
+                      <a:tailEnd type="none" w="med" len="med"/>
+                    </a:lnB>
+                    <a:lnTlToBr w="12700" cmpd="sng">
+                      <a:noFill/>
+                      <a:prstDash val="solid"/>
+                    </a:lnTlToBr>
+                    <a:lnBlToTr w="12700" cmpd="sng">
+                      <a:noFill/>
+                      <a:prstDash val="solid"/>
+                    </a:lnBlToTr>
+                    <a:noFill/>
+                  </a:tcPr>
+                </a:tc>
+                <a:tc>
+                  <a:txBody>
+                    <a:bodyPr/>
+                    <a:lstStyle/>
+                    <a:p>
+                      <a:pPr marL="0" algn="l" defTabSz="914400" rtl="0" eaLnBrk="1" latinLnBrk="0" hangingPunct="1">
+                        <a:lnSpc>
+                          <a:spcPts val="1200"/>
+                        </a:lnSpc>
+                      </a:pPr>
+                      <a:r>
+                        <a:rPr lang="en-US" sz="600" b="0" i="0" kern="1200" dirty="0">
+                          <a:solidFill>
+                            <a:schemeClr val="tx1"/>
+                          </a:solidFill>
+                          <a:latin typeface="Fund Light" pitchFamily="2" charset="-78"/>
+                          <a:ea typeface="+mn-ea"/>
+                          <a:cs typeface="Fund Light" pitchFamily="2" charset="-78"/>
+                        </a:rPr>
+                        <a:t>q</a:t>
+                      </a:r>
+                    </a:p>
+                  </a:txBody>
+                  <a:tcPr marL="36000" marR="36000" marT="0" marB="0" anchor="ctr">
+                    <a:lnL w="12700" cap="flat" cmpd="sng" algn="ctr">
+                      <a:noFill/>
+                      <a:prstDash val="solid"/>
+                      <a:round/>
+                      <a:headEnd type="none" w="med" len="med"/>
+                      <a:tailEnd type="none" w="med" len="med"/>
+                    </a:lnL>
+                    <a:lnR w="12700" cap="flat" cmpd="sng" algn="ctr">
+                      <a:noFill/>
+                      <a:prstDash val="solid"/>
+                      <a:round/>
+                      <a:headEnd type="none" w="med" len="med"/>
+                      <a:tailEnd type="none" w="med" len="med"/>
+                    </a:lnR>
+                    <a:lnT w="6350" cap="flat" cmpd="sng" algn="ctr">
+                      <a:solidFill>
+                        <a:schemeClr val="bg1">
+                          <a:lumMod val="85000"/>
+                        </a:schemeClr>
+                      </a:solidFill>
+                      <a:prstDash val="solid"/>
+                      <a:round/>
+                      <a:headEnd type="none" w="med" len="med"/>
+                      <a:tailEnd type="none" w="med" len="med"/>
+                    </a:lnT>
+                    <a:lnB w="6350" cap="flat" cmpd="sng" algn="ctr">
+                      <a:solidFill>
+                        <a:schemeClr val="bg1">
+                          <a:lumMod val="85000"/>
+                        </a:schemeClr>
+                      </a:solidFill>
+                      <a:prstDash val="solid"/>
+                      <a:round/>
+                      <a:headEnd type="none" w="med" len="med"/>
+                      <a:tailEnd type="none" w="med" len="med"/>
+                    </a:lnB>
+                    <a:lnTlToBr w="12700" cmpd="sng">
+                      <a:noFill/>
+                      <a:prstDash val="solid"/>
+                    </a:lnTlToBr>
+                    <a:lnBlToTr w="12700" cmpd="sng">
+                      <a:noFill/>
+                      <a:prstDash val="solid"/>
+                    </a:lnBlToTr>
+                    <a:noFill/>
+                  </a:tcPr>
+                </a:tc>
+                <a:tc>
+                  <a:txBody>
+                    <a:bodyPr/>
+                    <a:lstStyle/>
+                    <a:p>
+                      <a:pPr marL="0" algn="l" defTabSz="914400" rtl="0" eaLnBrk="1" latinLnBrk="0" hangingPunct="1">
+                        <a:lnSpc>
+                          <a:spcPts val="1200"/>
+                        </a:lnSpc>
+                      </a:pPr>
+                      <a:r>
+                        <a:rPr lang="en-US" sz="600" b="0" i="0" kern="1200" dirty="0">
+                          <a:solidFill>
+                            <a:schemeClr val="tx1"/>
+                          </a:solidFill>
+                          <a:latin typeface="Fund Light" pitchFamily="2" charset="-78"/>
+                          <a:ea typeface="+mn-ea"/>
+                          <a:cs typeface="Fund Light" pitchFamily="2" charset="-78"/>
+                        </a:rPr>
+                        <a:t>q</a:t>
+                      </a:r>
+                    </a:p>
+                  </a:txBody>
+                  <a:tcPr marL="36000" marR="36000" marT="0" marB="0" anchor="ctr">
+                    <a:lnL w="12700" cap="flat" cmpd="sng" algn="ctr">
+                      <a:noFill/>
+                      <a:prstDash val="solid"/>
+                      <a:round/>
+                      <a:headEnd type="none" w="med" len="med"/>
+                      <a:tailEnd type="none" w="med" len="med"/>
+                    </a:lnL>
+                    <a:lnR w="12700" cap="flat" cmpd="sng" algn="ctr">
+                      <a:noFill/>
+                      <a:prstDash val="solid"/>
+                      <a:round/>
+                      <a:headEnd type="none" w="med" len="med"/>
+                      <a:tailEnd type="none" w="med" len="med"/>
+                    </a:lnR>
+                    <a:lnT w="6350" cap="flat" cmpd="sng" algn="ctr">
+                      <a:solidFill>
+                        <a:schemeClr val="bg1">
+                          <a:lumMod val="85000"/>
+                        </a:schemeClr>
+                      </a:solidFill>
+                      <a:prstDash val="solid"/>
+                      <a:round/>
+                      <a:headEnd type="none" w="med" len="med"/>
+                      <a:tailEnd type="none" w="med" len="med"/>
+                    </a:lnT>
+                    <a:lnB w="6350" cap="flat" cmpd="sng" algn="ctr">
+                      <a:solidFill>
+                        <a:schemeClr val="bg1">
+                          <a:lumMod val="85000"/>
+                        </a:schemeClr>
+                      </a:solidFill>
+                      <a:prstDash val="solid"/>
+                      <a:round/>
+                      <a:headEnd type="none" w="med" len="med"/>
+                      <a:tailEnd type="none" w="med" len="med"/>
+                    </a:lnB>
+                    <a:lnTlToBr w="12700" cmpd="sng">
+                      <a:noFill/>
+                      <a:prstDash val="solid"/>
+                    </a:lnTlToBr>
+                    <a:lnBlToTr w="12700" cmpd="sng">
+                      <a:noFill/>
+                      <a:prstDash val="solid"/>
+                    </a:lnBlToTr>
+                    <a:noFill/>
+                  </a:tcPr>
+                </a:tc>
+                <a:tc>
+                  <a:txBody>
+                    <a:bodyPr/>
+                    <a:lstStyle/>
+                    <a:p>
+                      <a:pPr marL="0" algn="l" defTabSz="914400" rtl="0" eaLnBrk="1" latinLnBrk="0" hangingPunct="1">
+                        <a:lnSpc>
+                          <a:spcPts val="1200"/>
+                        </a:lnSpc>
+                      </a:pPr>
+                      <a:r>
+                        <a:rPr lang="en-US" sz="600" b="0" i="0" kern="1200" dirty="0">
+                          <a:solidFill>
+                            <a:schemeClr val="tx1"/>
+                          </a:solidFill>
+                          <a:latin typeface="Fund Light" pitchFamily="2" charset="-78"/>
+                          <a:ea typeface="+mn-ea"/>
+                          <a:cs typeface="Fund Light" pitchFamily="2" charset="-78"/>
+                        </a:rPr>
+                        <a:t>q</a:t>
+                      </a:r>
+                    </a:p>
+                  </a:txBody>
+                  <a:tcPr marL="36000" marR="36000" marT="0" marB="0" anchor="ctr">
+                    <a:lnL w="12700" cap="flat" cmpd="sng" algn="ctr">
+                      <a:noFill/>
+                      <a:prstDash val="solid"/>
+                      <a:round/>
+                      <a:headEnd type="none" w="med" len="med"/>
+                      <a:tailEnd type="none" w="med" len="med"/>
+                    </a:lnL>
+                    <a:lnR w="12700" cap="flat" cmpd="sng" algn="ctr">
+                      <a:noFill/>
+                      <a:prstDash val="solid"/>
+                      <a:round/>
+                      <a:headEnd type="none" w="med" len="med"/>
+                      <a:tailEnd type="none" w="med" len="med"/>
+                    </a:lnR>
+                    <a:lnT w="6350" cap="flat" cmpd="sng" algn="ctr">
+                      <a:solidFill>
+                        <a:schemeClr val="bg1">
+                          <a:lumMod val="85000"/>
+                        </a:schemeClr>
+                      </a:solidFill>
+                      <a:prstDash val="solid"/>
+                      <a:round/>
+                      <a:headEnd type="none" w="med" len="med"/>
+                      <a:tailEnd type="none" w="med" len="med"/>
+                    </a:lnT>
+                    <a:lnB w="6350" cap="flat" cmpd="sng" algn="ctr">
+                      <a:solidFill>
+                        <a:schemeClr val="bg1">
+                          <a:lumMod val="85000"/>
+                        </a:schemeClr>
+                      </a:solidFill>
+                      <a:prstDash val="solid"/>
+                      <a:round/>
+                      <a:headEnd type="none" w="med" len="med"/>
+                      <a:tailEnd type="none" w="med" len="med"/>
+                    </a:lnB>
+                    <a:lnTlToBr w="12700" cmpd="sng">
+                      <a:noFill/>
+                      <a:prstDash val="solid"/>
+                    </a:lnTlToBr>
+                    <a:lnBlToTr w="12700" cmpd="sng">
+                      <a:noFill/>
+                      <a:prstDash val="solid"/>
+                    </a:lnBlToTr>
+                    <a:noFill/>
+                  </a:tcPr>
+                </a:tc>
+                <a:extLst>
+                  <a:ext uri="{0D108BD9-81ED-4DB2-BD59-A6C34878D82A}">
+                    <a16:rowId xmlns:a16="http://schemas.microsoft.com/office/drawing/2014/main" val="1961714469"/>
+                  </a:ext>
+                </a:extLst>
+              </a:tr>
+            </a:tbl>
+          </a:graphicData>
+        </a:graphic>
+      </p:graphicFrame>
       <p:sp>
         <p:nvSpPr>
-          <p:cNvPr id="4" name="Footer Placeholder 3">
+          <p:cNvPr id="2" name="Footer Placeholder 1">
             <a:extLst>
               <a:ext uri="{FF2B5EF4-FFF2-40B4-BE49-F238E27FC236}">
-                <a16:creationId xmlns:a16="http://schemas.microsoft.com/office/drawing/2014/main" id="{704A712B-7D94-412A-AD53-6AE8FF5AB34D}"/>
+                <a16:creationId xmlns:a16="http://schemas.microsoft.com/office/drawing/2014/main" id="{E4A55677-1FD6-40FD-A80C-B7E44566976B}"/>
               </a:ext>
             </a:extLst>
           </p:cNvPr>
@@ -9739,415 +11356,6 @@
           </a:p>
         </p:txBody>
       </p:sp>
-      <p:graphicFrame>
-        <p:nvGraphicFramePr>
-          <p:cNvPr id="6" name="Table 1">
-            <a:extLst>
-              <a:ext uri="{FF2B5EF4-FFF2-40B4-BE49-F238E27FC236}">
-                <a16:creationId xmlns:a16="http://schemas.microsoft.com/office/drawing/2014/main" id="{4C88D6E7-DC14-A580-34D5-ED6EE5CB3E5B}"/>
-              </a:ext>
-            </a:extLst>
-          </p:cNvPr>
-          <p:cNvGraphicFramePr>
-            <a:graphicFrameLocks noGrp="1"/>
-          </p:cNvGraphicFramePr>
-          <p:nvPr>
-            <p:extLst>
-              <p:ext uri="{D42A27DB-BD31-4B8C-83A1-F6EECF244321}">
-                <p14:modId xmlns:p14="http://schemas.microsoft.com/office/powerpoint/2010/main" val="966796799"/>
-              </p:ext>
-            </p:extLst>
-          </p:nvPr>
-        </p:nvGraphicFramePr>
-        <p:xfrm>
-          <a:off x="6096000" y="40957"/>
-          <a:ext cx="4113823" cy="640080"/>
-        </p:xfrm>
-        <a:graphic>
-          <a:graphicData uri="http://schemas.openxmlformats.org/drawingml/2006/table">
-            <a:tbl>
-              <a:tblPr firstRow="1" bandRow="1">
-                <a:tableStyleId>{5C22544A-7EE6-4342-B048-85BDC9FD1C3A}</a:tableStyleId>
-              </a:tblPr>
-              <a:tblGrid>
-                <a:gridCol w="587689">
-                  <a:extLst>
-                    <a:ext uri="{9D8B030D-6E8A-4147-A177-3AD203B41FA5}">
-                      <a16:colId xmlns:a16="http://schemas.microsoft.com/office/drawing/2014/main" val="597839494"/>
-                    </a:ext>
-                  </a:extLst>
-                </a:gridCol>
-                <a:gridCol w="587689">
-                  <a:extLst>
-                    <a:ext uri="{9D8B030D-6E8A-4147-A177-3AD203B41FA5}">
-                      <a16:colId xmlns:a16="http://schemas.microsoft.com/office/drawing/2014/main" val="2965758537"/>
-                    </a:ext>
-                  </a:extLst>
-                </a:gridCol>
-                <a:gridCol w="587689">
-                  <a:extLst>
-                    <a:ext uri="{9D8B030D-6E8A-4147-A177-3AD203B41FA5}">
-                      <a16:colId xmlns:a16="http://schemas.microsoft.com/office/drawing/2014/main" val="985599110"/>
-                    </a:ext>
-                  </a:extLst>
-                </a:gridCol>
-                <a:gridCol w="587689">
-                  <a:extLst>
-                    <a:ext uri="{9D8B030D-6E8A-4147-A177-3AD203B41FA5}">
-                      <a16:colId xmlns:a16="http://schemas.microsoft.com/office/drawing/2014/main" val="2503815855"/>
-                    </a:ext>
-                  </a:extLst>
-                </a:gridCol>
-                <a:gridCol w="587689">
-                  <a:extLst>
-                    <a:ext uri="{9D8B030D-6E8A-4147-A177-3AD203B41FA5}">
-                      <a16:colId xmlns:a16="http://schemas.microsoft.com/office/drawing/2014/main" val="1132694783"/>
-                    </a:ext>
-                  </a:extLst>
-                </a:gridCol>
-                <a:gridCol w="587689">
-                  <a:extLst>
-                    <a:ext uri="{9D8B030D-6E8A-4147-A177-3AD203B41FA5}">
-                      <a16:colId xmlns:a16="http://schemas.microsoft.com/office/drawing/2014/main" val="870538356"/>
-                    </a:ext>
-                  </a:extLst>
-                </a:gridCol>
-                <a:gridCol w="587689">
-                  <a:extLst>
-                    <a:ext uri="{9D8B030D-6E8A-4147-A177-3AD203B41FA5}">
-                      <a16:colId xmlns:a16="http://schemas.microsoft.com/office/drawing/2014/main" val="140413072"/>
-                    </a:ext>
-                  </a:extLst>
-                </a:gridCol>
-              </a:tblGrid>
-              <a:tr h="0">
-                <a:tc gridSpan="2">
-                  <a:txBody>
-                    <a:bodyPr/>
-                    <a:lstStyle/>
-                    <a:p>
-                      <a:r>
-                        <a:rPr lang="en-US" sz="600" dirty="0"/>
-                        <a:t>Board </a:t>
-                      </a:r>
-                      <a:r>
-                        <a:rPr lang="en-US" sz="600" dirty="0" err="1"/>
-                        <a:t>Compostion</a:t>
-                      </a:r>
-                      <a:r>
-                        <a:rPr lang="en-US" sz="600" dirty="0"/>
-                        <a:t> Data</a:t>
-                      </a:r>
-                      <a:endParaRPr lang="en-IN" sz="600" dirty="0"/>
-                    </a:p>
-                  </a:txBody>
-                  <a:tcPr/>
-                </a:tc>
-                <a:tc hMerge="1">
-                  <a:txBody>
-                    <a:bodyPr/>
-                    <a:lstStyle/>
-                    <a:p>
-                      <a:endParaRPr lang="en-IN" sz="600" dirty="0"/>
-                    </a:p>
-                  </a:txBody>
-                  <a:tcPr/>
-                </a:tc>
-                <a:tc gridSpan="2">
-                  <a:txBody>
-                    <a:bodyPr/>
-                    <a:lstStyle/>
-                    <a:p>
-                      <a:r>
-                        <a:rPr lang="en-US" sz="600" dirty="0"/>
-                        <a:t>Start Date: MMMM-YYYY</a:t>
-                      </a:r>
-                      <a:endParaRPr lang="en-IN" sz="600" dirty="0"/>
-                    </a:p>
-                  </a:txBody>
-                  <a:tcPr/>
-                </a:tc>
-                <a:tc hMerge="1">
-                  <a:txBody>
-                    <a:bodyPr/>
-                    <a:lstStyle/>
-                    <a:p>
-                      <a:endParaRPr lang="en-IN" sz="600" dirty="0"/>
-                    </a:p>
-                  </a:txBody>
-                  <a:tcPr/>
-                </a:tc>
-                <a:tc gridSpan="3">
-                  <a:txBody>
-                    <a:bodyPr/>
-                    <a:lstStyle/>
-                    <a:p>
-                      <a:pPr marL="0" marR="0" lvl="0" indent="0" algn="l" defTabSz="914400" rtl="0" eaLnBrk="1" fontAlgn="auto" latinLnBrk="0" hangingPunct="1">
-                        <a:lnSpc>
-                          <a:spcPct val="100000"/>
-                        </a:lnSpc>
-                        <a:spcBef>
-                          <a:spcPts val="0"/>
-                        </a:spcBef>
-                        <a:spcAft>
-                          <a:spcPts val="0"/>
-                        </a:spcAft>
-                        <a:buClrTx/>
-                        <a:buSzTx/>
-                        <a:buFontTx/>
-                        <a:buNone/>
-                        <a:tabLst/>
-                        <a:defRPr/>
-                      </a:pPr>
-                      <a:r>
-                        <a:rPr lang="en-US" sz="600" dirty="0"/>
-                        <a:t>End Date: MMMM-YYYY</a:t>
-                      </a:r>
-                      <a:endParaRPr lang="en-IN" sz="600" dirty="0"/>
-                    </a:p>
-                  </a:txBody>
-                  <a:tcPr/>
-                </a:tc>
-                <a:tc hMerge="1">
-                  <a:txBody>
-                    <a:bodyPr/>
-                    <a:lstStyle/>
-                    <a:p>
-                      <a:endParaRPr lang="en-IN" sz="600" dirty="0"/>
-                    </a:p>
-                  </a:txBody>
-                  <a:tcPr/>
-                </a:tc>
-                <a:tc hMerge="1">
-                  <a:txBody>
-                    <a:bodyPr/>
-                    <a:lstStyle/>
-                    <a:p>
-                      <a:endParaRPr lang="en-IN" sz="600" dirty="0"/>
-                    </a:p>
-                  </a:txBody>
-                  <a:tcPr/>
-                </a:tc>
-                <a:extLst>
-                  <a:ext uri="{0D108BD9-81ED-4DB2-BD59-A6C34878D82A}">
-                    <a16:rowId xmlns:a16="http://schemas.microsoft.com/office/drawing/2014/main" val="611380770"/>
-                  </a:ext>
-                </a:extLst>
-              </a:tr>
-              <a:tr h="0">
-                <a:tc>
-                  <a:txBody>
-                    <a:bodyPr/>
-                    <a:lstStyle/>
-                    <a:p>
-                      <a:r>
-                        <a:rPr lang="en-US" sz="600" dirty="0"/>
-                        <a:t>NAME</a:t>
-                      </a:r>
-                      <a:endParaRPr lang="en-IN" sz="600" dirty="0"/>
-                    </a:p>
-                  </a:txBody>
-                  <a:tcPr/>
-                </a:tc>
-                <a:tc>
-                  <a:txBody>
-                    <a:bodyPr/>
-                    <a:lstStyle/>
-                    <a:p>
-                      <a:r>
-                        <a:rPr lang="en-US" sz="600" dirty="0"/>
-                        <a:t>PIF EMPLOYEE</a:t>
-                      </a:r>
-                      <a:endParaRPr lang="en-IN" sz="600" dirty="0"/>
-                    </a:p>
-                  </a:txBody>
-                  <a:tcPr/>
-                </a:tc>
-                <a:tc>
-                  <a:txBody>
-                    <a:bodyPr/>
-                    <a:lstStyle/>
-                    <a:p>
-                      <a:r>
-                        <a:rPr lang="en-US" sz="600" dirty="0"/>
-                        <a:t>OTHER PIF REP.</a:t>
-                      </a:r>
-                      <a:endParaRPr lang="en-IN" sz="600" dirty="0"/>
-                    </a:p>
-                  </a:txBody>
-                  <a:tcPr/>
-                </a:tc>
-                <a:tc>
-                  <a:txBody>
-                    <a:bodyPr/>
-                    <a:lstStyle/>
-                    <a:p>
-                      <a:r>
-                        <a:rPr lang="en-US" sz="600" dirty="0"/>
-                        <a:t>BOARD</a:t>
-                      </a:r>
-                      <a:endParaRPr lang="en-IN" sz="600" dirty="0"/>
-                    </a:p>
-                  </a:txBody>
-                  <a:tcPr/>
-                </a:tc>
-                <a:tc>
-                  <a:txBody>
-                    <a:bodyPr/>
-                    <a:lstStyle/>
-                    <a:p>
-                      <a:r>
-                        <a:rPr lang="en-US" sz="600" dirty="0"/>
-                        <a:t>EXCOM</a:t>
-                      </a:r>
-                      <a:endParaRPr lang="en-IN" sz="600" dirty="0"/>
-                    </a:p>
-                  </a:txBody>
-                  <a:tcPr/>
-                </a:tc>
-                <a:tc>
-                  <a:txBody>
-                    <a:bodyPr/>
-                    <a:lstStyle/>
-                    <a:p>
-                      <a:r>
-                        <a:rPr lang="en-US" sz="600" dirty="0"/>
-                        <a:t>AUDIT</a:t>
-                      </a:r>
-                      <a:endParaRPr lang="en-IN" sz="600" dirty="0"/>
-                    </a:p>
-                  </a:txBody>
-                  <a:tcPr/>
-                </a:tc>
-                <a:tc>
-                  <a:txBody>
-                    <a:bodyPr/>
-                    <a:lstStyle/>
-                    <a:p>
-                      <a:r>
-                        <a:rPr lang="en-US" sz="600" dirty="0"/>
-                        <a:t>NRC</a:t>
-                      </a:r>
-                      <a:endParaRPr lang="en-IN" sz="600" dirty="0"/>
-                    </a:p>
-                  </a:txBody>
-                  <a:tcPr/>
-                </a:tc>
-                <a:extLst>
-                  <a:ext uri="{0D108BD9-81ED-4DB2-BD59-A6C34878D82A}">
-                    <a16:rowId xmlns:a16="http://schemas.microsoft.com/office/drawing/2014/main" val="1077373604"/>
-                  </a:ext>
-                </a:extLst>
-              </a:tr>
-              <a:tr h="0">
-                <a:tc>
-                  <a:txBody>
-                    <a:bodyPr/>
-                    <a:lstStyle/>
-                    <a:p>
-                      <a:r>
-                        <a:rPr lang="en-US" sz="600" dirty="0"/>
-                        <a:t>a</a:t>
-                      </a:r>
-                      <a:endParaRPr lang="en-IN" sz="600" dirty="0"/>
-                    </a:p>
-                  </a:txBody>
-                  <a:tcPr/>
-                </a:tc>
-                <a:tc>
-                  <a:txBody>
-                    <a:bodyPr/>
-                    <a:lstStyle/>
-                    <a:p>
-                      <a:r>
-                        <a:rPr lang="en-US" sz="600" dirty="0"/>
-                        <a:t>A</a:t>
-                      </a:r>
-                      <a:endParaRPr lang="en-IN" sz="600" dirty="0"/>
-                    </a:p>
-                  </a:txBody>
-                  <a:tcPr/>
-                </a:tc>
-                <a:tc>
-                  <a:txBody>
-                    <a:bodyPr/>
-                    <a:lstStyle/>
-                    <a:p>
-                      <a:r>
-                        <a:rPr lang="en-US" sz="600" dirty="0"/>
-                        <a:t>A</a:t>
-                      </a:r>
-                      <a:endParaRPr lang="en-IN" sz="600" dirty="0"/>
-                    </a:p>
-                  </a:txBody>
-                  <a:tcPr/>
-                </a:tc>
-                <a:tc>
-                  <a:txBody>
-                    <a:bodyPr/>
-                    <a:lstStyle/>
-                    <a:p>
-                      <a:r>
-                        <a:rPr lang="en-US" sz="600" dirty="0"/>
-                        <a:t>A</a:t>
-                      </a:r>
-                      <a:endParaRPr lang="en-IN" sz="600" dirty="0"/>
-                    </a:p>
-                  </a:txBody>
-                  <a:tcPr/>
-                </a:tc>
-                <a:tc>
-                  <a:txBody>
-                    <a:bodyPr/>
-                    <a:lstStyle/>
-                    <a:p>
-                      <a:r>
-                        <a:rPr lang="en-US" sz="600" dirty="0"/>
-                        <a:t>A</a:t>
-                      </a:r>
-                      <a:endParaRPr lang="en-IN" sz="600" dirty="0"/>
-                    </a:p>
-                  </a:txBody>
-                  <a:tcPr/>
-                </a:tc>
-                <a:tc>
-                  <a:txBody>
-                    <a:bodyPr/>
-                    <a:lstStyle/>
-                    <a:p>
-                      <a:r>
-                        <a:rPr lang="en-US" sz="600" dirty="0"/>
-                        <a:t>A</a:t>
-                      </a:r>
-                      <a:endParaRPr lang="en-IN" sz="600" dirty="0"/>
-                    </a:p>
-                  </a:txBody>
-                  <a:tcPr/>
-                </a:tc>
-                <a:tc>
-                  <a:txBody>
-                    <a:bodyPr/>
-                    <a:lstStyle/>
-                    <a:p>
-                      <a:r>
-                        <a:rPr lang="en-US" sz="600" dirty="0"/>
-                        <a:t>a</a:t>
-                      </a:r>
-                      <a:endParaRPr lang="en-IN" sz="600" dirty="0"/>
-                    </a:p>
-                  </a:txBody>
-                  <a:tcPr/>
-                </a:tc>
-                <a:extLst>
-                  <a:ext uri="{0D108BD9-81ED-4DB2-BD59-A6C34878D82A}">
-                    <a16:rowId xmlns:a16="http://schemas.microsoft.com/office/drawing/2014/main" val="609257130"/>
-                  </a:ext>
-                </a:extLst>
-              </a:tr>
-            </a:tbl>
-          </a:graphicData>
-        </a:graphic>
-      </p:graphicFrame>
     </p:spTree>
     <p:extLst>
       <p:ext uri="{BB962C8B-B14F-4D97-AF65-F5344CB8AC3E}">
@@ -10766,10 +11974,10 @@
       </p:grpSp>
       <p:sp>
         <p:nvSpPr>
-          <p:cNvPr id="6" name="Footer Placeholder 5">
+          <p:cNvPr id="5" name="Footer Placeholder 4">
             <a:extLst>
               <a:ext uri="{FF2B5EF4-FFF2-40B4-BE49-F238E27FC236}">
-                <a16:creationId xmlns:a16="http://schemas.microsoft.com/office/drawing/2014/main" id="{2216E377-ED81-42F2-9E55-156972D6B437}"/>
+                <a16:creationId xmlns:a16="http://schemas.microsoft.com/office/drawing/2014/main" id="{527A73E8-F067-48F1-8C9F-D1E79455538B}"/>
               </a:ext>
             </a:extLst>
           </p:cNvPr>
@@ -11519,6 +12727,12 @@
 </file>
 
 <file path=customXml/item1.xml><?xml version="1.0" encoding="utf-8"?>
+<sisl xmlns:xsd="http://www.w3.org/2001/XMLSchema" xmlns:xsi="http://www.w3.org/2001/XMLSchema-instance" xmlns="http://www.boldonjames.com/2008/01/sie/internal/label" sislVersion="0" policy="4f3ffa34-8ea5-4d04-9688-c0eeb614b05f" origin="userSelected">
+  <element uid="id_classification_nonbusiness" value=""/>
+</sisl>
+</file>
+
+<file path=customXml/item2.xml><?xml version="1.0" encoding="utf-8"?>
 <WrappedLabelInfo xmlns:xsd="http://www.w3.org/2001/XMLSchema" xmlns:xsi="http://www.w3.org/2001/XMLSchema-instance" xmlns="http://www.boldonjames.com/2016/02/Classifier/internal/wrappedLabelInfo">
   <Value>
         PD94bWwgdmVyc2lvbj0iMS4wIiBlbmNvZGluZz0idXMtYXNjaWkiPz48TGFiZWxJbmZvWG1sUGFydCB4bWxuczp4c2Q9Imh0dHA6Ly93d3cudzMub3JnLzIwMDEvWE1MU2NoZW1hIiB4bWxuczp4c2k9Imh0dHA6Ly93d3cudzMub3JnLzIwMDEvWE1MU2NoZW1hLWluc3RhbmNlIiB4bWxucz0iaHR0cDovL3d3dy5ib2xkb25qYW1lcy5jb20vMjAxNi8wMi9DbGFzc2lmaWVyL2ludGVybmFsL2xhYmVsSW5mbyI+PGVsaD5zS0dRS1drK1lkdW5pR1dnWEZKaXhOaHZncEpxN1VHWTwvZWxoPjxjb25maWc+UElGX1BST0Q8L2NvbmZpZz48cG9sPlBJRl9QUk9EPC9wb2w+PHN1bW1hcnk+UHVibGljPC9zdW1tYXJ5PjxhcHA+UG93ZXJQb2ludDwvYXBwPjxTaWduYXR1cmVWYWxpZD5mYWxzZTwvU2lnbmF0dXJlVmFsaWQ+PC9MYWJlbEluZm9YbWxQYXJ0Pg==</Value>
@@ -11549,14 +12763,17 @@
 </WrappedLabelInfo>
 </file>
 
-<file path=customXml/item2.xml><?xml version="1.0" encoding="utf-8"?>
-<sisl xmlns:xsd="http://www.w3.org/2001/XMLSchema" xmlns:xsi="http://www.w3.org/2001/XMLSchema-instance" xmlns="http://www.boldonjames.com/2008/01/sie/internal/label" sislVersion="0" policy="4f3ffa34-8ea5-4d04-9688-c0eeb614b05f" origin="userSelected">
-  <element uid="id_classification_nonbusiness" value=""/>
-</sisl>
+<file path=customXml/itemProps1.xml><?xml version="1.0" encoding="utf-8"?>
+<ds:datastoreItem xmlns:ds="http://schemas.openxmlformats.org/officeDocument/2006/customXml" ds:itemID="{4BBA4F4B-83B1-4A04-928D-4E5BAAE29B16}">
+  <ds:schemaRefs>
+    <ds:schemaRef ds:uri="http://www.w3.org/2001/XMLSchema"/>
+    <ds:schemaRef ds:uri="http://www.boldonjames.com/2008/01/sie/internal/label"/>
+  </ds:schemaRefs>
+</ds:datastoreItem>
 </file>
 
-<file path=customXml/itemProps1.xml><?xml version="1.0" encoding="utf-8"?>
-<ds:datastoreItem xmlns:ds="http://schemas.openxmlformats.org/officeDocument/2006/customXml" ds:itemID="{DA1CAF05-4605-4D79-B2CD-2732286DB1E6}">
+<file path=customXml/itemProps2.xml><?xml version="1.0" encoding="utf-8"?>
+<ds:datastoreItem xmlns:ds="http://schemas.openxmlformats.org/officeDocument/2006/customXml" ds:itemID="{36AC9BF8-2F14-4C26-BFEB-10E05DBCEFAB}">
   <ds:schemaRefs>
     <ds:schemaRef ds:uri="http://www.w3.org/2001/XMLSchema"/>
     <ds:schemaRef ds:uri="http://www.boldonjames.com/2016/02/Classifier/internal/wrappedLabelInfo"/>
@@ -11564,13 +12781,4 @@
     <ds:schemaRef ds:uri=""/>
   </ds:schemaRefs>
 </ds:datastoreItem>
-</file>
-
-<file path=customXml/itemProps2.xml><?xml version="1.0" encoding="utf-8"?>
-<ds:datastoreItem xmlns:ds="http://schemas.openxmlformats.org/officeDocument/2006/customXml" ds:itemID="{1F932E4C-D55E-4037-A535-9777C851BCE7}">
-  <ds:schemaRefs>
-    <ds:schemaRef ds:uri="http://www.w3.org/2001/XMLSchema"/>
-    <ds:schemaRef ds:uri="http://www.boldonjames.com/2008/01/sie/internal/label"/>
-  </ds:schemaRefs>
-</ds:datastoreItem>
 </file>
</xml_diff>

<commit_message>
Revert "feat: add officePPT template files and implement TableManager helper"
This reverts commit 3cc99abc412480b4979c32a2a9dc770680c694bd.
</commit_message>
<xml_diff>
--- a/templates/officePPT.pptx
+++ b/templates/officePPT.pptx
@@ -787,7 +787,6 @@
     </c:legend>
     <c:plotVisOnly val="1"/>
     <c:dispBlanksAs val="gap"/>
-    <c:showDLblsOverMax val="0"/>
     <c:extLst>
       <c:ext xmlns:c16r3="http://schemas.microsoft.com/office/drawing/2017/03/chart" uri="{56B9EC1D-385E-4148-901F-78D8002777C0}">
         <c16r3:dataDisplayOptions16>
@@ -795,6 +794,7 @@
         </c16r3:dataDisplayOptions16>
       </c:ext>
     </c:extLst>
+    <c:showDLblsOverMax val="0"/>
   </c:chart>
   <c:spPr>
     <a:noFill/>
@@ -1244,7 +1244,6 @@
     </c:legend>
     <c:plotVisOnly val="1"/>
     <c:dispBlanksAs val="gap"/>
-    <c:showDLblsOverMax val="0"/>
     <c:extLst>
       <c:ext xmlns:c16r3="http://schemas.microsoft.com/office/drawing/2017/03/chart" uri="{56B9EC1D-385E-4148-901F-78D8002777C0}">
         <c16r3:dataDisplayOptions16>
@@ -1252,6 +1251,7 @@
         </c16r3:dataDisplayOptions16>
       </c:ext>
     </c:extLst>
+    <c:showDLblsOverMax val="0"/>
   </c:chart>
   <c:spPr>
     <a:noFill/>
@@ -2038,7 +2038,6 @@
     </c:plotArea>
     <c:plotVisOnly val="1"/>
     <c:dispBlanksAs val="gap"/>
-    <c:showDLblsOverMax val="0"/>
     <c:extLst>
       <c:ext xmlns:c16r3="http://schemas.microsoft.com/office/drawing/2017/03/chart" uri="{56B9EC1D-385E-4148-901F-78D8002777C0}">
         <c16r3:dataDisplayOptions16>
@@ -2046,6 +2045,7 @@
         </c16r3:dataDisplayOptions16>
       </c:ext>
     </c:extLst>
+    <c:showDLblsOverMax val="0"/>
   </c:chart>
   <c:spPr>
     <a:noFill/>
@@ -3783,7 +3783,7 @@
           <a:p>
             <a:fld id="{8B1AF6D7-0F32-4F05-B21A-8AF0CB26F94C}" type="datetimeFigureOut">
               <a:rPr lang="en-IN" smtClean="0"/>
-              <a:t>08-07-2026</a:t>
+              <a:t>26-06-2026</a:t>
             </a:fld>
             <a:endParaRPr lang="en-IN"/>
           </a:p>
@@ -4980,7 +4980,7 @@
           <a:p>
             <a:fld id="{0490EA95-AFA9-47FA-B067-612933D1D62E}" type="datetimeFigureOut">
               <a:rPr lang="en-IN" smtClean="0"/>
-              <a:t>08-07-2026</a:t>
+              <a:t>26-06-2026</a:t>
             </a:fld>
             <a:endParaRPr lang="en-IN"/>
           </a:p>
@@ -5180,7 +5180,7 @@
           <a:p>
             <a:fld id="{0490EA95-AFA9-47FA-B067-612933D1D62E}" type="datetimeFigureOut">
               <a:rPr lang="en-IN" smtClean="0"/>
-              <a:t>08-07-2026</a:t>
+              <a:t>26-06-2026</a:t>
             </a:fld>
             <a:endParaRPr lang="en-IN"/>
           </a:p>
@@ -5390,7 +5390,7 @@
           <a:p>
             <a:fld id="{0490EA95-AFA9-47FA-B067-612933D1D62E}" type="datetimeFigureOut">
               <a:rPr lang="en-IN" smtClean="0"/>
-              <a:t>08-07-2026</a:t>
+              <a:t>26-06-2026</a:t>
             </a:fld>
             <a:endParaRPr lang="en-IN"/>
           </a:p>
@@ -5590,7 +5590,7 @@
           <a:p>
             <a:fld id="{0490EA95-AFA9-47FA-B067-612933D1D62E}" type="datetimeFigureOut">
               <a:rPr lang="en-IN" smtClean="0"/>
-              <a:t>08-07-2026</a:t>
+              <a:t>26-06-2026</a:t>
             </a:fld>
             <a:endParaRPr lang="en-IN"/>
           </a:p>
@@ -5880,7 +5880,7 @@
           <a:p>
             <a:fld id="{0490EA95-AFA9-47FA-B067-612933D1D62E}" type="datetimeFigureOut">
               <a:rPr lang="en-IN" smtClean="0"/>
-              <a:t>08-07-2026</a:t>
+              <a:t>26-06-2026</a:t>
             </a:fld>
             <a:endParaRPr lang="en-IN"/>
           </a:p>
@@ -6148,7 +6148,7 @@
           <a:p>
             <a:fld id="{0490EA95-AFA9-47FA-B067-612933D1D62E}" type="datetimeFigureOut">
               <a:rPr lang="en-IN" smtClean="0"/>
-              <a:t>08-07-2026</a:t>
+              <a:t>26-06-2026</a:t>
             </a:fld>
             <a:endParaRPr lang="en-IN"/>
           </a:p>
@@ -6563,7 +6563,7 @@
           <a:p>
             <a:fld id="{0490EA95-AFA9-47FA-B067-612933D1D62E}" type="datetimeFigureOut">
               <a:rPr lang="en-IN" smtClean="0"/>
-              <a:t>08-07-2026</a:t>
+              <a:t>26-06-2026</a:t>
             </a:fld>
             <a:endParaRPr lang="en-IN"/>
           </a:p>
@@ -6705,7 +6705,7 @@
           <a:p>
             <a:fld id="{0490EA95-AFA9-47FA-B067-612933D1D62E}" type="datetimeFigureOut">
               <a:rPr lang="en-IN" smtClean="0"/>
-              <a:t>08-07-2026</a:t>
+              <a:t>26-06-2026</a:t>
             </a:fld>
             <a:endParaRPr lang="en-IN"/>
           </a:p>
@@ -6818,7 +6818,7 @@
           <a:p>
             <a:fld id="{0490EA95-AFA9-47FA-B067-612933D1D62E}" type="datetimeFigureOut">
               <a:rPr lang="en-IN" smtClean="0"/>
-              <a:t>08-07-2026</a:t>
+              <a:t>26-06-2026</a:t>
             </a:fld>
             <a:endParaRPr lang="en-IN"/>
           </a:p>
@@ -7131,7 +7131,7 @@
           <a:p>
             <a:fld id="{0490EA95-AFA9-47FA-B067-612933D1D62E}" type="datetimeFigureOut">
               <a:rPr lang="en-IN" smtClean="0"/>
-              <a:t>08-07-2026</a:t>
+              <a:t>26-06-2026</a:t>
             </a:fld>
             <a:endParaRPr lang="en-IN"/>
           </a:p>
@@ -7420,7 +7420,7 @@
           <a:p>
             <a:fld id="{0490EA95-AFA9-47FA-B067-612933D1D62E}" type="datetimeFigureOut">
               <a:rPr lang="en-IN" smtClean="0"/>
-              <a:t>08-07-2026</a:t>
+              <a:t>26-06-2026</a:t>
             </a:fld>
             <a:endParaRPr lang="en-IN"/>
           </a:p>
@@ -7663,7 +7663,7 @@
           <a:p>
             <a:fld id="{0490EA95-AFA9-47FA-B067-612933D1D62E}" type="datetimeFigureOut">
               <a:rPr lang="en-IN" smtClean="0"/>
-              <a:t>08-07-2026</a:t>
+              <a:t>26-06-2026</a:t>
             </a:fld>
             <a:endParaRPr lang="en-IN"/>
           </a:p>
@@ -8193,10 +8193,10 @@
       </p:graphicFrame>
       <p:sp>
         <p:nvSpPr>
-          <p:cNvPr id="4" name="Footer Placeholder 3">
+          <p:cNvPr id="5" name="Footer Placeholder 4">
             <a:extLst>
               <a:ext uri="{FF2B5EF4-FFF2-40B4-BE49-F238E27FC236}">
-                <a16:creationId xmlns:a16="http://schemas.microsoft.com/office/drawing/2014/main" id="{2E80303B-D788-4D39-A1D0-32C5F90213D0}"/>
+                <a16:creationId xmlns:a16="http://schemas.microsoft.com/office/drawing/2014/main" id="{A4EB2420-B09B-4DFD-B28E-37DDE47DFA71}"/>
               </a:ext>
             </a:extLst>
           </p:cNvPr>
@@ -8320,10 +8320,10 @@
       </p:graphicFrame>
       <p:sp>
         <p:nvSpPr>
-          <p:cNvPr id="3" name="Footer Placeholder 2">
+          <p:cNvPr id="4" name="Footer Placeholder 3">
             <a:extLst>
               <a:ext uri="{FF2B5EF4-FFF2-40B4-BE49-F238E27FC236}">
-                <a16:creationId xmlns:a16="http://schemas.microsoft.com/office/drawing/2014/main" id="{4AB522F2-E5A7-4F5D-999D-810C8CB35B71}"/>
+                <a16:creationId xmlns:a16="http://schemas.microsoft.com/office/drawing/2014/main" id="{0A82AB87-F5C6-4A29-A383-B9C3449C5CAE}"/>
               </a:ext>
             </a:extLst>
           </p:cNvPr>
@@ -9319,10 +9319,10 @@
       </p:sp>
       <p:sp>
         <p:nvSpPr>
-          <p:cNvPr id="12" name="Footer Placeholder 11">
+          <p:cNvPr id="13" name="Footer Placeholder 12">
             <a:extLst>
               <a:ext uri="{FF2B5EF4-FFF2-40B4-BE49-F238E27FC236}">
-                <a16:creationId xmlns:a16="http://schemas.microsoft.com/office/drawing/2014/main" id="{1672FF25-2EE4-4CCB-8E91-567C30CA9325}"/>
+                <a16:creationId xmlns:a16="http://schemas.microsoft.com/office/drawing/2014/main" id="{6F8B634C-829C-4055-8907-6A01C93C3E7F}"/>
               </a:ext>
             </a:extLst>
           </p:cNvPr>
@@ -9563,10 +9563,10 @@
       </p:sp>
       <p:sp>
         <p:nvSpPr>
-          <p:cNvPr id="6" name="Footer Placeholder 5">
+          <p:cNvPr id="7" name="Footer Placeholder 6">
             <a:extLst>
               <a:ext uri="{FF2B5EF4-FFF2-40B4-BE49-F238E27FC236}">
-                <a16:creationId xmlns:a16="http://schemas.microsoft.com/office/drawing/2014/main" id="{6D551B71-AFB5-4983-9668-CCD00F9D7E49}"/>
+                <a16:creationId xmlns:a16="http://schemas.microsoft.com/office/drawing/2014/main" id="{010F6015-4DD0-471D-A60C-AB6C888A6AD0}"/>
               </a:ext>
             </a:extLst>
           </p:cNvPr>
@@ -9708,1629 +9708,12 @@
           </a:p>
         </p:txBody>
       </p:sp>
-      <p:graphicFrame>
-        <p:nvGraphicFramePr>
-          <p:cNvPr id="5" name="Board Data">
+      <p:sp>
+        <p:nvSpPr>
+          <p:cNvPr id="4" name="Footer Placeholder 3">
             <a:extLst>
               <a:ext uri="{FF2B5EF4-FFF2-40B4-BE49-F238E27FC236}">
-                <a16:creationId xmlns:a16="http://schemas.microsoft.com/office/drawing/2014/main" id="{200C1D5F-0C2A-486C-A767-14A24E5AA098}"/>
-              </a:ext>
-            </a:extLst>
-          </p:cNvPr>
-          <p:cNvGraphicFramePr>
-            <a:graphicFrameLocks noGrp="1"/>
-          </p:cNvGraphicFramePr>
-          <p:nvPr>
-            <p:extLst>
-              <p:ext uri="{D42A27DB-BD31-4B8C-83A1-F6EECF244321}">
-                <p14:modId xmlns:p14="http://schemas.microsoft.com/office/powerpoint/2010/main" val="131546633"/>
-              </p:ext>
-            </p:extLst>
-          </p:nvPr>
-        </p:nvGraphicFramePr>
-        <p:xfrm>
-          <a:off x="6941467" y="136525"/>
-          <a:ext cx="4334512" cy="457200"/>
-        </p:xfrm>
-        <a:graphic>
-          <a:graphicData uri="http://schemas.openxmlformats.org/drawingml/2006/table">
-            <a:tbl>
-              <a:tblPr firstRow="1">
-                <a:tableStyleId>{5C22544A-7EE6-4342-B048-85BDC9FD1C3A}</a:tableStyleId>
-              </a:tblPr>
-              <a:tblGrid>
-                <a:gridCol w="619216">
-                  <a:extLst>
-                    <a:ext uri="{9D8B030D-6E8A-4147-A177-3AD203B41FA5}">
-                      <a16:colId xmlns:a16="http://schemas.microsoft.com/office/drawing/2014/main" val="2710512592"/>
-                    </a:ext>
-                  </a:extLst>
-                </a:gridCol>
-                <a:gridCol w="1152494">
-                  <a:extLst>
-                    <a:ext uri="{9D8B030D-6E8A-4147-A177-3AD203B41FA5}">
-                      <a16:colId xmlns:a16="http://schemas.microsoft.com/office/drawing/2014/main" val="3519371818"/>
-                    </a:ext>
-                  </a:extLst>
-                </a:gridCol>
-                <a:gridCol w="738554">
-                  <a:extLst>
-                    <a:ext uri="{9D8B030D-6E8A-4147-A177-3AD203B41FA5}">
-                      <a16:colId xmlns:a16="http://schemas.microsoft.com/office/drawing/2014/main" val="4260604003"/>
-                    </a:ext>
-                  </a:extLst>
-                </a:gridCol>
-                <a:gridCol w="580292">
-                  <a:extLst>
-                    <a:ext uri="{9D8B030D-6E8A-4147-A177-3AD203B41FA5}">
-                      <a16:colId xmlns:a16="http://schemas.microsoft.com/office/drawing/2014/main" val="958991336"/>
-                    </a:ext>
-                  </a:extLst>
-                </a:gridCol>
-                <a:gridCol w="457200">
-                  <a:extLst>
-                    <a:ext uri="{9D8B030D-6E8A-4147-A177-3AD203B41FA5}">
-                      <a16:colId xmlns:a16="http://schemas.microsoft.com/office/drawing/2014/main" val="4239024402"/>
-                    </a:ext>
-                  </a:extLst>
-                </a:gridCol>
-                <a:gridCol w="474785">
-                  <a:extLst>
-                    <a:ext uri="{9D8B030D-6E8A-4147-A177-3AD203B41FA5}">
-                      <a16:colId xmlns:a16="http://schemas.microsoft.com/office/drawing/2014/main" val="505228023"/>
-                    </a:ext>
-                  </a:extLst>
-                </a:gridCol>
-                <a:gridCol w="311971">
-                  <a:extLst>
-                    <a:ext uri="{9D8B030D-6E8A-4147-A177-3AD203B41FA5}">
-                      <a16:colId xmlns:a16="http://schemas.microsoft.com/office/drawing/2014/main" val="3014002297"/>
-                    </a:ext>
-                  </a:extLst>
-                </a:gridCol>
-              </a:tblGrid>
-              <a:tr h="182880">
-                <a:tc gridSpan="2">
-                  <a:txBody>
-                    <a:bodyPr/>
-                    <a:lstStyle/>
-                    <a:p>
-                      <a:pPr algn="l">
-                        <a:lnSpc>
-                          <a:spcPts val="1300"/>
-                        </a:lnSpc>
-                      </a:pPr>
-                      <a:r>
-                        <a:rPr lang="en-US" sz="600" b="0" i="0" dirty="0">
-                          <a:solidFill>
-                            <a:schemeClr val="bg1"/>
-                          </a:solidFill>
-                          <a:latin typeface="Fund Regular" pitchFamily="2" charset="-78"/>
-                          <a:cs typeface="Fund Regular" pitchFamily="2" charset="-78"/>
-                        </a:rPr>
-                        <a:t>BOARD COMPOSITION DATA</a:t>
-                      </a:r>
-                    </a:p>
-                  </a:txBody>
-                  <a:tcPr marL="36000" marR="36000" marT="0" marB="0" anchor="ctr">
-                    <a:lnL w="3175" cap="flat" cmpd="sng" algn="ctr">
-                      <a:solidFill>
-                        <a:schemeClr val="bg1"/>
-                      </a:solidFill>
-                      <a:prstDash val="solid"/>
-                      <a:round/>
-                      <a:headEnd type="none" w="med" len="med"/>
-                      <a:tailEnd type="none" w="med" len="med"/>
-                    </a:lnL>
-                    <a:lnR w="3175" cap="flat" cmpd="sng" algn="ctr">
-                      <a:solidFill>
-                        <a:schemeClr val="bg1"/>
-                      </a:solidFill>
-                      <a:prstDash val="solid"/>
-                      <a:round/>
-                      <a:headEnd type="none" w="med" len="med"/>
-                      <a:tailEnd type="none" w="med" len="med"/>
-                    </a:lnR>
-                    <a:lnT w="3175" cap="flat" cmpd="sng" algn="ctr">
-                      <a:solidFill>
-                        <a:schemeClr val="bg1"/>
-                      </a:solidFill>
-                      <a:prstDash val="solid"/>
-                      <a:round/>
-                      <a:headEnd type="none" w="med" len="med"/>
-                      <a:tailEnd type="none" w="med" len="med"/>
-                    </a:lnT>
-                    <a:lnB w="3175" cap="flat" cmpd="sng" algn="ctr">
-                      <a:solidFill>
-                        <a:schemeClr val="bg1"/>
-                      </a:solidFill>
-                      <a:prstDash val="solid"/>
-                      <a:round/>
-                      <a:headEnd type="none" w="med" len="med"/>
-                      <a:tailEnd type="none" w="med" len="med"/>
-                    </a:lnB>
-                    <a:lnTlToBr w="12700" cmpd="sng">
-                      <a:noFill/>
-                      <a:prstDash val="solid"/>
-                    </a:lnTlToBr>
-                    <a:lnBlToTr w="12700" cmpd="sng">
-                      <a:noFill/>
-                      <a:prstDash val="solid"/>
-                    </a:lnBlToTr>
-                    <a:solidFill>
-                      <a:schemeClr val="tx2"/>
-                    </a:solidFill>
-                  </a:tcPr>
-                </a:tc>
-                <a:tc hMerge="1">
-                  <a:txBody>
-                    <a:bodyPr/>
-                    <a:lstStyle/>
-                    <a:p>
-                      <a:pPr>
-                        <a:lnSpc>
-                          <a:spcPts val="1300"/>
-                        </a:lnSpc>
-                      </a:pPr>
-                      <a:endParaRPr lang="en-US" sz="1200" dirty="0">
-                        <a:solidFill>
-                          <a:schemeClr val="bg1"/>
-                        </a:solidFill>
-                        <a:latin typeface="Sakkal Majalla" panose="02000000000000000000" pitchFamily="2" charset="-78"/>
-                        <a:cs typeface="Sakkal Majalla" panose="02000000000000000000" pitchFamily="2" charset="-78"/>
-                      </a:endParaRPr>
-                    </a:p>
-                  </a:txBody>
-                  <a:tcPr marL="36000" marR="36000" marT="0" marB="0" anchor="ctr">
-                    <a:lnL w="3175" cap="flat" cmpd="sng" algn="ctr">
-                      <a:solidFill>
-                        <a:schemeClr val="bg1"/>
-                      </a:solidFill>
-                      <a:prstDash val="solid"/>
-                      <a:round/>
-                      <a:headEnd type="none" w="med" len="med"/>
-                      <a:tailEnd type="none" w="med" len="med"/>
-                    </a:lnL>
-                    <a:lnR w="3175" cap="flat" cmpd="sng" algn="ctr">
-                      <a:solidFill>
-                        <a:schemeClr val="bg1"/>
-                      </a:solidFill>
-                      <a:prstDash val="solid"/>
-                      <a:round/>
-                      <a:headEnd type="none" w="med" len="med"/>
-                      <a:tailEnd type="none" w="med" len="med"/>
-                    </a:lnR>
-                    <a:lnT w="3175" cap="flat" cmpd="sng" algn="ctr">
-                      <a:solidFill>
-                        <a:schemeClr val="bg1"/>
-                      </a:solidFill>
-                      <a:prstDash val="solid"/>
-                      <a:round/>
-                      <a:headEnd type="none" w="med" len="med"/>
-                      <a:tailEnd type="none" w="med" len="med"/>
-                    </a:lnT>
-                    <a:lnB w="3175" cap="flat" cmpd="sng" algn="ctr">
-                      <a:solidFill>
-                        <a:schemeClr val="bg1"/>
-                      </a:solidFill>
-                      <a:prstDash val="solid"/>
-                      <a:round/>
-                      <a:headEnd type="none" w="med" len="med"/>
-                      <a:tailEnd type="none" w="med" len="med"/>
-                    </a:lnB>
-                    <a:lnTlToBr w="12700" cmpd="sng">
-                      <a:noFill/>
-                      <a:prstDash val="solid"/>
-                    </a:lnTlToBr>
-                    <a:lnBlToTr w="12700" cmpd="sng">
-                      <a:noFill/>
-                      <a:prstDash val="solid"/>
-                    </a:lnBlToTr>
-                    <a:solidFill>
-                      <a:schemeClr val="tx2"/>
-                    </a:solidFill>
-                  </a:tcPr>
-                </a:tc>
-                <a:tc gridSpan="2">
-                  <a:txBody>
-                    <a:bodyPr/>
-                    <a:lstStyle/>
-                    <a:p>
-                      <a:pPr algn="l">
-                        <a:lnSpc>
-                          <a:spcPts val="1300"/>
-                        </a:lnSpc>
-                      </a:pPr>
-                      <a:r>
-                        <a:rPr lang="en-US" sz="600" b="0" i="0" kern="1200" dirty="0">
-                          <a:solidFill>
-                            <a:schemeClr val="bg1"/>
-                          </a:solidFill>
-                          <a:latin typeface="Fund Regular" pitchFamily="2" charset="-78"/>
-                          <a:ea typeface="+mn-ea"/>
-                          <a:cs typeface="Fund Regular" pitchFamily="2" charset="-78"/>
-                        </a:rPr>
-                        <a:t>START DATE: MMMM-YYYY</a:t>
-                      </a:r>
-                      <a:endParaRPr lang="en-US" sz="600" dirty="0">
-                        <a:solidFill>
-                          <a:schemeClr val="bg1"/>
-                        </a:solidFill>
-                        <a:latin typeface="Sakkal Majalla" panose="02000000000000000000" pitchFamily="2" charset="-78"/>
-                        <a:cs typeface="Sakkal Majalla" panose="02000000000000000000" pitchFamily="2" charset="-78"/>
-                      </a:endParaRPr>
-                    </a:p>
-                  </a:txBody>
-                  <a:tcPr marL="36000" marR="36000" marT="0" marB="0" anchor="ctr">
-                    <a:lnL w="3175" cap="flat" cmpd="sng" algn="ctr">
-                      <a:solidFill>
-                        <a:schemeClr val="bg1"/>
-                      </a:solidFill>
-                      <a:prstDash val="solid"/>
-                      <a:round/>
-                      <a:headEnd type="none" w="med" len="med"/>
-                      <a:tailEnd type="none" w="med" len="med"/>
-                    </a:lnL>
-                    <a:lnR w="3175" cap="flat" cmpd="sng" algn="ctr">
-                      <a:solidFill>
-                        <a:schemeClr val="bg1"/>
-                      </a:solidFill>
-                      <a:prstDash val="solid"/>
-                      <a:round/>
-                      <a:headEnd type="none" w="med" len="med"/>
-                      <a:tailEnd type="none" w="med" len="med"/>
-                    </a:lnR>
-                    <a:lnT w="3175" cap="flat" cmpd="sng" algn="ctr">
-                      <a:solidFill>
-                        <a:schemeClr val="bg1"/>
-                      </a:solidFill>
-                      <a:prstDash val="solid"/>
-                      <a:round/>
-                      <a:headEnd type="none" w="med" len="med"/>
-                      <a:tailEnd type="none" w="med" len="med"/>
-                    </a:lnT>
-                    <a:lnB w="3175" cap="flat" cmpd="sng" algn="ctr">
-                      <a:solidFill>
-                        <a:schemeClr val="bg1"/>
-                      </a:solidFill>
-                      <a:prstDash val="solid"/>
-                      <a:round/>
-                      <a:headEnd type="none" w="med" len="med"/>
-                      <a:tailEnd type="none" w="med" len="med"/>
-                    </a:lnB>
-                    <a:lnTlToBr w="12700" cmpd="sng">
-                      <a:noFill/>
-                      <a:prstDash val="solid"/>
-                    </a:lnTlToBr>
-                    <a:lnBlToTr w="12700" cmpd="sng">
-                      <a:noFill/>
-                      <a:prstDash val="solid"/>
-                    </a:lnBlToTr>
-                    <a:solidFill>
-                      <a:schemeClr val="tx2"/>
-                    </a:solidFill>
-                  </a:tcPr>
-                </a:tc>
-                <a:tc hMerge="1">
-                  <a:txBody>
-                    <a:bodyPr/>
-                    <a:lstStyle/>
-                    <a:p>
-                      <a:pPr>
-                        <a:lnSpc>
-                          <a:spcPts val="1300"/>
-                        </a:lnSpc>
-                      </a:pPr>
-                      <a:endParaRPr lang="en-US" sz="1200" dirty="0">
-                        <a:solidFill>
-                          <a:schemeClr val="bg1"/>
-                        </a:solidFill>
-                        <a:latin typeface="Sakkal Majalla" panose="02000000000000000000" pitchFamily="2" charset="-78"/>
-                        <a:cs typeface="Sakkal Majalla" panose="02000000000000000000" pitchFamily="2" charset="-78"/>
-                      </a:endParaRPr>
-                    </a:p>
-                  </a:txBody>
-                  <a:tcPr marL="36000" marR="36000" marT="0" marB="0" anchor="ctr">
-                    <a:lnL w="3175" cap="flat" cmpd="sng" algn="ctr">
-                      <a:solidFill>
-                        <a:schemeClr val="bg1"/>
-                      </a:solidFill>
-                      <a:prstDash val="solid"/>
-                      <a:round/>
-                      <a:headEnd type="none" w="med" len="med"/>
-                      <a:tailEnd type="none" w="med" len="med"/>
-                    </a:lnL>
-                    <a:lnR w="3175" cap="flat" cmpd="sng" algn="ctr">
-                      <a:solidFill>
-                        <a:schemeClr val="bg1"/>
-                      </a:solidFill>
-                      <a:prstDash val="solid"/>
-                      <a:round/>
-                      <a:headEnd type="none" w="med" len="med"/>
-                      <a:tailEnd type="none" w="med" len="med"/>
-                    </a:lnR>
-                    <a:lnT w="3175" cap="flat" cmpd="sng" algn="ctr">
-                      <a:solidFill>
-                        <a:schemeClr val="bg1"/>
-                      </a:solidFill>
-                      <a:prstDash val="solid"/>
-                      <a:round/>
-                      <a:headEnd type="none" w="med" len="med"/>
-                      <a:tailEnd type="none" w="med" len="med"/>
-                    </a:lnT>
-                    <a:lnB w="3175" cap="flat" cmpd="sng" algn="ctr">
-                      <a:solidFill>
-                        <a:schemeClr val="bg1"/>
-                      </a:solidFill>
-                      <a:prstDash val="solid"/>
-                      <a:round/>
-                      <a:headEnd type="none" w="med" len="med"/>
-                      <a:tailEnd type="none" w="med" len="med"/>
-                    </a:lnB>
-                    <a:lnTlToBr w="12700" cmpd="sng">
-                      <a:noFill/>
-                      <a:prstDash val="solid"/>
-                    </a:lnTlToBr>
-                    <a:lnBlToTr w="12700" cmpd="sng">
-                      <a:noFill/>
-                      <a:prstDash val="solid"/>
-                    </a:lnBlToTr>
-                    <a:solidFill>
-                      <a:schemeClr val="tx2"/>
-                    </a:solidFill>
-                  </a:tcPr>
-                </a:tc>
-                <a:tc gridSpan="3">
-                  <a:txBody>
-                    <a:bodyPr/>
-                    <a:lstStyle/>
-                    <a:p>
-                      <a:pPr algn="l">
-                        <a:lnSpc>
-                          <a:spcPts val="1300"/>
-                        </a:lnSpc>
-                      </a:pPr>
-                      <a:r>
-                        <a:rPr kumimoji="0" lang="en-US" sz="600" b="0" i="0" u="none" strike="noStrike" kern="1200" cap="none" spc="0" normalizeH="0" baseline="0" noProof="0" dirty="0">
-                          <a:ln>
-                            <a:noFill/>
-                          </a:ln>
-                          <a:solidFill>
-                            <a:srgbClr val="FFFFFF"/>
-                          </a:solidFill>
-                          <a:effectLst/>
-                          <a:uLnTx/>
-                          <a:uFillTx/>
-                          <a:latin typeface="Fund Regular" pitchFamily="2" charset="-78"/>
-                          <a:ea typeface="+mn-ea"/>
-                          <a:cs typeface="Fund Regular" pitchFamily="2" charset="-78"/>
-                        </a:rPr>
-                        <a:t>END DATE: MMMM-YYYY</a:t>
-                      </a:r>
-                      <a:endParaRPr lang="en-US" sz="600" dirty="0">
-                        <a:solidFill>
-                          <a:schemeClr val="bg1"/>
-                        </a:solidFill>
-                        <a:latin typeface="Sakkal Majalla" panose="02000000000000000000" pitchFamily="2" charset="-78"/>
-                        <a:cs typeface="Sakkal Majalla" panose="02000000000000000000" pitchFamily="2" charset="-78"/>
-                      </a:endParaRPr>
-                    </a:p>
-                  </a:txBody>
-                  <a:tcPr marL="36000" marR="36000" marT="0" marB="0" anchor="ctr">
-                    <a:lnL w="3175" cap="flat" cmpd="sng" algn="ctr">
-                      <a:solidFill>
-                        <a:schemeClr val="bg1"/>
-                      </a:solidFill>
-                      <a:prstDash val="solid"/>
-                      <a:round/>
-                      <a:headEnd type="none" w="med" len="med"/>
-                      <a:tailEnd type="none" w="med" len="med"/>
-                    </a:lnL>
-                    <a:lnR w="3175" cap="flat" cmpd="sng" algn="ctr">
-                      <a:solidFill>
-                        <a:schemeClr val="bg1"/>
-                      </a:solidFill>
-                      <a:prstDash val="solid"/>
-                      <a:round/>
-                      <a:headEnd type="none" w="med" len="med"/>
-                      <a:tailEnd type="none" w="med" len="med"/>
-                    </a:lnR>
-                    <a:lnT w="3175" cap="flat" cmpd="sng" algn="ctr">
-                      <a:solidFill>
-                        <a:schemeClr val="bg1"/>
-                      </a:solidFill>
-                      <a:prstDash val="solid"/>
-                      <a:round/>
-                      <a:headEnd type="none" w="med" len="med"/>
-                      <a:tailEnd type="none" w="med" len="med"/>
-                    </a:lnT>
-                    <a:lnB w="3175" cap="flat" cmpd="sng" algn="ctr">
-                      <a:solidFill>
-                        <a:schemeClr val="bg1"/>
-                      </a:solidFill>
-                      <a:prstDash val="solid"/>
-                      <a:round/>
-                      <a:headEnd type="none" w="med" len="med"/>
-                      <a:tailEnd type="none" w="med" len="med"/>
-                    </a:lnB>
-                    <a:lnTlToBr w="12700" cmpd="sng">
-                      <a:noFill/>
-                      <a:prstDash val="solid"/>
-                    </a:lnTlToBr>
-                    <a:lnBlToTr w="12700" cmpd="sng">
-                      <a:noFill/>
-                      <a:prstDash val="solid"/>
-                    </a:lnBlToTr>
-                    <a:solidFill>
-                      <a:schemeClr val="tx2"/>
-                    </a:solidFill>
-                  </a:tcPr>
-                </a:tc>
-                <a:tc hMerge="1">
-                  <a:txBody>
-                    <a:bodyPr/>
-                    <a:lstStyle/>
-                    <a:p>
-                      <a:pPr>
-                        <a:lnSpc>
-                          <a:spcPts val="1300"/>
-                        </a:lnSpc>
-                      </a:pPr>
-                      <a:endParaRPr lang="en-US" sz="1200" dirty="0">
-                        <a:solidFill>
-                          <a:schemeClr val="bg1"/>
-                        </a:solidFill>
-                        <a:latin typeface="Sakkal Majalla" panose="02000000000000000000" pitchFamily="2" charset="-78"/>
-                        <a:cs typeface="Sakkal Majalla" panose="02000000000000000000" pitchFamily="2" charset="-78"/>
-                      </a:endParaRPr>
-                    </a:p>
-                  </a:txBody>
-                  <a:tcPr marL="36000" marR="36000" marT="0" marB="0" anchor="ctr">
-                    <a:lnL w="3175" cap="flat" cmpd="sng" algn="ctr">
-                      <a:solidFill>
-                        <a:schemeClr val="bg1"/>
-                      </a:solidFill>
-                      <a:prstDash val="solid"/>
-                      <a:round/>
-                      <a:headEnd type="none" w="med" len="med"/>
-                      <a:tailEnd type="none" w="med" len="med"/>
-                    </a:lnL>
-                    <a:lnR w="3175" cap="flat" cmpd="sng" algn="ctr">
-                      <a:solidFill>
-                        <a:schemeClr val="bg1"/>
-                      </a:solidFill>
-                      <a:prstDash val="solid"/>
-                      <a:round/>
-                      <a:headEnd type="none" w="med" len="med"/>
-                      <a:tailEnd type="none" w="med" len="med"/>
-                    </a:lnR>
-                    <a:lnT w="3175" cap="flat" cmpd="sng" algn="ctr">
-                      <a:solidFill>
-                        <a:schemeClr val="bg1"/>
-                      </a:solidFill>
-                      <a:prstDash val="solid"/>
-                      <a:round/>
-                      <a:headEnd type="none" w="med" len="med"/>
-                      <a:tailEnd type="none" w="med" len="med"/>
-                    </a:lnT>
-                    <a:lnB w="3175" cap="flat" cmpd="sng" algn="ctr">
-                      <a:solidFill>
-                        <a:schemeClr val="bg1"/>
-                      </a:solidFill>
-                      <a:prstDash val="solid"/>
-                      <a:round/>
-                      <a:headEnd type="none" w="med" len="med"/>
-                      <a:tailEnd type="none" w="med" len="med"/>
-                    </a:lnB>
-                    <a:lnTlToBr w="12700" cmpd="sng">
-                      <a:noFill/>
-                      <a:prstDash val="solid"/>
-                    </a:lnTlToBr>
-                    <a:lnBlToTr w="12700" cmpd="sng">
-                      <a:noFill/>
-                      <a:prstDash val="solid"/>
-                    </a:lnBlToTr>
-                    <a:solidFill>
-                      <a:schemeClr val="tx2"/>
-                    </a:solidFill>
-                  </a:tcPr>
-                </a:tc>
-                <a:tc hMerge="1">
-                  <a:txBody>
-                    <a:bodyPr/>
-                    <a:lstStyle/>
-                    <a:p>
-                      <a:pPr>
-                        <a:lnSpc>
-                          <a:spcPts val="1300"/>
-                        </a:lnSpc>
-                      </a:pPr>
-                      <a:endParaRPr lang="en-US" sz="1200" dirty="0">
-                        <a:solidFill>
-                          <a:schemeClr val="bg1"/>
-                        </a:solidFill>
-                        <a:latin typeface="Sakkal Majalla" panose="02000000000000000000" pitchFamily="2" charset="-78"/>
-                        <a:cs typeface="Sakkal Majalla" panose="02000000000000000000" pitchFamily="2" charset="-78"/>
-                      </a:endParaRPr>
-                    </a:p>
-                  </a:txBody>
-                  <a:tcPr marL="36000" marR="36000" marT="0" marB="0" anchor="ctr">
-                    <a:lnL w="3175" cap="flat" cmpd="sng" algn="ctr">
-                      <a:solidFill>
-                        <a:schemeClr val="bg1"/>
-                      </a:solidFill>
-                      <a:prstDash val="solid"/>
-                      <a:round/>
-                      <a:headEnd type="none" w="med" len="med"/>
-                      <a:tailEnd type="none" w="med" len="med"/>
-                    </a:lnL>
-                    <a:lnR w="3175" cap="flat" cmpd="sng" algn="ctr">
-                      <a:solidFill>
-                        <a:schemeClr val="bg1"/>
-                      </a:solidFill>
-                      <a:prstDash val="solid"/>
-                      <a:round/>
-                      <a:headEnd type="none" w="med" len="med"/>
-                      <a:tailEnd type="none" w="med" len="med"/>
-                    </a:lnR>
-                    <a:lnT w="3175" cap="flat" cmpd="sng" algn="ctr">
-                      <a:solidFill>
-                        <a:schemeClr val="bg1"/>
-                      </a:solidFill>
-                      <a:prstDash val="solid"/>
-                      <a:round/>
-                      <a:headEnd type="none" w="med" len="med"/>
-                      <a:tailEnd type="none" w="med" len="med"/>
-                    </a:lnT>
-                    <a:lnB w="3175" cap="flat" cmpd="sng" algn="ctr">
-                      <a:solidFill>
-                        <a:schemeClr val="bg1"/>
-                      </a:solidFill>
-                      <a:prstDash val="solid"/>
-                      <a:round/>
-                      <a:headEnd type="none" w="med" len="med"/>
-                      <a:tailEnd type="none" w="med" len="med"/>
-                    </a:lnB>
-                    <a:lnTlToBr w="12700" cmpd="sng">
-                      <a:noFill/>
-                      <a:prstDash val="solid"/>
-                    </a:lnTlToBr>
-                    <a:lnBlToTr w="12700" cmpd="sng">
-                      <a:noFill/>
-                      <a:prstDash val="solid"/>
-                    </a:lnBlToTr>
-                    <a:solidFill>
-                      <a:schemeClr val="tx2"/>
-                    </a:solidFill>
-                  </a:tcPr>
-                </a:tc>
-                <a:extLst>
-                  <a:ext uri="{0D108BD9-81ED-4DB2-BD59-A6C34878D82A}">
-                    <a16:rowId xmlns:a16="http://schemas.microsoft.com/office/drawing/2014/main" val="3944166192"/>
-                  </a:ext>
-                </a:extLst>
-              </a:tr>
-              <a:tr h="142016">
-                <a:tc>
-                  <a:txBody>
-                    <a:bodyPr/>
-                    <a:lstStyle/>
-                    <a:p>
-                      <a:pPr algn="l">
-                        <a:lnSpc>
-                          <a:spcPts val="1200"/>
-                        </a:lnSpc>
-                      </a:pPr>
-                      <a:r>
-                        <a:rPr lang="en-US" sz="600" b="0" i="0" dirty="0">
-                          <a:solidFill>
-                            <a:schemeClr val="tx2"/>
-                          </a:solidFill>
-                          <a:latin typeface="Fund Regular" pitchFamily="2" charset="-78"/>
-                          <a:cs typeface="Fund Regular" pitchFamily="2" charset="-78"/>
-                        </a:rPr>
-                        <a:t>NAME</a:t>
-                      </a:r>
-                    </a:p>
-                  </a:txBody>
-                  <a:tcPr marL="36000" marR="36000" marT="0" marB="0" anchor="ctr">
-                    <a:lnL w="12700" cap="flat" cmpd="sng" algn="ctr">
-                      <a:noFill/>
-                      <a:prstDash val="solid"/>
-                      <a:round/>
-                      <a:headEnd type="none" w="med" len="med"/>
-                      <a:tailEnd type="none" w="med" len="med"/>
-                    </a:lnL>
-                    <a:lnR w="12700" cap="flat" cmpd="sng" algn="ctr">
-                      <a:noFill/>
-                      <a:prstDash val="solid"/>
-                      <a:round/>
-                      <a:headEnd type="none" w="med" len="med"/>
-                      <a:tailEnd type="none" w="med" len="med"/>
-                    </a:lnR>
-                    <a:lnT w="3175" cap="flat" cmpd="sng" algn="ctr">
-                      <a:solidFill>
-                        <a:schemeClr val="bg1"/>
-                      </a:solidFill>
-                      <a:prstDash val="solid"/>
-                      <a:round/>
-                      <a:headEnd type="none" w="med" len="med"/>
-                      <a:tailEnd type="none" w="med" len="med"/>
-                    </a:lnT>
-                    <a:lnB w="6350" cap="flat" cmpd="sng" algn="ctr">
-                      <a:solidFill>
-                        <a:schemeClr val="bg1">
-                          <a:lumMod val="85000"/>
-                        </a:schemeClr>
-                      </a:solidFill>
-                      <a:prstDash val="solid"/>
-                      <a:round/>
-                      <a:headEnd type="none" w="med" len="med"/>
-                      <a:tailEnd type="none" w="med" len="med"/>
-                    </a:lnB>
-                    <a:lnTlToBr w="12700" cmpd="sng">
-                      <a:noFill/>
-                      <a:prstDash val="solid"/>
-                    </a:lnTlToBr>
-                    <a:lnBlToTr w="12700" cmpd="sng">
-                      <a:noFill/>
-                      <a:prstDash val="solid"/>
-                    </a:lnBlToTr>
-                    <a:solidFill>
-                      <a:schemeClr val="bg1">
-                        <a:lumMod val="95000"/>
-                      </a:schemeClr>
-                    </a:solidFill>
-                  </a:tcPr>
-                </a:tc>
-                <a:tc>
-                  <a:txBody>
-                    <a:bodyPr/>
-                    <a:lstStyle/>
-                    <a:p>
-                      <a:pPr algn="l">
-                        <a:lnSpc>
-                          <a:spcPts val="1200"/>
-                        </a:lnSpc>
-                      </a:pPr>
-                      <a:r>
-                        <a:rPr lang="en-US" sz="600" b="0" i="0" dirty="0">
-                          <a:solidFill>
-                            <a:schemeClr val="tx2"/>
-                          </a:solidFill>
-                          <a:latin typeface="Fund Regular" pitchFamily="2" charset="-78"/>
-                          <a:cs typeface="Fund Regular" pitchFamily="2" charset="-78"/>
-                        </a:rPr>
-                        <a:t>PIF EMPLOYEE</a:t>
-                      </a:r>
-                    </a:p>
-                  </a:txBody>
-                  <a:tcPr marL="36000" marR="36000" marT="0" marB="0" anchor="ctr">
-                    <a:lnL w="12700" cap="flat" cmpd="sng" algn="ctr">
-                      <a:noFill/>
-                      <a:prstDash val="solid"/>
-                      <a:round/>
-                      <a:headEnd type="none" w="med" len="med"/>
-                      <a:tailEnd type="none" w="med" len="med"/>
-                    </a:lnL>
-                    <a:lnR w="12700" cap="flat" cmpd="sng" algn="ctr">
-                      <a:noFill/>
-                      <a:prstDash val="solid"/>
-                      <a:round/>
-                      <a:headEnd type="none" w="med" len="med"/>
-                      <a:tailEnd type="none" w="med" len="med"/>
-                    </a:lnR>
-                    <a:lnT w="3175" cap="flat" cmpd="sng" algn="ctr">
-                      <a:solidFill>
-                        <a:schemeClr val="bg1"/>
-                      </a:solidFill>
-                      <a:prstDash val="solid"/>
-                      <a:round/>
-                      <a:headEnd type="none" w="med" len="med"/>
-                      <a:tailEnd type="none" w="med" len="med"/>
-                    </a:lnT>
-                    <a:lnB w="6350" cap="flat" cmpd="sng" algn="ctr">
-                      <a:solidFill>
-                        <a:schemeClr val="bg1">
-                          <a:lumMod val="85000"/>
-                        </a:schemeClr>
-                      </a:solidFill>
-                      <a:prstDash val="solid"/>
-                      <a:round/>
-                      <a:headEnd type="none" w="med" len="med"/>
-                      <a:tailEnd type="none" w="med" len="med"/>
-                    </a:lnB>
-                    <a:lnTlToBr w="12700" cmpd="sng">
-                      <a:noFill/>
-                      <a:prstDash val="solid"/>
-                    </a:lnTlToBr>
-                    <a:lnBlToTr w="12700" cmpd="sng">
-                      <a:noFill/>
-                      <a:prstDash val="solid"/>
-                    </a:lnBlToTr>
-                    <a:solidFill>
-                      <a:schemeClr val="bg1">
-                        <a:lumMod val="95000"/>
-                      </a:schemeClr>
-                    </a:solidFill>
-                  </a:tcPr>
-                </a:tc>
-                <a:tc>
-                  <a:txBody>
-                    <a:bodyPr/>
-                    <a:lstStyle/>
-                    <a:p>
-                      <a:pPr algn="l">
-                        <a:lnSpc>
-                          <a:spcPts val="1200"/>
-                        </a:lnSpc>
-                      </a:pPr>
-                      <a:r>
-                        <a:rPr lang="en-US" sz="600" b="0" i="0" dirty="0">
-                          <a:solidFill>
-                            <a:schemeClr val="tx2"/>
-                          </a:solidFill>
-                          <a:latin typeface="Fund Regular" pitchFamily="2" charset="-78"/>
-                          <a:cs typeface="Fund Regular" pitchFamily="2" charset="-78"/>
-                        </a:rPr>
-                        <a:t>OTHER PIF REP.</a:t>
-                      </a:r>
-                    </a:p>
-                  </a:txBody>
-                  <a:tcPr marL="36000" marR="36000" marT="0" marB="0" anchor="ctr">
-                    <a:lnL w="12700" cap="flat" cmpd="sng" algn="ctr">
-                      <a:noFill/>
-                      <a:prstDash val="solid"/>
-                      <a:round/>
-                      <a:headEnd type="none" w="med" len="med"/>
-                      <a:tailEnd type="none" w="med" len="med"/>
-                    </a:lnL>
-                    <a:lnR w="12700" cap="flat" cmpd="sng" algn="ctr">
-                      <a:noFill/>
-                      <a:prstDash val="solid"/>
-                      <a:round/>
-                      <a:headEnd type="none" w="med" len="med"/>
-                      <a:tailEnd type="none" w="med" len="med"/>
-                    </a:lnR>
-                    <a:lnT w="3175" cap="flat" cmpd="sng" algn="ctr">
-                      <a:solidFill>
-                        <a:schemeClr val="bg1"/>
-                      </a:solidFill>
-                      <a:prstDash val="solid"/>
-                      <a:round/>
-                      <a:headEnd type="none" w="med" len="med"/>
-                      <a:tailEnd type="none" w="med" len="med"/>
-                    </a:lnT>
-                    <a:lnB w="6350" cap="flat" cmpd="sng" algn="ctr">
-                      <a:solidFill>
-                        <a:schemeClr val="bg1">
-                          <a:lumMod val="85000"/>
-                        </a:schemeClr>
-                      </a:solidFill>
-                      <a:prstDash val="solid"/>
-                      <a:round/>
-                      <a:headEnd type="none" w="med" len="med"/>
-                      <a:tailEnd type="none" w="med" len="med"/>
-                    </a:lnB>
-                    <a:lnTlToBr w="12700" cmpd="sng">
-                      <a:noFill/>
-                      <a:prstDash val="solid"/>
-                    </a:lnTlToBr>
-                    <a:lnBlToTr w="12700" cmpd="sng">
-                      <a:noFill/>
-                      <a:prstDash val="solid"/>
-                    </a:lnBlToTr>
-                    <a:solidFill>
-                      <a:schemeClr val="bg1">
-                        <a:lumMod val="95000"/>
-                      </a:schemeClr>
-                    </a:solidFill>
-                  </a:tcPr>
-                </a:tc>
-                <a:tc>
-                  <a:txBody>
-                    <a:bodyPr/>
-                    <a:lstStyle/>
-                    <a:p>
-                      <a:pPr algn="l">
-                        <a:lnSpc>
-                          <a:spcPts val="1200"/>
-                        </a:lnSpc>
-                      </a:pPr>
-                      <a:r>
-                        <a:rPr lang="en-US" sz="600" b="0" i="0" dirty="0">
-                          <a:solidFill>
-                            <a:schemeClr val="tx2"/>
-                          </a:solidFill>
-                          <a:latin typeface="Fund Regular" pitchFamily="2" charset="-78"/>
-                          <a:cs typeface="Fund Regular" pitchFamily="2" charset="-78"/>
-                        </a:rPr>
-                        <a:t>BOARD</a:t>
-                      </a:r>
-                    </a:p>
-                  </a:txBody>
-                  <a:tcPr marL="36000" marR="36000" marT="0" marB="0" anchor="ctr">
-                    <a:lnL w="12700" cmpd="sng">
-                      <a:noFill/>
-                    </a:lnL>
-                    <a:lnR w="12700" cap="flat" cmpd="sng" algn="ctr">
-                      <a:noFill/>
-                      <a:prstDash val="solid"/>
-                      <a:round/>
-                      <a:headEnd type="none" w="med" len="med"/>
-                      <a:tailEnd type="none" w="med" len="med"/>
-                    </a:lnR>
-                    <a:lnT w="3175" cap="flat" cmpd="sng" algn="ctr">
-                      <a:solidFill>
-                        <a:schemeClr val="bg1"/>
-                      </a:solidFill>
-                      <a:prstDash val="solid"/>
-                      <a:round/>
-                      <a:headEnd type="none" w="med" len="med"/>
-                      <a:tailEnd type="none" w="med" len="med"/>
-                    </a:lnT>
-                    <a:lnB w="6350" cap="flat" cmpd="sng" algn="ctr">
-                      <a:solidFill>
-                        <a:schemeClr val="bg1">
-                          <a:lumMod val="85000"/>
-                        </a:schemeClr>
-                      </a:solidFill>
-                      <a:prstDash val="solid"/>
-                      <a:round/>
-                      <a:headEnd type="none" w="med" len="med"/>
-                      <a:tailEnd type="none" w="med" len="med"/>
-                    </a:lnB>
-                    <a:lnTlToBr w="12700" cmpd="sng">
-                      <a:noFill/>
-                      <a:prstDash val="solid"/>
-                    </a:lnTlToBr>
-                    <a:lnBlToTr w="12700" cmpd="sng">
-                      <a:noFill/>
-                      <a:prstDash val="solid"/>
-                    </a:lnBlToTr>
-                    <a:solidFill>
-                      <a:schemeClr val="bg1">
-                        <a:lumMod val="95000"/>
-                      </a:schemeClr>
-                    </a:solidFill>
-                  </a:tcPr>
-                </a:tc>
-                <a:tc>
-                  <a:txBody>
-                    <a:bodyPr/>
-                    <a:lstStyle/>
-                    <a:p>
-                      <a:pPr algn="l">
-                        <a:lnSpc>
-                          <a:spcPts val="1200"/>
-                        </a:lnSpc>
-                      </a:pPr>
-                      <a:r>
-                        <a:rPr lang="en-US" sz="600" b="0" i="0" dirty="0">
-                          <a:solidFill>
-                            <a:schemeClr val="tx2"/>
-                          </a:solidFill>
-                          <a:latin typeface="Fund Regular" pitchFamily="2" charset="-78"/>
-                          <a:cs typeface="Fund Regular" pitchFamily="2" charset="-78"/>
-                        </a:rPr>
-                        <a:t>EXCOM</a:t>
-                      </a:r>
-                    </a:p>
-                  </a:txBody>
-                  <a:tcPr marL="36000" marR="36000" marT="0" marB="0" anchor="ctr">
-                    <a:lnL w="12700" cap="flat" cmpd="sng" algn="ctr">
-                      <a:noFill/>
-                      <a:prstDash val="solid"/>
-                      <a:round/>
-                      <a:headEnd type="none" w="med" len="med"/>
-                      <a:tailEnd type="none" w="med" len="med"/>
-                    </a:lnL>
-                    <a:lnR w="12700" cap="flat" cmpd="sng" algn="ctr">
-                      <a:noFill/>
-                      <a:prstDash val="solid"/>
-                      <a:round/>
-                      <a:headEnd type="none" w="med" len="med"/>
-                      <a:tailEnd type="none" w="med" len="med"/>
-                    </a:lnR>
-                    <a:lnT w="3175" cap="flat" cmpd="sng" algn="ctr">
-                      <a:solidFill>
-                        <a:schemeClr val="bg1"/>
-                      </a:solidFill>
-                      <a:prstDash val="solid"/>
-                      <a:round/>
-                      <a:headEnd type="none" w="med" len="med"/>
-                      <a:tailEnd type="none" w="med" len="med"/>
-                    </a:lnT>
-                    <a:lnB w="6350" cap="flat" cmpd="sng" algn="ctr">
-                      <a:solidFill>
-                        <a:schemeClr val="bg1">
-                          <a:lumMod val="85000"/>
-                        </a:schemeClr>
-                      </a:solidFill>
-                      <a:prstDash val="solid"/>
-                      <a:round/>
-                      <a:headEnd type="none" w="med" len="med"/>
-                      <a:tailEnd type="none" w="med" len="med"/>
-                    </a:lnB>
-                    <a:lnTlToBr w="12700" cmpd="sng">
-                      <a:noFill/>
-                      <a:prstDash val="solid"/>
-                    </a:lnTlToBr>
-                    <a:lnBlToTr w="12700" cmpd="sng">
-                      <a:noFill/>
-                      <a:prstDash val="solid"/>
-                    </a:lnBlToTr>
-                    <a:solidFill>
-                      <a:schemeClr val="bg1">
-                        <a:lumMod val="95000"/>
-                      </a:schemeClr>
-                    </a:solidFill>
-                  </a:tcPr>
-                </a:tc>
-                <a:tc>
-                  <a:txBody>
-                    <a:bodyPr/>
-                    <a:lstStyle/>
-                    <a:p>
-                      <a:pPr algn="l">
-                        <a:lnSpc>
-                          <a:spcPts val="1200"/>
-                        </a:lnSpc>
-                      </a:pPr>
-                      <a:r>
-                        <a:rPr lang="en-US" sz="600" b="0" i="0" dirty="0">
-                          <a:solidFill>
-                            <a:schemeClr val="tx2"/>
-                          </a:solidFill>
-                          <a:latin typeface="Fund Regular" pitchFamily="2" charset="-78"/>
-                          <a:cs typeface="Fund Regular" pitchFamily="2" charset="-78"/>
-                        </a:rPr>
-                        <a:t>AUDIT</a:t>
-                      </a:r>
-                    </a:p>
-                  </a:txBody>
-                  <a:tcPr marL="36000" marR="36000" marT="0" marB="0" anchor="ctr">
-                    <a:lnL w="12700" cap="flat" cmpd="sng" algn="ctr">
-                      <a:noFill/>
-                      <a:prstDash val="solid"/>
-                      <a:round/>
-                      <a:headEnd type="none" w="med" len="med"/>
-                      <a:tailEnd type="none" w="med" len="med"/>
-                    </a:lnL>
-                    <a:lnR w="12700" cap="flat" cmpd="sng" algn="ctr">
-                      <a:noFill/>
-                      <a:prstDash val="solid"/>
-                      <a:round/>
-                      <a:headEnd type="none" w="med" len="med"/>
-                      <a:tailEnd type="none" w="med" len="med"/>
-                    </a:lnR>
-                    <a:lnT w="3175" cap="flat" cmpd="sng" algn="ctr">
-                      <a:solidFill>
-                        <a:schemeClr val="bg1"/>
-                      </a:solidFill>
-                      <a:prstDash val="solid"/>
-                      <a:round/>
-                      <a:headEnd type="none" w="med" len="med"/>
-                      <a:tailEnd type="none" w="med" len="med"/>
-                    </a:lnT>
-                    <a:lnB w="6350" cap="flat" cmpd="sng" algn="ctr">
-                      <a:solidFill>
-                        <a:schemeClr val="bg1">
-                          <a:lumMod val="85000"/>
-                        </a:schemeClr>
-                      </a:solidFill>
-                      <a:prstDash val="solid"/>
-                      <a:round/>
-                      <a:headEnd type="none" w="med" len="med"/>
-                      <a:tailEnd type="none" w="med" len="med"/>
-                    </a:lnB>
-                    <a:lnTlToBr w="12700" cmpd="sng">
-                      <a:noFill/>
-                      <a:prstDash val="solid"/>
-                    </a:lnTlToBr>
-                    <a:lnBlToTr w="12700" cmpd="sng">
-                      <a:noFill/>
-                      <a:prstDash val="solid"/>
-                    </a:lnBlToTr>
-                    <a:solidFill>
-                      <a:schemeClr val="bg1">
-                        <a:lumMod val="95000"/>
-                      </a:schemeClr>
-                    </a:solidFill>
-                  </a:tcPr>
-                </a:tc>
-                <a:tc>
-                  <a:txBody>
-                    <a:bodyPr/>
-                    <a:lstStyle/>
-                    <a:p>
-                      <a:pPr algn="l">
-                        <a:lnSpc>
-                          <a:spcPts val="1200"/>
-                        </a:lnSpc>
-                      </a:pPr>
-                      <a:r>
-                        <a:rPr lang="en-US" sz="600" b="0" i="0" dirty="0">
-                          <a:solidFill>
-                            <a:schemeClr val="tx2"/>
-                          </a:solidFill>
-                          <a:latin typeface="Fund Regular" pitchFamily="2" charset="-78"/>
-                          <a:cs typeface="Fund Regular" pitchFamily="2" charset="-78"/>
-                        </a:rPr>
-                        <a:t>NRC</a:t>
-                      </a:r>
-                    </a:p>
-                  </a:txBody>
-                  <a:tcPr marL="36000" marR="36000" marT="0" marB="0" anchor="ctr">
-                    <a:lnL w="12700" cap="flat" cmpd="sng" algn="ctr">
-                      <a:noFill/>
-                      <a:prstDash val="solid"/>
-                      <a:round/>
-                      <a:headEnd type="none" w="med" len="med"/>
-                      <a:tailEnd type="none" w="med" len="med"/>
-                    </a:lnL>
-                    <a:lnR w="12700" cap="flat" cmpd="sng" algn="ctr">
-                      <a:noFill/>
-                      <a:prstDash val="solid"/>
-                      <a:round/>
-                      <a:headEnd type="none" w="med" len="med"/>
-                      <a:tailEnd type="none" w="med" len="med"/>
-                    </a:lnR>
-                    <a:lnT w="3175" cap="flat" cmpd="sng" algn="ctr">
-                      <a:solidFill>
-                        <a:schemeClr val="bg1"/>
-                      </a:solidFill>
-                      <a:prstDash val="solid"/>
-                      <a:round/>
-                      <a:headEnd type="none" w="med" len="med"/>
-                      <a:tailEnd type="none" w="med" len="med"/>
-                    </a:lnT>
-                    <a:lnB w="6350" cap="flat" cmpd="sng" algn="ctr">
-                      <a:solidFill>
-                        <a:schemeClr val="bg1">
-                          <a:lumMod val="85000"/>
-                        </a:schemeClr>
-                      </a:solidFill>
-                      <a:prstDash val="solid"/>
-                      <a:round/>
-                      <a:headEnd type="none" w="med" len="med"/>
-                      <a:tailEnd type="none" w="med" len="med"/>
-                    </a:lnB>
-                    <a:lnTlToBr w="12700" cmpd="sng">
-                      <a:noFill/>
-                      <a:prstDash val="solid"/>
-                    </a:lnTlToBr>
-                    <a:lnBlToTr w="12700" cmpd="sng">
-                      <a:noFill/>
-                      <a:prstDash val="solid"/>
-                    </a:lnBlToTr>
-                    <a:solidFill>
-                      <a:schemeClr val="bg1">
-                        <a:lumMod val="95000"/>
-                      </a:schemeClr>
-                    </a:solidFill>
-                  </a:tcPr>
-                </a:tc>
-                <a:extLst>
-                  <a:ext uri="{0D108BD9-81ED-4DB2-BD59-A6C34878D82A}">
-                    <a16:rowId xmlns:a16="http://schemas.microsoft.com/office/drawing/2014/main" val="2147178351"/>
-                  </a:ext>
-                </a:extLst>
-              </a:tr>
-              <a:tr h="132304">
-                <a:tc>
-                  <a:txBody>
-                    <a:bodyPr/>
-                    <a:lstStyle/>
-                    <a:p>
-                      <a:pPr algn="l">
-                        <a:lnSpc>
-                          <a:spcPts val="1200"/>
-                        </a:lnSpc>
-                      </a:pPr>
-                      <a:r>
-                        <a:rPr lang="en-US" sz="600" b="0" i="0" dirty="0">
-                          <a:solidFill>
-                            <a:schemeClr val="tx1"/>
-                          </a:solidFill>
-                          <a:latin typeface="Fund Light" pitchFamily="2" charset="-78"/>
-                          <a:cs typeface="Fund Light" pitchFamily="2" charset="-78"/>
-                        </a:rPr>
-                        <a:t>Member #1</a:t>
-                      </a:r>
-                    </a:p>
-                  </a:txBody>
-                  <a:tcPr marL="36000" marR="36000" marT="0" marB="0" anchor="ctr">
-                    <a:lnL w="12700" cap="flat" cmpd="sng" algn="ctr">
-                      <a:noFill/>
-                      <a:prstDash val="solid"/>
-                      <a:round/>
-                      <a:headEnd type="none" w="med" len="med"/>
-                      <a:tailEnd type="none" w="med" len="med"/>
-                    </a:lnL>
-                    <a:lnR w="12700" cap="flat" cmpd="sng" algn="ctr">
-                      <a:noFill/>
-                      <a:prstDash val="solid"/>
-                      <a:round/>
-                      <a:headEnd type="none" w="med" len="med"/>
-                      <a:tailEnd type="none" w="med" len="med"/>
-                    </a:lnR>
-                    <a:lnT w="6350" cap="flat" cmpd="sng" algn="ctr">
-                      <a:solidFill>
-                        <a:schemeClr val="bg1">
-                          <a:lumMod val="85000"/>
-                        </a:schemeClr>
-                      </a:solidFill>
-                      <a:prstDash val="solid"/>
-                      <a:round/>
-                      <a:headEnd type="none" w="med" len="med"/>
-                      <a:tailEnd type="none" w="med" len="med"/>
-                    </a:lnT>
-                    <a:lnB w="6350" cap="flat" cmpd="sng" algn="ctr">
-                      <a:solidFill>
-                        <a:schemeClr val="bg1">
-                          <a:lumMod val="85000"/>
-                        </a:schemeClr>
-                      </a:solidFill>
-                      <a:prstDash val="solid"/>
-                      <a:round/>
-                      <a:headEnd type="none" w="med" len="med"/>
-                      <a:tailEnd type="none" w="med" len="med"/>
-                    </a:lnB>
-                    <a:lnTlToBr w="12700" cmpd="sng">
-                      <a:noFill/>
-                      <a:prstDash val="solid"/>
-                    </a:lnTlToBr>
-                    <a:lnBlToTr w="12700" cmpd="sng">
-                      <a:noFill/>
-                      <a:prstDash val="solid"/>
-                    </a:lnBlToTr>
-                    <a:noFill/>
-                  </a:tcPr>
-                </a:tc>
-                <a:tc>
-                  <a:txBody>
-                    <a:bodyPr/>
-                    <a:lstStyle/>
-                    <a:p>
-                      <a:pPr algn="l">
-                        <a:lnSpc>
-                          <a:spcPts val="1200"/>
-                        </a:lnSpc>
-                      </a:pPr>
-                      <a:r>
-                        <a:rPr lang="en-US" sz="600" b="0" i="0" dirty="0">
-                          <a:solidFill>
-                            <a:schemeClr val="tx1"/>
-                          </a:solidFill>
-                          <a:latin typeface="Fund Light" pitchFamily="2" charset="-78"/>
-                          <a:cs typeface="Fund Light" pitchFamily="2" charset="-78"/>
-                        </a:rPr>
-                        <a:t>No</a:t>
-                      </a:r>
-                    </a:p>
-                  </a:txBody>
-                  <a:tcPr marL="36000" marR="36000" marT="0" marB="0" anchor="ctr">
-                    <a:lnL w="12700" cap="flat" cmpd="sng" algn="ctr">
-                      <a:noFill/>
-                      <a:prstDash val="solid"/>
-                      <a:round/>
-                      <a:headEnd type="none" w="med" len="med"/>
-                      <a:tailEnd type="none" w="med" len="med"/>
-                    </a:lnL>
-                    <a:lnR w="12700" cap="flat" cmpd="sng" algn="ctr">
-                      <a:noFill/>
-                      <a:prstDash val="solid"/>
-                      <a:round/>
-                      <a:headEnd type="none" w="med" len="med"/>
-                      <a:tailEnd type="none" w="med" len="med"/>
-                    </a:lnR>
-                    <a:lnT w="6350" cap="flat" cmpd="sng" algn="ctr">
-                      <a:solidFill>
-                        <a:schemeClr val="bg1">
-                          <a:lumMod val="85000"/>
-                        </a:schemeClr>
-                      </a:solidFill>
-                      <a:prstDash val="solid"/>
-                      <a:round/>
-                      <a:headEnd type="none" w="med" len="med"/>
-                      <a:tailEnd type="none" w="med" len="med"/>
-                    </a:lnT>
-                    <a:lnB w="6350" cap="flat" cmpd="sng" algn="ctr">
-                      <a:solidFill>
-                        <a:schemeClr val="bg1">
-                          <a:lumMod val="85000"/>
-                        </a:schemeClr>
-                      </a:solidFill>
-                      <a:prstDash val="solid"/>
-                      <a:round/>
-                      <a:headEnd type="none" w="med" len="med"/>
-                      <a:tailEnd type="none" w="med" len="med"/>
-                    </a:lnB>
-                    <a:lnTlToBr w="12700" cmpd="sng">
-                      <a:noFill/>
-                      <a:prstDash val="solid"/>
-                    </a:lnTlToBr>
-                    <a:lnBlToTr w="12700" cmpd="sng">
-                      <a:noFill/>
-                      <a:prstDash val="solid"/>
-                    </a:lnBlToTr>
-                    <a:noFill/>
-                  </a:tcPr>
-                </a:tc>
-                <a:tc>
-                  <a:txBody>
-                    <a:bodyPr/>
-                    <a:lstStyle/>
-                    <a:p>
-                      <a:pPr algn="l">
-                        <a:lnSpc>
-                          <a:spcPts val="1200"/>
-                        </a:lnSpc>
-                      </a:pPr>
-                      <a:r>
-                        <a:rPr lang="en-US" sz="600" b="0" i="0">
-                          <a:solidFill>
-                            <a:schemeClr val="tx1"/>
-                          </a:solidFill>
-                          <a:latin typeface="Fund Light" pitchFamily="2" charset="-78"/>
-                          <a:cs typeface="Fund Light" pitchFamily="2" charset="-78"/>
-                        </a:rPr>
-                        <a:t>Yes</a:t>
-                      </a:r>
-                      <a:endParaRPr lang="en-US" sz="600" b="0" i="0" dirty="0">
-                        <a:solidFill>
-                          <a:schemeClr val="tx1"/>
-                        </a:solidFill>
-                        <a:latin typeface="Fund Light" pitchFamily="2" charset="-78"/>
-                        <a:cs typeface="Fund Light" pitchFamily="2" charset="-78"/>
-                      </a:endParaRPr>
-                    </a:p>
-                  </a:txBody>
-                  <a:tcPr marL="36000" marR="36000" marT="0" marB="0" anchor="ctr">
-                    <a:lnL w="12700" cap="flat" cmpd="sng" algn="ctr">
-                      <a:noFill/>
-                      <a:prstDash val="solid"/>
-                      <a:round/>
-                      <a:headEnd type="none" w="med" len="med"/>
-                      <a:tailEnd type="none" w="med" len="med"/>
-                    </a:lnL>
-                    <a:lnR w="12700" cap="flat" cmpd="sng" algn="ctr">
-                      <a:noFill/>
-                      <a:prstDash val="solid"/>
-                      <a:round/>
-                      <a:headEnd type="none" w="med" len="med"/>
-                      <a:tailEnd type="none" w="med" len="med"/>
-                    </a:lnR>
-                    <a:lnT w="6350" cap="flat" cmpd="sng" algn="ctr">
-                      <a:solidFill>
-                        <a:schemeClr val="bg1">
-                          <a:lumMod val="85000"/>
-                        </a:schemeClr>
-                      </a:solidFill>
-                      <a:prstDash val="solid"/>
-                      <a:round/>
-                      <a:headEnd type="none" w="med" len="med"/>
-                      <a:tailEnd type="none" w="med" len="med"/>
-                    </a:lnT>
-                    <a:lnB w="6350" cap="flat" cmpd="sng" algn="ctr">
-                      <a:solidFill>
-                        <a:schemeClr val="bg1">
-                          <a:lumMod val="85000"/>
-                        </a:schemeClr>
-                      </a:solidFill>
-                      <a:prstDash val="solid"/>
-                      <a:round/>
-                      <a:headEnd type="none" w="med" len="med"/>
-                      <a:tailEnd type="none" w="med" len="med"/>
-                    </a:lnB>
-                    <a:lnTlToBr w="12700" cmpd="sng">
-                      <a:noFill/>
-                      <a:prstDash val="solid"/>
-                    </a:lnTlToBr>
-                    <a:lnBlToTr w="12700" cmpd="sng">
-                      <a:noFill/>
-                      <a:prstDash val="solid"/>
-                    </a:lnBlToTr>
-                    <a:noFill/>
-                  </a:tcPr>
-                </a:tc>
-                <a:tc>
-                  <a:txBody>
-                    <a:bodyPr/>
-                    <a:lstStyle/>
-                    <a:p>
-                      <a:pPr marL="0" algn="l" defTabSz="914400" rtl="0" eaLnBrk="1" latinLnBrk="0" hangingPunct="1">
-                        <a:lnSpc>
-                          <a:spcPts val="1200"/>
-                        </a:lnSpc>
-                      </a:pPr>
-                      <a:r>
-                        <a:rPr lang="en-US" sz="600" b="0" i="0" kern="1200" dirty="0">
-                          <a:solidFill>
-                            <a:schemeClr val="tx1"/>
-                          </a:solidFill>
-                          <a:latin typeface="Fund Light" pitchFamily="2" charset="-78"/>
-                          <a:ea typeface="+mn-ea"/>
-                          <a:cs typeface="Fund Light" pitchFamily="2" charset="-78"/>
-                        </a:rPr>
-                        <a:t>q</a:t>
-                      </a:r>
-                    </a:p>
-                  </a:txBody>
-                  <a:tcPr marL="36000" marR="36000" marT="0" marB="0" anchor="b">
-                    <a:lnL w="12700" cmpd="sng">
-                      <a:noFill/>
-                    </a:lnL>
-                    <a:lnR w="12700" cap="flat" cmpd="sng" algn="ctr">
-                      <a:noFill/>
-                      <a:prstDash val="solid"/>
-                      <a:round/>
-                      <a:headEnd type="none" w="med" len="med"/>
-                      <a:tailEnd type="none" w="med" len="med"/>
-                    </a:lnR>
-                    <a:lnT w="6350" cap="flat" cmpd="sng" algn="ctr">
-                      <a:solidFill>
-                        <a:schemeClr val="bg1">
-                          <a:lumMod val="85000"/>
-                        </a:schemeClr>
-                      </a:solidFill>
-                      <a:prstDash val="solid"/>
-                      <a:round/>
-                      <a:headEnd type="none" w="med" len="med"/>
-                      <a:tailEnd type="none" w="med" len="med"/>
-                    </a:lnT>
-                    <a:lnB w="6350" cap="flat" cmpd="sng" algn="ctr">
-                      <a:solidFill>
-                        <a:schemeClr val="bg1">
-                          <a:lumMod val="85000"/>
-                        </a:schemeClr>
-                      </a:solidFill>
-                      <a:prstDash val="solid"/>
-                      <a:round/>
-                      <a:headEnd type="none" w="med" len="med"/>
-                      <a:tailEnd type="none" w="med" len="med"/>
-                    </a:lnB>
-                    <a:lnTlToBr w="12700" cmpd="sng">
-                      <a:noFill/>
-                      <a:prstDash val="solid"/>
-                    </a:lnTlToBr>
-                    <a:lnBlToTr w="12700" cmpd="sng">
-                      <a:noFill/>
-                      <a:prstDash val="solid"/>
-                    </a:lnBlToTr>
-                    <a:noFill/>
-                  </a:tcPr>
-                </a:tc>
-                <a:tc>
-                  <a:txBody>
-                    <a:bodyPr/>
-                    <a:lstStyle/>
-                    <a:p>
-                      <a:pPr marL="0" algn="l" defTabSz="914400" rtl="0" eaLnBrk="1" latinLnBrk="0" hangingPunct="1">
-                        <a:lnSpc>
-                          <a:spcPts val="1200"/>
-                        </a:lnSpc>
-                      </a:pPr>
-                      <a:r>
-                        <a:rPr lang="en-US" sz="600" b="0" i="0" kern="1200" dirty="0">
-                          <a:solidFill>
-                            <a:schemeClr val="tx1"/>
-                          </a:solidFill>
-                          <a:latin typeface="Fund Light" pitchFamily="2" charset="-78"/>
-                          <a:ea typeface="+mn-ea"/>
-                          <a:cs typeface="Fund Light" pitchFamily="2" charset="-78"/>
-                        </a:rPr>
-                        <a:t>q</a:t>
-                      </a:r>
-                    </a:p>
-                  </a:txBody>
-                  <a:tcPr marL="36000" marR="36000" marT="0" marB="0" anchor="ctr">
-                    <a:lnL w="12700" cap="flat" cmpd="sng" algn="ctr">
-                      <a:noFill/>
-                      <a:prstDash val="solid"/>
-                      <a:round/>
-                      <a:headEnd type="none" w="med" len="med"/>
-                      <a:tailEnd type="none" w="med" len="med"/>
-                    </a:lnL>
-                    <a:lnR w="12700" cap="flat" cmpd="sng" algn="ctr">
-                      <a:noFill/>
-                      <a:prstDash val="solid"/>
-                      <a:round/>
-                      <a:headEnd type="none" w="med" len="med"/>
-                      <a:tailEnd type="none" w="med" len="med"/>
-                    </a:lnR>
-                    <a:lnT w="6350" cap="flat" cmpd="sng" algn="ctr">
-                      <a:solidFill>
-                        <a:schemeClr val="bg1">
-                          <a:lumMod val="85000"/>
-                        </a:schemeClr>
-                      </a:solidFill>
-                      <a:prstDash val="solid"/>
-                      <a:round/>
-                      <a:headEnd type="none" w="med" len="med"/>
-                      <a:tailEnd type="none" w="med" len="med"/>
-                    </a:lnT>
-                    <a:lnB w="6350" cap="flat" cmpd="sng" algn="ctr">
-                      <a:solidFill>
-                        <a:schemeClr val="bg1">
-                          <a:lumMod val="85000"/>
-                        </a:schemeClr>
-                      </a:solidFill>
-                      <a:prstDash val="solid"/>
-                      <a:round/>
-                      <a:headEnd type="none" w="med" len="med"/>
-                      <a:tailEnd type="none" w="med" len="med"/>
-                    </a:lnB>
-                    <a:lnTlToBr w="12700" cmpd="sng">
-                      <a:noFill/>
-                      <a:prstDash val="solid"/>
-                    </a:lnTlToBr>
-                    <a:lnBlToTr w="12700" cmpd="sng">
-                      <a:noFill/>
-                      <a:prstDash val="solid"/>
-                    </a:lnBlToTr>
-                    <a:noFill/>
-                  </a:tcPr>
-                </a:tc>
-                <a:tc>
-                  <a:txBody>
-                    <a:bodyPr/>
-                    <a:lstStyle/>
-                    <a:p>
-                      <a:pPr marL="0" algn="l" defTabSz="914400" rtl="0" eaLnBrk="1" latinLnBrk="0" hangingPunct="1">
-                        <a:lnSpc>
-                          <a:spcPts val="1200"/>
-                        </a:lnSpc>
-                      </a:pPr>
-                      <a:r>
-                        <a:rPr lang="en-US" sz="600" b="0" i="0" kern="1200" dirty="0">
-                          <a:solidFill>
-                            <a:schemeClr val="tx1"/>
-                          </a:solidFill>
-                          <a:latin typeface="Fund Light" pitchFamily="2" charset="-78"/>
-                          <a:ea typeface="+mn-ea"/>
-                          <a:cs typeface="Fund Light" pitchFamily="2" charset="-78"/>
-                        </a:rPr>
-                        <a:t>q</a:t>
-                      </a:r>
-                    </a:p>
-                  </a:txBody>
-                  <a:tcPr marL="36000" marR="36000" marT="0" marB="0" anchor="ctr">
-                    <a:lnL w="12700" cap="flat" cmpd="sng" algn="ctr">
-                      <a:noFill/>
-                      <a:prstDash val="solid"/>
-                      <a:round/>
-                      <a:headEnd type="none" w="med" len="med"/>
-                      <a:tailEnd type="none" w="med" len="med"/>
-                    </a:lnL>
-                    <a:lnR w="12700" cap="flat" cmpd="sng" algn="ctr">
-                      <a:noFill/>
-                      <a:prstDash val="solid"/>
-                      <a:round/>
-                      <a:headEnd type="none" w="med" len="med"/>
-                      <a:tailEnd type="none" w="med" len="med"/>
-                    </a:lnR>
-                    <a:lnT w="6350" cap="flat" cmpd="sng" algn="ctr">
-                      <a:solidFill>
-                        <a:schemeClr val="bg1">
-                          <a:lumMod val="85000"/>
-                        </a:schemeClr>
-                      </a:solidFill>
-                      <a:prstDash val="solid"/>
-                      <a:round/>
-                      <a:headEnd type="none" w="med" len="med"/>
-                      <a:tailEnd type="none" w="med" len="med"/>
-                    </a:lnT>
-                    <a:lnB w="6350" cap="flat" cmpd="sng" algn="ctr">
-                      <a:solidFill>
-                        <a:schemeClr val="bg1">
-                          <a:lumMod val="85000"/>
-                        </a:schemeClr>
-                      </a:solidFill>
-                      <a:prstDash val="solid"/>
-                      <a:round/>
-                      <a:headEnd type="none" w="med" len="med"/>
-                      <a:tailEnd type="none" w="med" len="med"/>
-                    </a:lnB>
-                    <a:lnTlToBr w="12700" cmpd="sng">
-                      <a:noFill/>
-                      <a:prstDash val="solid"/>
-                    </a:lnTlToBr>
-                    <a:lnBlToTr w="12700" cmpd="sng">
-                      <a:noFill/>
-                      <a:prstDash val="solid"/>
-                    </a:lnBlToTr>
-                    <a:noFill/>
-                  </a:tcPr>
-                </a:tc>
-                <a:tc>
-                  <a:txBody>
-                    <a:bodyPr/>
-                    <a:lstStyle/>
-                    <a:p>
-                      <a:pPr marL="0" algn="l" defTabSz="914400" rtl="0" eaLnBrk="1" latinLnBrk="0" hangingPunct="1">
-                        <a:lnSpc>
-                          <a:spcPts val="1200"/>
-                        </a:lnSpc>
-                      </a:pPr>
-                      <a:r>
-                        <a:rPr lang="en-US" sz="600" b="0" i="0" kern="1200" dirty="0">
-                          <a:solidFill>
-                            <a:schemeClr val="tx1"/>
-                          </a:solidFill>
-                          <a:latin typeface="Fund Light" pitchFamily="2" charset="-78"/>
-                          <a:ea typeface="+mn-ea"/>
-                          <a:cs typeface="Fund Light" pitchFamily="2" charset="-78"/>
-                        </a:rPr>
-                        <a:t>q</a:t>
-                      </a:r>
-                    </a:p>
-                  </a:txBody>
-                  <a:tcPr marL="36000" marR="36000" marT="0" marB="0" anchor="ctr">
-                    <a:lnL w="12700" cap="flat" cmpd="sng" algn="ctr">
-                      <a:noFill/>
-                      <a:prstDash val="solid"/>
-                      <a:round/>
-                      <a:headEnd type="none" w="med" len="med"/>
-                      <a:tailEnd type="none" w="med" len="med"/>
-                    </a:lnL>
-                    <a:lnR w="12700" cap="flat" cmpd="sng" algn="ctr">
-                      <a:noFill/>
-                      <a:prstDash val="solid"/>
-                      <a:round/>
-                      <a:headEnd type="none" w="med" len="med"/>
-                      <a:tailEnd type="none" w="med" len="med"/>
-                    </a:lnR>
-                    <a:lnT w="6350" cap="flat" cmpd="sng" algn="ctr">
-                      <a:solidFill>
-                        <a:schemeClr val="bg1">
-                          <a:lumMod val="85000"/>
-                        </a:schemeClr>
-                      </a:solidFill>
-                      <a:prstDash val="solid"/>
-                      <a:round/>
-                      <a:headEnd type="none" w="med" len="med"/>
-                      <a:tailEnd type="none" w="med" len="med"/>
-                    </a:lnT>
-                    <a:lnB w="6350" cap="flat" cmpd="sng" algn="ctr">
-                      <a:solidFill>
-                        <a:schemeClr val="bg1">
-                          <a:lumMod val="85000"/>
-                        </a:schemeClr>
-                      </a:solidFill>
-                      <a:prstDash val="solid"/>
-                      <a:round/>
-                      <a:headEnd type="none" w="med" len="med"/>
-                      <a:tailEnd type="none" w="med" len="med"/>
-                    </a:lnB>
-                    <a:lnTlToBr w="12700" cmpd="sng">
-                      <a:noFill/>
-                      <a:prstDash val="solid"/>
-                    </a:lnTlToBr>
-                    <a:lnBlToTr w="12700" cmpd="sng">
-                      <a:noFill/>
-                      <a:prstDash val="solid"/>
-                    </a:lnBlToTr>
-                    <a:noFill/>
-                  </a:tcPr>
-                </a:tc>
-                <a:extLst>
-                  <a:ext uri="{0D108BD9-81ED-4DB2-BD59-A6C34878D82A}">
-                    <a16:rowId xmlns:a16="http://schemas.microsoft.com/office/drawing/2014/main" val="1961714469"/>
-                  </a:ext>
-                </a:extLst>
-              </a:tr>
-            </a:tbl>
-          </a:graphicData>
-        </a:graphic>
-      </p:graphicFrame>
-      <p:sp>
-        <p:nvSpPr>
-          <p:cNvPr id="2" name="Footer Placeholder 1">
-            <a:extLst>
-              <a:ext uri="{FF2B5EF4-FFF2-40B4-BE49-F238E27FC236}">
-                <a16:creationId xmlns:a16="http://schemas.microsoft.com/office/drawing/2014/main" id="{E4A55677-1FD6-40FD-A80C-B7E44566976B}"/>
+                <a16:creationId xmlns:a16="http://schemas.microsoft.com/office/drawing/2014/main" id="{704A712B-7D94-412A-AD53-6AE8FF5AB34D}"/>
               </a:ext>
             </a:extLst>
           </p:cNvPr>
@@ -11974,10 +10357,10 @@
       </p:grpSp>
       <p:sp>
         <p:nvSpPr>
-          <p:cNvPr id="5" name="Footer Placeholder 4">
+          <p:cNvPr id="6" name="Footer Placeholder 5">
             <a:extLst>
               <a:ext uri="{FF2B5EF4-FFF2-40B4-BE49-F238E27FC236}">
-                <a16:creationId xmlns:a16="http://schemas.microsoft.com/office/drawing/2014/main" id="{527A73E8-F067-48F1-8C9F-D1E79455538B}"/>
+                <a16:creationId xmlns:a16="http://schemas.microsoft.com/office/drawing/2014/main" id="{2216E377-ED81-42F2-9E55-156972D6B437}"/>
               </a:ext>
             </a:extLst>
           </p:cNvPr>
@@ -12764,7 +11147,7 @@
 </file>
 
 <file path=customXml/itemProps1.xml><?xml version="1.0" encoding="utf-8"?>
-<ds:datastoreItem xmlns:ds="http://schemas.openxmlformats.org/officeDocument/2006/customXml" ds:itemID="{4BBA4F4B-83B1-4A04-928D-4E5BAAE29B16}">
+<ds:datastoreItem xmlns:ds="http://schemas.openxmlformats.org/officeDocument/2006/customXml" ds:itemID="{1F932E4C-D55E-4037-A535-9777C851BCE7}">
   <ds:schemaRefs>
     <ds:schemaRef ds:uri="http://www.w3.org/2001/XMLSchema"/>
     <ds:schemaRef ds:uri="http://www.boldonjames.com/2008/01/sie/internal/label"/>
@@ -12773,7 +11156,7 @@
 </file>
 
 <file path=customXml/itemProps2.xml><?xml version="1.0" encoding="utf-8"?>
-<ds:datastoreItem xmlns:ds="http://schemas.openxmlformats.org/officeDocument/2006/customXml" ds:itemID="{36AC9BF8-2F14-4C26-BFEB-10E05DBCEFAB}">
+<ds:datastoreItem xmlns:ds="http://schemas.openxmlformats.org/officeDocument/2006/customXml" ds:itemID="{DA1CAF05-4605-4D79-B2CD-2732286DB1E6}">
   <ds:schemaRefs>
     <ds:schemaRef ds:uri="http://www.w3.org/2001/XMLSchema"/>
     <ds:schemaRef ds:uri="http://www.boldonjames.com/2016/02/Classifier/internal/wrappedLabelInfo"/>

</xml_diff>

<commit_message>
feat: add officePPT and sample template structure with initial slide and note XML files
</commit_message>
<xml_diff>
--- a/templates/officePPT.pptx
+++ b/templates/officePPT.pptx
@@ -787,6 +787,7 @@
     </c:legend>
     <c:plotVisOnly val="1"/>
     <c:dispBlanksAs val="gap"/>
+    <c:showDLblsOverMax val="0"/>
     <c:extLst>
       <c:ext xmlns:c16r3="http://schemas.microsoft.com/office/drawing/2017/03/chart" uri="{56B9EC1D-385E-4148-901F-78D8002777C0}">
         <c16r3:dataDisplayOptions16>
@@ -794,7 +795,6 @@
         </c16r3:dataDisplayOptions16>
       </c:ext>
     </c:extLst>
-    <c:showDLblsOverMax val="0"/>
   </c:chart>
   <c:spPr>
     <a:noFill/>
@@ -1244,6 +1244,7 @@
     </c:legend>
     <c:plotVisOnly val="1"/>
     <c:dispBlanksAs val="gap"/>
+    <c:showDLblsOverMax val="0"/>
     <c:extLst>
       <c:ext xmlns:c16r3="http://schemas.microsoft.com/office/drawing/2017/03/chart" uri="{56B9EC1D-385E-4148-901F-78D8002777C0}">
         <c16r3:dataDisplayOptions16>
@@ -1251,7 +1252,6 @@
         </c16r3:dataDisplayOptions16>
       </c:ext>
     </c:extLst>
-    <c:showDLblsOverMax val="0"/>
   </c:chart>
   <c:spPr>
     <a:noFill/>
@@ -2038,6 +2038,7 @@
     </c:plotArea>
     <c:plotVisOnly val="1"/>
     <c:dispBlanksAs val="gap"/>
+    <c:showDLblsOverMax val="0"/>
     <c:extLst>
       <c:ext xmlns:c16r3="http://schemas.microsoft.com/office/drawing/2017/03/chart" uri="{56B9EC1D-385E-4148-901F-78D8002777C0}">
         <c16r3:dataDisplayOptions16>
@@ -2045,7 +2046,6 @@
         </c16r3:dataDisplayOptions16>
       </c:ext>
     </c:extLst>
-    <c:showDLblsOverMax val="0"/>
   </c:chart>
   <c:spPr>
     <a:noFill/>
@@ -3783,7 +3783,7 @@
           <a:p>
             <a:fld id="{8B1AF6D7-0F32-4F05-B21A-8AF0CB26F94C}" type="datetimeFigureOut">
               <a:rPr lang="en-IN" smtClean="0"/>
-              <a:t>26-06-2026</a:t>
+              <a:t>08-07-2026</a:t>
             </a:fld>
             <a:endParaRPr lang="en-IN"/>
           </a:p>
@@ -4980,7 +4980,7 @@
           <a:p>
             <a:fld id="{0490EA95-AFA9-47FA-B067-612933D1D62E}" type="datetimeFigureOut">
               <a:rPr lang="en-IN" smtClean="0"/>
-              <a:t>26-06-2026</a:t>
+              <a:t>08-07-2026</a:t>
             </a:fld>
             <a:endParaRPr lang="en-IN"/>
           </a:p>
@@ -5180,7 +5180,7 @@
           <a:p>
             <a:fld id="{0490EA95-AFA9-47FA-B067-612933D1D62E}" type="datetimeFigureOut">
               <a:rPr lang="en-IN" smtClean="0"/>
-              <a:t>26-06-2026</a:t>
+              <a:t>08-07-2026</a:t>
             </a:fld>
             <a:endParaRPr lang="en-IN"/>
           </a:p>
@@ -5390,7 +5390,7 @@
           <a:p>
             <a:fld id="{0490EA95-AFA9-47FA-B067-612933D1D62E}" type="datetimeFigureOut">
               <a:rPr lang="en-IN" smtClean="0"/>
-              <a:t>26-06-2026</a:t>
+              <a:t>08-07-2026</a:t>
             </a:fld>
             <a:endParaRPr lang="en-IN"/>
           </a:p>
@@ -5590,7 +5590,7 @@
           <a:p>
             <a:fld id="{0490EA95-AFA9-47FA-B067-612933D1D62E}" type="datetimeFigureOut">
               <a:rPr lang="en-IN" smtClean="0"/>
-              <a:t>26-06-2026</a:t>
+              <a:t>08-07-2026</a:t>
             </a:fld>
             <a:endParaRPr lang="en-IN"/>
           </a:p>
@@ -5880,7 +5880,7 @@
           <a:p>
             <a:fld id="{0490EA95-AFA9-47FA-B067-612933D1D62E}" type="datetimeFigureOut">
               <a:rPr lang="en-IN" smtClean="0"/>
-              <a:t>26-06-2026</a:t>
+              <a:t>08-07-2026</a:t>
             </a:fld>
             <a:endParaRPr lang="en-IN"/>
           </a:p>
@@ -6148,7 +6148,7 @@
           <a:p>
             <a:fld id="{0490EA95-AFA9-47FA-B067-612933D1D62E}" type="datetimeFigureOut">
               <a:rPr lang="en-IN" smtClean="0"/>
-              <a:t>26-06-2026</a:t>
+              <a:t>08-07-2026</a:t>
             </a:fld>
             <a:endParaRPr lang="en-IN"/>
           </a:p>
@@ -6563,7 +6563,7 @@
           <a:p>
             <a:fld id="{0490EA95-AFA9-47FA-B067-612933D1D62E}" type="datetimeFigureOut">
               <a:rPr lang="en-IN" smtClean="0"/>
-              <a:t>26-06-2026</a:t>
+              <a:t>08-07-2026</a:t>
             </a:fld>
             <a:endParaRPr lang="en-IN"/>
           </a:p>
@@ -6705,7 +6705,7 @@
           <a:p>
             <a:fld id="{0490EA95-AFA9-47FA-B067-612933D1D62E}" type="datetimeFigureOut">
               <a:rPr lang="en-IN" smtClean="0"/>
-              <a:t>26-06-2026</a:t>
+              <a:t>08-07-2026</a:t>
             </a:fld>
             <a:endParaRPr lang="en-IN"/>
           </a:p>
@@ -6818,7 +6818,7 @@
           <a:p>
             <a:fld id="{0490EA95-AFA9-47FA-B067-612933D1D62E}" type="datetimeFigureOut">
               <a:rPr lang="en-IN" smtClean="0"/>
-              <a:t>26-06-2026</a:t>
+              <a:t>08-07-2026</a:t>
             </a:fld>
             <a:endParaRPr lang="en-IN"/>
           </a:p>
@@ -7131,7 +7131,7 @@
           <a:p>
             <a:fld id="{0490EA95-AFA9-47FA-B067-612933D1D62E}" type="datetimeFigureOut">
               <a:rPr lang="en-IN" smtClean="0"/>
-              <a:t>26-06-2026</a:t>
+              <a:t>08-07-2026</a:t>
             </a:fld>
             <a:endParaRPr lang="en-IN"/>
           </a:p>
@@ -7420,7 +7420,7 @@
           <a:p>
             <a:fld id="{0490EA95-AFA9-47FA-B067-612933D1D62E}" type="datetimeFigureOut">
               <a:rPr lang="en-IN" smtClean="0"/>
-              <a:t>26-06-2026</a:t>
+              <a:t>08-07-2026</a:t>
             </a:fld>
             <a:endParaRPr lang="en-IN"/>
           </a:p>
@@ -7663,7 +7663,7 @@
           <a:p>
             <a:fld id="{0490EA95-AFA9-47FA-B067-612933D1D62E}" type="datetimeFigureOut">
               <a:rPr lang="en-IN" smtClean="0"/>
-              <a:t>26-06-2026</a:t>
+              <a:t>08-07-2026</a:t>
             </a:fld>
             <a:endParaRPr lang="en-IN"/>
           </a:p>
@@ -8193,10 +8193,10 @@
       </p:graphicFrame>
       <p:sp>
         <p:nvSpPr>
-          <p:cNvPr id="5" name="Footer Placeholder 4">
+          <p:cNvPr id="4" name="Footer Placeholder 3">
             <a:extLst>
               <a:ext uri="{FF2B5EF4-FFF2-40B4-BE49-F238E27FC236}">
-                <a16:creationId xmlns:a16="http://schemas.microsoft.com/office/drawing/2014/main" id="{A4EB2420-B09B-4DFD-B28E-37DDE47DFA71}"/>
+                <a16:creationId xmlns:a16="http://schemas.microsoft.com/office/drawing/2014/main" id="{2E80303B-D788-4D39-A1D0-32C5F90213D0}"/>
               </a:ext>
             </a:extLst>
           </p:cNvPr>
@@ -8320,10 +8320,10 @@
       </p:graphicFrame>
       <p:sp>
         <p:nvSpPr>
-          <p:cNvPr id="4" name="Footer Placeholder 3">
+          <p:cNvPr id="3" name="Footer Placeholder 2">
             <a:extLst>
               <a:ext uri="{FF2B5EF4-FFF2-40B4-BE49-F238E27FC236}">
-                <a16:creationId xmlns:a16="http://schemas.microsoft.com/office/drawing/2014/main" id="{0A82AB87-F5C6-4A29-A383-B9C3449C5CAE}"/>
+                <a16:creationId xmlns:a16="http://schemas.microsoft.com/office/drawing/2014/main" id="{4AB522F2-E5A7-4F5D-999D-810C8CB35B71}"/>
               </a:ext>
             </a:extLst>
           </p:cNvPr>
@@ -9319,10 +9319,10 @@
       </p:sp>
       <p:sp>
         <p:nvSpPr>
-          <p:cNvPr id="13" name="Footer Placeholder 12">
+          <p:cNvPr id="12" name="Footer Placeholder 11">
             <a:extLst>
               <a:ext uri="{FF2B5EF4-FFF2-40B4-BE49-F238E27FC236}">
-                <a16:creationId xmlns:a16="http://schemas.microsoft.com/office/drawing/2014/main" id="{6F8B634C-829C-4055-8907-6A01C93C3E7F}"/>
+                <a16:creationId xmlns:a16="http://schemas.microsoft.com/office/drawing/2014/main" id="{1672FF25-2EE4-4CCB-8E91-567C30CA9325}"/>
               </a:ext>
             </a:extLst>
           </p:cNvPr>
@@ -9563,10 +9563,10 @@
       </p:sp>
       <p:sp>
         <p:nvSpPr>
-          <p:cNvPr id="7" name="Footer Placeholder 6">
+          <p:cNvPr id="6" name="Footer Placeholder 5">
             <a:extLst>
               <a:ext uri="{FF2B5EF4-FFF2-40B4-BE49-F238E27FC236}">
-                <a16:creationId xmlns:a16="http://schemas.microsoft.com/office/drawing/2014/main" id="{010F6015-4DD0-471D-A60C-AB6C888A6AD0}"/>
+                <a16:creationId xmlns:a16="http://schemas.microsoft.com/office/drawing/2014/main" id="{6D551B71-AFB5-4983-9668-CCD00F9D7E49}"/>
               </a:ext>
             </a:extLst>
           </p:cNvPr>
@@ -9708,12 +9708,1629 @@
           </a:p>
         </p:txBody>
       </p:sp>
+      <p:graphicFrame>
+        <p:nvGraphicFramePr>
+          <p:cNvPr id="5" name="Board Data">
+            <a:extLst>
+              <a:ext uri="{FF2B5EF4-FFF2-40B4-BE49-F238E27FC236}">
+                <a16:creationId xmlns:a16="http://schemas.microsoft.com/office/drawing/2014/main" id="{200C1D5F-0C2A-486C-A767-14A24E5AA098}"/>
+              </a:ext>
+            </a:extLst>
+          </p:cNvPr>
+          <p:cNvGraphicFramePr>
+            <a:graphicFrameLocks noGrp="1"/>
+          </p:cNvGraphicFramePr>
+          <p:nvPr>
+            <p:extLst>
+              <p:ext uri="{D42A27DB-BD31-4B8C-83A1-F6EECF244321}">
+                <p14:modId xmlns:p14="http://schemas.microsoft.com/office/powerpoint/2010/main" val="131546633"/>
+              </p:ext>
+            </p:extLst>
+          </p:nvPr>
+        </p:nvGraphicFramePr>
+        <p:xfrm>
+          <a:off x="6941467" y="136525"/>
+          <a:ext cx="4334512" cy="457200"/>
+        </p:xfrm>
+        <a:graphic>
+          <a:graphicData uri="http://schemas.openxmlformats.org/drawingml/2006/table">
+            <a:tbl>
+              <a:tblPr firstRow="1">
+                <a:tableStyleId>{5C22544A-7EE6-4342-B048-85BDC9FD1C3A}</a:tableStyleId>
+              </a:tblPr>
+              <a:tblGrid>
+                <a:gridCol w="619216">
+                  <a:extLst>
+                    <a:ext uri="{9D8B030D-6E8A-4147-A177-3AD203B41FA5}">
+                      <a16:colId xmlns:a16="http://schemas.microsoft.com/office/drawing/2014/main" val="2710512592"/>
+                    </a:ext>
+                  </a:extLst>
+                </a:gridCol>
+                <a:gridCol w="1152494">
+                  <a:extLst>
+                    <a:ext uri="{9D8B030D-6E8A-4147-A177-3AD203B41FA5}">
+                      <a16:colId xmlns:a16="http://schemas.microsoft.com/office/drawing/2014/main" val="3519371818"/>
+                    </a:ext>
+                  </a:extLst>
+                </a:gridCol>
+                <a:gridCol w="738554">
+                  <a:extLst>
+                    <a:ext uri="{9D8B030D-6E8A-4147-A177-3AD203B41FA5}">
+                      <a16:colId xmlns:a16="http://schemas.microsoft.com/office/drawing/2014/main" val="4260604003"/>
+                    </a:ext>
+                  </a:extLst>
+                </a:gridCol>
+                <a:gridCol w="580292">
+                  <a:extLst>
+                    <a:ext uri="{9D8B030D-6E8A-4147-A177-3AD203B41FA5}">
+                      <a16:colId xmlns:a16="http://schemas.microsoft.com/office/drawing/2014/main" val="958991336"/>
+                    </a:ext>
+                  </a:extLst>
+                </a:gridCol>
+                <a:gridCol w="457200">
+                  <a:extLst>
+                    <a:ext uri="{9D8B030D-6E8A-4147-A177-3AD203B41FA5}">
+                      <a16:colId xmlns:a16="http://schemas.microsoft.com/office/drawing/2014/main" val="4239024402"/>
+                    </a:ext>
+                  </a:extLst>
+                </a:gridCol>
+                <a:gridCol w="474785">
+                  <a:extLst>
+                    <a:ext uri="{9D8B030D-6E8A-4147-A177-3AD203B41FA5}">
+                      <a16:colId xmlns:a16="http://schemas.microsoft.com/office/drawing/2014/main" val="505228023"/>
+                    </a:ext>
+                  </a:extLst>
+                </a:gridCol>
+                <a:gridCol w="311971">
+                  <a:extLst>
+                    <a:ext uri="{9D8B030D-6E8A-4147-A177-3AD203B41FA5}">
+                      <a16:colId xmlns:a16="http://schemas.microsoft.com/office/drawing/2014/main" val="3014002297"/>
+                    </a:ext>
+                  </a:extLst>
+                </a:gridCol>
+              </a:tblGrid>
+              <a:tr h="182880">
+                <a:tc gridSpan="2">
+                  <a:txBody>
+                    <a:bodyPr/>
+                    <a:lstStyle/>
+                    <a:p>
+                      <a:pPr algn="l">
+                        <a:lnSpc>
+                          <a:spcPts val="1300"/>
+                        </a:lnSpc>
+                      </a:pPr>
+                      <a:r>
+                        <a:rPr lang="en-US" sz="600" b="0" i="0" dirty="0">
+                          <a:solidFill>
+                            <a:schemeClr val="bg1"/>
+                          </a:solidFill>
+                          <a:latin typeface="Fund Regular" pitchFamily="2" charset="-78"/>
+                          <a:cs typeface="Fund Regular" pitchFamily="2" charset="-78"/>
+                        </a:rPr>
+                        <a:t>BOARD COMPOSITION DATA</a:t>
+                      </a:r>
+                    </a:p>
+                  </a:txBody>
+                  <a:tcPr marL="36000" marR="36000" marT="0" marB="0" anchor="ctr">
+                    <a:lnL w="3175" cap="flat" cmpd="sng" algn="ctr">
+                      <a:solidFill>
+                        <a:schemeClr val="bg1"/>
+                      </a:solidFill>
+                      <a:prstDash val="solid"/>
+                      <a:round/>
+                      <a:headEnd type="none" w="med" len="med"/>
+                      <a:tailEnd type="none" w="med" len="med"/>
+                    </a:lnL>
+                    <a:lnR w="3175" cap="flat" cmpd="sng" algn="ctr">
+                      <a:solidFill>
+                        <a:schemeClr val="bg1"/>
+                      </a:solidFill>
+                      <a:prstDash val="solid"/>
+                      <a:round/>
+                      <a:headEnd type="none" w="med" len="med"/>
+                      <a:tailEnd type="none" w="med" len="med"/>
+                    </a:lnR>
+                    <a:lnT w="3175" cap="flat" cmpd="sng" algn="ctr">
+                      <a:solidFill>
+                        <a:schemeClr val="bg1"/>
+                      </a:solidFill>
+                      <a:prstDash val="solid"/>
+                      <a:round/>
+                      <a:headEnd type="none" w="med" len="med"/>
+                      <a:tailEnd type="none" w="med" len="med"/>
+                    </a:lnT>
+                    <a:lnB w="3175" cap="flat" cmpd="sng" algn="ctr">
+                      <a:solidFill>
+                        <a:schemeClr val="bg1"/>
+                      </a:solidFill>
+                      <a:prstDash val="solid"/>
+                      <a:round/>
+                      <a:headEnd type="none" w="med" len="med"/>
+                      <a:tailEnd type="none" w="med" len="med"/>
+                    </a:lnB>
+                    <a:lnTlToBr w="12700" cmpd="sng">
+                      <a:noFill/>
+                      <a:prstDash val="solid"/>
+                    </a:lnTlToBr>
+                    <a:lnBlToTr w="12700" cmpd="sng">
+                      <a:noFill/>
+                      <a:prstDash val="solid"/>
+                    </a:lnBlToTr>
+                    <a:solidFill>
+                      <a:schemeClr val="tx2"/>
+                    </a:solidFill>
+                  </a:tcPr>
+                </a:tc>
+                <a:tc hMerge="1">
+                  <a:txBody>
+                    <a:bodyPr/>
+                    <a:lstStyle/>
+                    <a:p>
+                      <a:pPr>
+                        <a:lnSpc>
+                          <a:spcPts val="1300"/>
+                        </a:lnSpc>
+                      </a:pPr>
+                      <a:endParaRPr lang="en-US" sz="1200" dirty="0">
+                        <a:solidFill>
+                          <a:schemeClr val="bg1"/>
+                        </a:solidFill>
+                        <a:latin typeface="Sakkal Majalla" panose="02000000000000000000" pitchFamily="2" charset="-78"/>
+                        <a:cs typeface="Sakkal Majalla" panose="02000000000000000000" pitchFamily="2" charset="-78"/>
+                      </a:endParaRPr>
+                    </a:p>
+                  </a:txBody>
+                  <a:tcPr marL="36000" marR="36000" marT="0" marB="0" anchor="ctr">
+                    <a:lnL w="3175" cap="flat" cmpd="sng" algn="ctr">
+                      <a:solidFill>
+                        <a:schemeClr val="bg1"/>
+                      </a:solidFill>
+                      <a:prstDash val="solid"/>
+                      <a:round/>
+                      <a:headEnd type="none" w="med" len="med"/>
+                      <a:tailEnd type="none" w="med" len="med"/>
+                    </a:lnL>
+                    <a:lnR w="3175" cap="flat" cmpd="sng" algn="ctr">
+                      <a:solidFill>
+                        <a:schemeClr val="bg1"/>
+                      </a:solidFill>
+                      <a:prstDash val="solid"/>
+                      <a:round/>
+                      <a:headEnd type="none" w="med" len="med"/>
+                      <a:tailEnd type="none" w="med" len="med"/>
+                    </a:lnR>
+                    <a:lnT w="3175" cap="flat" cmpd="sng" algn="ctr">
+                      <a:solidFill>
+                        <a:schemeClr val="bg1"/>
+                      </a:solidFill>
+                      <a:prstDash val="solid"/>
+                      <a:round/>
+                      <a:headEnd type="none" w="med" len="med"/>
+                      <a:tailEnd type="none" w="med" len="med"/>
+                    </a:lnT>
+                    <a:lnB w="3175" cap="flat" cmpd="sng" algn="ctr">
+                      <a:solidFill>
+                        <a:schemeClr val="bg1"/>
+                      </a:solidFill>
+                      <a:prstDash val="solid"/>
+                      <a:round/>
+                      <a:headEnd type="none" w="med" len="med"/>
+                      <a:tailEnd type="none" w="med" len="med"/>
+                    </a:lnB>
+                    <a:lnTlToBr w="12700" cmpd="sng">
+                      <a:noFill/>
+                      <a:prstDash val="solid"/>
+                    </a:lnTlToBr>
+                    <a:lnBlToTr w="12700" cmpd="sng">
+                      <a:noFill/>
+                      <a:prstDash val="solid"/>
+                    </a:lnBlToTr>
+                    <a:solidFill>
+                      <a:schemeClr val="tx2"/>
+                    </a:solidFill>
+                  </a:tcPr>
+                </a:tc>
+                <a:tc gridSpan="2">
+                  <a:txBody>
+                    <a:bodyPr/>
+                    <a:lstStyle/>
+                    <a:p>
+                      <a:pPr algn="l">
+                        <a:lnSpc>
+                          <a:spcPts val="1300"/>
+                        </a:lnSpc>
+                      </a:pPr>
+                      <a:r>
+                        <a:rPr lang="en-US" sz="600" b="0" i="0" kern="1200" dirty="0">
+                          <a:solidFill>
+                            <a:schemeClr val="bg1"/>
+                          </a:solidFill>
+                          <a:latin typeface="Fund Regular" pitchFamily="2" charset="-78"/>
+                          <a:ea typeface="+mn-ea"/>
+                          <a:cs typeface="Fund Regular" pitchFamily="2" charset="-78"/>
+                        </a:rPr>
+                        <a:t>START DATE: MMMM-YYYY</a:t>
+                      </a:r>
+                      <a:endParaRPr lang="en-US" sz="600" dirty="0">
+                        <a:solidFill>
+                          <a:schemeClr val="bg1"/>
+                        </a:solidFill>
+                        <a:latin typeface="Sakkal Majalla" panose="02000000000000000000" pitchFamily="2" charset="-78"/>
+                        <a:cs typeface="Sakkal Majalla" panose="02000000000000000000" pitchFamily="2" charset="-78"/>
+                      </a:endParaRPr>
+                    </a:p>
+                  </a:txBody>
+                  <a:tcPr marL="36000" marR="36000" marT="0" marB="0" anchor="ctr">
+                    <a:lnL w="3175" cap="flat" cmpd="sng" algn="ctr">
+                      <a:solidFill>
+                        <a:schemeClr val="bg1"/>
+                      </a:solidFill>
+                      <a:prstDash val="solid"/>
+                      <a:round/>
+                      <a:headEnd type="none" w="med" len="med"/>
+                      <a:tailEnd type="none" w="med" len="med"/>
+                    </a:lnL>
+                    <a:lnR w="3175" cap="flat" cmpd="sng" algn="ctr">
+                      <a:solidFill>
+                        <a:schemeClr val="bg1"/>
+                      </a:solidFill>
+                      <a:prstDash val="solid"/>
+                      <a:round/>
+                      <a:headEnd type="none" w="med" len="med"/>
+                      <a:tailEnd type="none" w="med" len="med"/>
+                    </a:lnR>
+                    <a:lnT w="3175" cap="flat" cmpd="sng" algn="ctr">
+                      <a:solidFill>
+                        <a:schemeClr val="bg1"/>
+                      </a:solidFill>
+                      <a:prstDash val="solid"/>
+                      <a:round/>
+                      <a:headEnd type="none" w="med" len="med"/>
+                      <a:tailEnd type="none" w="med" len="med"/>
+                    </a:lnT>
+                    <a:lnB w="3175" cap="flat" cmpd="sng" algn="ctr">
+                      <a:solidFill>
+                        <a:schemeClr val="bg1"/>
+                      </a:solidFill>
+                      <a:prstDash val="solid"/>
+                      <a:round/>
+                      <a:headEnd type="none" w="med" len="med"/>
+                      <a:tailEnd type="none" w="med" len="med"/>
+                    </a:lnB>
+                    <a:lnTlToBr w="12700" cmpd="sng">
+                      <a:noFill/>
+                      <a:prstDash val="solid"/>
+                    </a:lnTlToBr>
+                    <a:lnBlToTr w="12700" cmpd="sng">
+                      <a:noFill/>
+                      <a:prstDash val="solid"/>
+                    </a:lnBlToTr>
+                    <a:solidFill>
+                      <a:schemeClr val="tx2"/>
+                    </a:solidFill>
+                  </a:tcPr>
+                </a:tc>
+                <a:tc hMerge="1">
+                  <a:txBody>
+                    <a:bodyPr/>
+                    <a:lstStyle/>
+                    <a:p>
+                      <a:pPr>
+                        <a:lnSpc>
+                          <a:spcPts val="1300"/>
+                        </a:lnSpc>
+                      </a:pPr>
+                      <a:endParaRPr lang="en-US" sz="1200" dirty="0">
+                        <a:solidFill>
+                          <a:schemeClr val="bg1"/>
+                        </a:solidFill>
+                        <a:latin typeface="Sakkal Majalla" panose="02000000000000000000" pitchFamily="2" charset="-78"/>
+                        <a:cs typeface="Sakkal Majalla" panose="02000000000000000000" pitchFamily="2" charset="-78"/>
+                      </a:endParaRPr>
+                    </a:p>
+                  </a:txBody>
+                  <a:tcPr marL="36000" marR="36000" marT="0" marB="0" anchor="ctr">
+                    <a:lnL w="3175" cap="flat" cmpd="sng" algn="ctr">
+                      <a:solidFill>
+                        <a:schemeClr val="bg1"/>
+                      </a:solidFill>
+                      <a:prstDash val="solid"/>
+                      <a:round/>
+                      <a:headEnd type="none" w="med" len="med"/>
+                      <a:tailEnd type="none" w="med" len="med"/>
+                    </a:lnL>
+                    <a:lnR w="3175" cap="flat" cmpd="sng" algn="ctr">
+                      <a:solidFill>
+                        <a:schemeClr val="bg1"/>
+                      </a:solidFill>
+                      <a:prstDash val="solid"/>
+                      <a:round/>
+                      <a:headEnd type="none" w="med" len="med"/>
+                      <a:tailEnd type="none" w="med" len="med"/>
+                    </a:lnR>
+                    <a:lnT w="3175" cap="flat" cmpd="sng" algn="ctr">
+                      <a:solidFill>
+                        <a:schemeClr val="bg1"/>
+                      </a:solidFill>
+                      <a:prstDash val="solid"/>
+                      <a:round/>
+                      <a:headEnd type="none" w="med" len="med"/>
+                      <a:tailEnd type="none" w="med" len="med"/>
+                    </a:lnT>
+                    <a:lnB w="3175" cap="flat" cmpd="sng" algn="ctr">
+                      <a:solidFill>
+                        <a:schemeClr val="bg1"/>
+                      </a:solidFill>
+                      <a:prstDash val="solid"/>
+                      <a:round/>
+                      <a:headEnd type="none" w="med" len="med"/>
+                      <a:tailEnd type="none" w="med" len="med"/>
+                    </a:lnB>
+                    <a:lnTlToBr w="12700" cmpd="sng">
+                      <a:noFill/>
+                      <a:prstDash val="solid"/>
+                    </a:lnTlToBr>
+                    <a:lnBlToTr w="12700" cmpd="sng">
+                      <a:noFill/>
+                      <a:prstDash val="solid"/>
+                    </a:lnBlToTr>
+                    <a:solidFill>
+                      <a:schemeClr val="tx2"/>
+                    </a:solidFill>
+                  </a:tcPr>
+                </a:tc>
+                <a:tc gridSpan="3">
+                  <a:txBody>
+                    <a:bodyPr/>
+                    <a:lstStyle/>
+                    <a:p>
+                      <a:pPr algn="l">
+                        <a:lnSpc>
+                          <a:spcPts val="1300"/>
+                        </a:lnSpc>
+                      </a:pPr>
+                      <a:r>
+                        <a:rPr kumimoji="0" lang="en-US" sz="600" b="0" i="0" u="none" strike="noStrike" kern="1200" cap="none" spc="0" normalizeH="0" baseline="0" noProof="0" dirty="0">
+                          <a:ln>
+                            <a:noFill/>
+                          </a:ln>
+                          <a:solidFill>
+                            <a:srgbClr val="FFFFFF"/>
+                          </a:solidFill>
+                          <a:effectLst/>
+                          <a:uLnTx/>
+                          <a:uFillTx/>
+                          <a:latin typeface="Fund Regular" pitchFamily="2" charset="-78"/>
+                          <a:ea typeface="+mn-ea"/>
+                          <a:cs typeface="Fund Regular" pitchFamily="2" charset="-78"/>
+                        </a:rPr>
+                        <a:t>END DATE: MMMM-YYYY</a:t>
+                      </a:r>
+                      <a:endParaRPr lang="en-US" sz="600" dirty="0">
+                        <a:solidFill>
+                          <a:schemeClr val="bg1"/>
+                        </a:solidFill>
+                        <a:latin typeface="Sakkal Majalla" panose="02000000000000000000" pitchFamily="2" charset="-78"/>
+                        <a:cs typeface="Sakkal Majalla" panose="02000000000000000000" pitchFamily="2" charset="-78"/>
+                      </a:endParaRPr>
+                    </a:p>
+                  </a:txBody>
+                  <a:tcPr marL="36000" marR="36000" marT="0" marB="0" anchor="ctr">
+                    <a:lnL w="3175" cap="flat" cmpd="sng" algn="ctr">
+                      <a:solidFill>
+                        <a:schemeClr val="bg1"/>
+                      </a:solidFill>
+                      <a:prstDash val="solid"/>
+                      <a:round/>
+                      <a:headEnd type="none" w="med" len="med"/>
+                      <a:tailEnd type="none" w="med" len="med"/>
+                    </a:lnL>
+                    <a:lnR w="3175" cap="flat" cmpd="sng" algn="ctr">
+                      <a:solidFill>
+                        <a:schemeClr val="bg1"/>
+                      </a:solidFill>
+                      <a:prstDash val="solid"/>
+                      <a:round/>
+                      <a:headEnd type="none" w="med" len="med"/>
+                      <a:tailEnd type="none" w="med" len="med"/>
+                    </a:lnR>
+                    <a:lnT w="3175" cap="flat" cmpd="sng" algn="ctr">
+                      <a:solidFill>
+                        <a:schemeClr val="bg1"/>
+                      </a:solidFill>
+                      <a:prstDash val="solid"/>
+                      <a:round/>
+                      <a:headEnd type="none" w="med" len="med"/>
+                      <a:tailEnd type="none" w="med" len="med"/>
+                    </a:lnT>
+                    <a:lnB w="3175" cap="flat" cmpd="sng" algn="ctr">
+                      <a:solidFill>
+                        <a:schemeClr val="bg1"/>
+                      </a:solidFill>
+                      <a:prstDash val="solid"/>
+                      <a:round/>
+                      <a:headEnd type="none" w="med" len="med"/>
+                      <a:tailEnd type="none" w="med" len="med"/>
+                    </a:lnB>
+                    <a:lnTlToBr w="12700" cmpd="sng">
+                      <a:noFill/>
+                      <a:prstDash val="solid"/>
+                    </a:lnTlToBr>
+                    <a:lnBlToTr w="12700" cmpd="sng">
+                      <a:noFill/>
+                      <a:prstDash val="solid"/>
+                    </a:lnBlToTr>
+                    <a:solidFill>
+                      <a:schemeClr val="tx2"/>
+                    </a:solidFill>
+                  </a:tcPr>
+                </a:tc>
+                <a:tc hMerge="1">
+                  <a:txBody>
+                    <a:bodyPr/>
+                    <a:lstStyle/>
+                    <a:p>
+                      <a:pPr>
+                        <a:lnSpc>
+                          <a:spcPts val="1300"/>
+                        </a:lnSpc>
+                      </a:pPr>
+                      <a:endParaRPr lang="en-US" sz="1200" dirty="0">
+                        <a:solidFill>
+                          <a:schemeClr val="bg1"/>
+                        </a:solidFill>
+                        <a:latin typeface="Sakkal Majalla" panose="02000000000000000000" pitchFamily="2" charset="-78"/>
+                        <a:cs typeface="Sakkal Majalla" panose="02000000000000000000" pitchFamily="2" charset="-78"/>
+                      </a:endParaRPr>
+                    </a:p>
+                  </a:txBody>
+                  <a:tcPr marL="36000" marR="36000" marT="0" marB="0" anchor="ctr">
+                    <a:lnL w="3175" cap="flat" cmpd="sng" algn="ctr">
+                      <a:solidFill>
+                        <a:schemeClr val="bg1"/>
+                      </a:solidFill>
+                      <a:prstDash val="solid"/>
+                      <a:round/>
+                      <a:headEnd type="none" w="med" len="med"/>
+                      <a:tailEnd type="none" w="med" len="med"/>
+                    </a:lnL>
+                    <a:lnR w="3175" cap="flat" cmpd="sng" algn="ctr">
+                      <a:solidFill>
+                        <a:schemeClr val="bg1"/>
+                      </a:solidFill>
+                      <a:prstDash val="solid"/>
+                      <a:round/>
+                      <a:headEnd type="none" w="med" len="med"/>
+                      <a:tailEnd type="none" w="med" len="med"/>
+                    </a:lnR>
+                    <a:lnT w="3175" cap="flat" cmpd="sng" algn="ctr">
+                      <a:solidFill>
+                        <a:schemeClr val="bg1"/>
+                      </a:solidFill>
+                      <a:prstDash val="solid"/>
+                      <a:round/>
+                      <a:headEnd type="none" w="med" len="med"/>
+                      <a:tailEnd type="none" w="med" len="med"/>
+                    </a:lnT>
+                    <a:lnB w="3175" cap="flat" cmpd="sng" algn="ctr">
+                      <a:solidFill>
+                        <a:schemeClr val="bg1"/>
+                      </a:solidFill>
+                      <a:prstDash val="solid"/>
+                      <a:round/>
+                      <a:headEnd type="none" w="med" len="med"/>
+                      <a:tailEnd type="none" w="med" len="med"/>
+                    </a:lnB>
+                    <a:lnTlToBr w="12700" cmpd="sng">
+                      <a:noFill/>
+                      <a:prstDash val="solid"/>
+                    </a:lnTlToBr>
+                    <a:lnBlToTr w="12700" cmpd="sng">
+                      <a:noFill/>
+                      <a:prstDash val="solid"/>
+                    </a:lnBlToTr>
+                    <a:solidFill>
+                      <a:schemeClr val="tx2"/>
+                    </a:solidFill>
+                  </a:tcPr>
+                </a:tc>
+                <a:tc hMerge="1">
+                  <a:txBody>
+                    <a:bodyPr/>
+                    <a:lstStyle/>
+                    <a:p>
+                      <a:pPr>
+                        <a:lnSpc>
+                          <a:spcPts val="1300"/>
+                        </a:lnSpc>
+                      </a:pPr>
+                      <a:endParaRPr lang="en-US" sz="1200" dirty="0">
+                        <a:solidFill>
+                          <a:schemeClr val="bg1"/>
+                        </a:solidFill>
+                        <a:latin typeface="Sakkal Majalla" panose="02000000000000000000" pitchFamily="2" charset="-78"/>
+                        <a:cs typeface="Sakkal Majalla" panose="02000000000000000000" pitchFamily="2" charset="-78"/>
+                      </a:endParaRPr>
+                    </a:p>
+                  </a:txBody>
+                  <a:tcPr marL="36000" marR="36000" marT="0" marB="0" anchor="ctr">
+                    <a:lnL w="3175" cap="flat" cmpd="sng" algn="ctr">
+                      <a:solidFill>
+                        <a:schemeClr val="bg1"/>
+                      </a:solidFill>
+                      <a:prstDash val="solid"/>
+                      <a:round/>
+                      <a:headEnd type="none" w="med" len="med"/>
+                      <a:tailEnd type="none" w="med" len="med"/>
+                    </a:lnL>
+                    <a:lnR w="3175" cap="flat" cmpd="sng" algn="ctr">
+                      <a:solidFill>
+                        <a:schemeClr val="bg1"/>
+                      </a:solidFill>
+                      <a:prstDash val="solid"/>
+                      <a:round/>
+                      <a:headEnd type="none" w="med" len="med"/>
+                      <a:tailEnd type="none" w="med" len="med"/>
+                    </a:lnR>
+                    <a:lnT w="3175" cap="flat" cmpd="sng" algn="ctr">
+                      <a:solidFill>
+                        <a:schemeClr val="bg1"/>
+                      </a:solidFill>
+                      <a:prstDash val="solid"/>
+                      <a:round/>
+                      <a:headEnd type="none" w="med" len="med"/>
+                      <a:tailEnd type="none" w="med" len="med"/>
+                    </a:lnT>
+                    <a:lnB w="3175" cap="flat" cmpd="sng" algn="ctr">
+                      <a:solidFill>
+                        <a:schemeClr val="bg1"/>
+                      </a:solidFill>
+                      <a:prstDash val="solid"/>
+                      <a:round/>
+                      <a:headEnd type="none" w="med" len="med"/>
+                      <a:tailEnd type="none" w="med" len="med"/>
+                    </a:lnB>
+                    <a:lnTlToBr w="12700" cmpd="sng">
+                      <a:noFill/>
+                      <a:prstDash val="solid"/>
+                    </a:lnTlToBr>
+                    <a:lnBlToTr w="12700" cmpd="sng">
+                      <a:noFill/>
+                      <a:prstDash val="solid"/>
+                    </a:lnBlToTr>
+                    <a:solidFill>
+                      <a:schemeClr val="tx2"/>
+                    </a:solidFill>
+                  </a:tcPr>
+                </a:tc>
+                <a:extLst>
+                  <a:ext uri="{0D108BD9-81ED-4DB2-BD59-A6C34878D82A}">
+                    <a16:rowId xmlns:a16="http://schemas.microsoft.com/office/drawing/2014/main" val="3944166192"/>
+                  </a:ext>
+                </a:extLst>
+              </a:tr>
+              <a:tr h="142016">
+                <a:tc>
+                  <a:txBody>
+                    <a:bodyPr/>
+                    <a:lstStyle/>
+                    <a:p>
+                      <a:pPr algn="l">
+                        <a:lnSpc>
+                          <a:spcPts val="1200"/>
+                        </a:lnSpc>
+                      </a:pPr>
+                      <a:r>
+                        <a:rPr lang="en-US" sz="600" b="0" i="0" dirty="0">
+                          <a:solidFill>
+                            <a:schemeClr val="tx2"/>
+                          </a:solidFill>
+                          <a:latin typeface="Fund Regular" pitchFamily="2" charset="-78"/>
+                          <a:cs typeface="Fund Regular" pitchFamily="2" charset="-78"/>
+                        </a:rPr>
+                        <a:t>NAME</a:t>
+                      </a:r>
+                    </a:p>
+                  </a:txBody>
+                  <a:tcPr marL="36000" marR="36000" marT="0" marB="0" anchor="ctr">
+                    <a:lnL w="12700" cap="flat" cmpd="sng" algn="ctr">
+                      <a:noFill/>
+                      <a:prstDash val="solid"/>
+                      <a:round/>
+                      <a:headEnd type="none" w="med" len="med"/>
+                      <a:tailEnd type="none" w="med" len="med"/>
+                    </a:lnL>
+                    <a:lnR w="12700" cap="flat" cmpd="sng" algn="ctr">
+                      <a:noFill/>
+                      <a:prstDash val="solid"/>
+                      <a:round/>
+                      <a:headEnd type="none" w="med" len="med"/>
+                      <a:tailEnd type="none" w="med" len="med"/>
+                    </a:lnR>
+                    <a:lnT w="3175" cap="flat" cmpd="sng" algn="ctr">
+                      <a:solidFill>
+                        <a:schemeClr val="bg1"/>
+                      </a:solidFill>
+                      <a:prstDash val="solid"/>
+                      <a:round/>
+                      <a:headEnd type="none" w="med" len="med"/>
+                      <a:tailEnd type="none" w="med" len="med"/>
+                    </a:lnT>
+                    <a:lnB w="6350" cap="flat" cmpd="sng" algn="ctr">
+                      <a:solidFill>
+                        <a:schemeClr val="bg1">
+                          <a:lumMod val="85000"/>
+                        </a:schemeClr>
+                      </a:solidFill>
+                      <a:prstDash val="solid"/>
+                      <a:round/>
+                      <a:headEnd type="none" w="med" len="med"/>
+                      <a:tailEnd type="none" w="med" len="med"/>
+                    </a:lnB>
+                    <a:lnTlToBr w="12700" cmpd="sng">
+                      <a:noFill/>
+                      <a:prstDash val="solid"/>
+                    </a:lnTlToBr>
+                    <a:lnBlToTr w="12700" cmpd="sng">
+                      <a:noFill/>
+                      <a:prstDash val="solid"/>
+                    </a:lnBlToTr>
+                    <a:solidFill>
+                      <a:schemeClr val="bg1">
+                        <a:lumMod val="95000"/>
+                      </a:schemeClr>
+                    </a:solidFill>
+                  </a:tcPr>
+                </a:tc>
+                <a:tc>
+                  <a:txBody>
+                    <a:bodyPr/>
+                    <a:lstStyle/>
+                    <a:p>
+                      <a:pPr algn="l">
+                        <a:lnSpc>
+                          <a:spcPts val="1200"/>
+                        </a:lnSpc>
+                      </a:pPr>
+                      <a:r>
+                        <a:rPr lang="en-US" sz="600" b="0" i="0" dirty="0">
+                          <a:solidFill>
+                            <a:schemeClr val="tx2"/>
+                          </a:solidFill>
+                          <a:latin typeface="Fund Regular" pitchFamily="2" charset="-78"/>
+                          <a:cs typeface="Fund Regular" pitchFamily="2" charset="-78"/>
+                        </a:rPr>
+                        <a:t>PIF EMPLOYEE</a:t>
+                      </a:r>
+                    </a:p>
+                  </a:txBody>
+                  <a:tcPr marL="36000" marR="36000" marT="0" marB="0" anchor="ctr">
+                    <a:lnL w="12700" cap="flat" cmpd="sng" algn="ctr">
+                      <a:noFill/>
+                      <a:prstDash val="solid"/>
+                      <a:round/>
+                      <a:headEnd type="none" w="med" len="med"/>
+                      <a:tailEnd type="none" w="med" len="med"/>
+                    </a:lnL>
+                    <a:lnR w="12700" cap="flat" cmpd="sng" algn="ctr">
+                      <a:noFill/>
+                      <a:prstDash val="solid"/>
+                      <a:round/>
+                      <a:headEnd type="none" w="med" len="med"/>
+                      <a:tailEnd type="none" w="med" len="med"/>
+                    </a:lnR>
+                    <a:lnT w="3175" cap="flat" cmpd="sng" algn="ctr">
+                      <a:solidFill>
+                        <a:schemeClr val="bg1"/>
+                      </a:solidFill>
+                      <a:prstDash val="solid"/>
+                      <a:round/>
+                      <a:headEnd type="none" w="med" len="med"/>
+                      <a:tailEnd type="none" w="med" len="med"/>
+                    </a:lnT>
+                    <a:lnB w="6350" cap="flat" cmpd="sng" algn="ctr">
+                      <a:solidFill>
+                        <a:schemeClr val="bg1">
+                          <a:lumMod val="85000"/>
+                        </a:schemeClr>
+                      </a:solidFill>
+                      <a:prstDash val="solid"/>
+                      <a:round/>
+                      <a:headEnd type="none" w="med" len="med"/>
+                      <a:tailEnd type="none" w="med" len="med"/>
+                    </a:lnB>
+                    <a:lnTlToBr w="12700" cmpd="sng">
+                      <a:noFill/>
+                      <a:prstDash val="solid"/>
+                    </a:lnTlToBr>
+                    <a:lnBlToTr w="12700" cmpd="sng">
+                      <a:noFill/>
+                      <a:prstDash val="solid"/>
+                    </a:lnBlToTr>
+                    <a:solidFill>
+                      <a:schemeClr val="bg1">
+                        <a:lumMod val="95000"/>
+                      </a:schemeClr>
+                    </a:solidFill>
+                  </a:tcPr>
+                </a:tc>
+                <a:tc>
+                  <a:txBody>
+                    <a:bodyPr/>
+                    <a:lstStyle/>
+                    <a:p>
+                      <a:pPr algn="l">
+                        <a:lnSpc>
+                          <a:spcPts val="1200"/>
+                        </a:lnSpc>
+                      </a:pPr>
+                      <a:r>
+                        <a:rPr lang="en-US" sz="600" b="0" i="0" dirty="0">
+                          <a:solidFill>
+                            <a:schemeClr val="tx2"/>
+                          </a:solidFill>
+                          <a:latin typeface="Fund Regular" pitchFamily="2" charset="-78"/>
+                          <a:cs typeface="Fund Regular" pitchFamily="2" charset="-78"/>
+                        </a:rPr>
+                        <a:t>OTHER PIF REP.</a:t>
+                      </a:r>
+                    </a:p>
+                  </a:txBody>
+                  <a:tcPr marL="36000" marR="36000" marT="0" marB="0" anchor="ctr">
+                    <a:lnL w="12700" cap="flat" cmpd="sng" algn="ctr">
+                      <a:noFill/>
+                      <a:prstDash val="solid"/>
+                      <a:round/>
+                      <a:headEnd type="none" w="med" len="med"/>
+                      <a:tailEnd type="none" w="med" len="med"/>
+                    </a:lnL>
+                    <a:lnR w="12700" cap="flat" cmpd="sng" algn="ctr">
+                      <a:noFill/>
+                      <a:prstDash val="solid"/>
+                      <a:round/>
+                      <a:headEnd type="none" w="med" len="med"/>
+                      <a:tailEnd type="none" w="med" len="med"/>
+                    </a:lnR>
+                    <a:lnT w="3175" cap="flat" cmpd="sng" algn="ctr">
+                      <a:solidFill>
+                        <a:schemeClr val="bg1"/>
+                      </a:solidFill>
+                      <a:prstDash val="solid"/>
+                      <a:round/>
+                      <a:headEnd type="none" w="med" len="med"/>
+                      <a:tailEnd type="none" w="med" len="med"/>
+                    </a:lnT>
+                    <a:lnB w="6350" cap="flat" cmpd="sng" algn="ctr">
+                      <a:solidFill>
+                        <a:schemeClr val="bg1">
+                          <a:lumMod val="85000"/>
+                        </a:schemeClr>
+                      </a:solidFill>
+                      <a:prstDash val="solid"/>
+                      <a:round/>
+                      <a:headEnd type="none" w="med" len="med"/>
+                      <a:tailEnd type="none" w="med" len="med"/>
+                    </a:lnB>
+                    <a:lnTlToBr w="12700" cmpd="sng">
+                      <a:noFill/>
+                      <a:prstDash val="solid"/>
+                    </a:lnTlToBr>
+                    <a:lnBlToTr w="12700" cmpd="sng">
+                      <a:noFill/>
+                      <a:prstDash val="solid"/>
+                    </a:lnBlToTr>
+                    <a:solidFill>
+                      <a:schemeClr val="bg1">
+                        <a:lumMod val="95000"/>
+                      </a:schemeClr>
+                    </a:solidFill>
+                  </a:tcPr>
+                </a:tc>
+                <a:tc>
+                  <a:txBody>
+                    <a:bodyPr/>
+                    <a:lstStyle/>
+                    <a:p>
+                      <a:pPr algn="l">
+                        <a:lnSpc>
+                          <a:spcPts val="1200"/>
+                        </a:lnSpc>
+                      </a:pPr>
+                      <a:r>
+                        <a:rPr lang="en-US" sz="600" b="0" i="0" dirty="0">
+                          <a:solidFill>
+                            <a:schemeClr val="tx2"/>
+                          </a:solidFill>
+                          <a:latin typeface="Fund Regular" pitchFamily="2" charset="-78"/>
+                          <a:cs typeface="Fund Regular" pitchFamily="2" charset="-78"/>
+                        </a:rPr>
+                        <a:t>BOARD</a:t>
+                      </a:r>
+                    </a:p>
+                  </a:txBody>
+                  <a:tcPr marL="36000" marR="36000" marT="0" marB="0" anchor="ctr">
+                    <a:lnL w="12700" cmpd="sng">
+                      <a:noFill/>
+                    </a:lnL>
+                    <a:lnR w="12700" cap="flat" cmpd="sng" algn="ctr">
+                      <a:noFill/>
+                      <a:prstDash val="solid"/>
+                      <a:round/>
+                      <a:headEnd type="none" w="med" len="med"/>
+                      <a:tailEnd type="none" w="med" len="med"/>
+                    </a:lnR>
+                    <a:lnT w="3175" cap="flat" cmpd="sng" algn="ctr">
+                      <a:solidFill>
+                        <a:schemeClr val="bg1"/>
+                      </a:solidFill>
+                      <a:prstDash val="solid"/>
+                      <a:round/>
+                      <a:headEnd type="none" w="med" len="med"/>
+                      <a:tailEnd type="none" w="med" len="med"/>
+                    </a:lnT>
+                    <a:lnB w="6350" cap="flat" cmpd="sng" algn="ctr">
+                      <a:solidFill>
+                        <a:schemeClr val="bg1">
+                          <a:lumMod val="85000"/>
+                        </a:schemeClr>
+                      </a:solidFill>
+                      <a:prstDash val="solid"/>
+                      <a:round/>
+                      <a:headEnd type="none" w="med" len="med"/>
+                      <a:tailEnd type="none" w="med" len="med"/>
+                    </a:lnB>
+                    <a:lnTlToBr w="12700" cmpd="sng">
+                      <a:noFill/>
+                      <a:prstDash val="solid"/>
+                    </a:lnTlToBr>
+                    <a:lnBlToTr w="12700" cmpd="sng">
+                      <a:noFill/>
+                      <a:prstDash val="solid"/>
+                    </a:lnBlToTr>
+                    <a:solidFill>
+                      <a:schemeClr val="bg1">
+                        <a:lumMod val="95000"/>
+                      </a:schemeClr>
+                    </a:solidFill>
+                  </a:tcPr>
+                </a:tc>
+                <a:tc>
+                  <a:txBody>
+                    <a:bodyPr/>
+                    <a:lstStyle/>
+                    <a:p>
+                      <a:pPr algn="l">
+                        <a:lnSpc>
+                          <a:spcPts val="1200"/>
+                        </a:lnSpc>
+                      </a:pPr>
+                      <a:r>
+                        <a:rPr lang="en-US" sz="600" b="0" i="0" dirty="0">
+                          <a:solidFill>
+                            <a:schemeClr val="tx2"/>
+                          </a:solidFill>
+                          <a:latin typeface="Fund Regular" pitchFamily="2" charset="-78"/>
+                          <a:cs typeface="Fund Regular" pitchFamily="2" charset="-78"/>
+                        </a:rPr>
+                        <a:t>EXCOM</a:t>
+                      </a:r>
+                    </a:p>
+                  </a:txBody>
+                  <a:tcPr marL="36000" marR="36000" marT="0" marB="0" anchor="ctr">
+                    <a:lnL w="12700" cap="flat" cmpd="sng" algn="ctr">
+                      <a:noFill/>
+                      <a:prstDash val="solid"/>
+                      <a:round/>
+                      <a:headEnd type="none" w="med" len="med"/>
+                      <a:tailEnd type="none" w="med" len="med"/>
+                    </a:lnL>
+                    <a:lnR w="12700" cap="flat" cmpd="sng" algn="ctr">
+                      <a:noFill/>
+                      <a:prstDash val="solid"/>
+                      <a:round/>
+                      <a:headEnd type="none" w="med" len="med"/>
+                      <a:tailEnd type="none" w="med" len="med"/>
+                    </a:lnR>
+                    <a:lnT w="3175" cap="flat" cmpd="sng" algn="ctr">
+                      <a:solidFill>
+                        <a:schemeClr val="bg1"/>
+                      </a:solidFill>
+                      <a:prstDash val="solid"/>
+                      <a:round/>
+                      <a:headEnd type="none" w="med" len="med"/>
+                      <a:tailEnd type="none" w="med" len="med"/>
+                    </a:lnT>
+                    <a:lnB w="6350" cap="flat" cmpd="sng" algn="ctr">
+                      <a:solidFill>
+                        <a:schemeClr val="bg1">
+                          <a:lumMod val="85000"/>
+                        </a:schemeClr>
+                      </a:solidFill>
+                      <a:prstDash val="solid"/>
+                      <a:round/>
+                      <a:headEnd type="none" w="med" len="med"/>
+                      <a:tailEnd type="none" w="med" len="med"/>
+                    </a:lnB>
+                    <a:lnTlToBr w="12700" cmpd="sng">
+                      <a:noFill/>
+                      <a:prstDash val="solid"/>
+                    </a:lnTlToBr>
+                    <a:lnBlToTr w="12700" cmpd="sng">
+                      <a:noFill/>
+                      <a:prstDash val="solid"/>
+                    </a:lnBlToTr>
+                    <a:solidFill>
+                      <a:schemeClr val="bg1">
+                        <a:lumMod val="95000"/>
+                      </a:schemeClr>
+                    </a:solidFill>
+                  </a:tcPr>
+                </a:tc>
+                <a:tc>
+                  <a:txBody>
+                    <a:bodyPr/>
+                    <a:lstStyle/>
+                    <a:p>
+                      <a:pPr algn="l">
+                        <a:lnSpc>
+                          <a:spcPts val="1200"/>
+                        </a:lnSpc>
+                      </a:pPr>
+                      <a:r>
+                        <a:rPr lang="en-US" sz="600" b="0" i="0" dirty="0">
+                          <a:solidFill>
+                            <a:schemeClr val="tx2"/>
+                          </a:solidFill>
+                          <a:latin typeface="Fund Regular" pitchFamily="2" charset="-78"/>
+                          <a:cs typeface="Fund Regular" pitchFamily="2" charset="-78"/>
+                        </a:rPr>
+                        <a:t>AUDIT</a:t>
+                      </a:r>
+                    </a:p>
+                  </a:txBody>
+                  <a:tcPr marL="36000" marR="36000" marT="0" marB="0" anchor="ctr">
+                    <a:lnL w="12700" cap="flat" cmpd="sng" algn="ctr">
+                      <a:noFill/>
+                      <a:prstDash val="solid"/>
+                      <a:round/>
+                      <a:headEnd type="none" w="med" len="med"/>
+                      <a:tailEnd type="none" w="med" len="med"/>
+                    </a:lnL>
+                    <a:lnR w="12700" cap="flat" cmpd="sng" algn="ctr">
+                      <a:noFill/>
+                      <a:prstDash val="solid"/>
+                      <a:round/>
+                      <a:headEnd type="none" w="med" len="med"/>
+                      <a:tailEnd type="none" w="med" len="med"/>
+                    </a:lnR>
+                    <a:lnT w="3175" cap="flat" cmpd="sng" algn="ctr">
+                      <a:solidFill>
+                        <a:schemeClr val="bg1"/>
+                      </a:solidFill>
+                      <a:prstDash val="solid"/>
+                      <a:round/>
+                      <a:headEnd type="none" w="med" len="med"/>
+                      <a:tailEnd type="none" w="med" len="med"/>
+                    </a:lnT>
+                    <a:lnB w="6350" cap="flat" cmpd="sng" algn="ctr">
+                      <a:solidFill>
+                        <a:schemeClr val="bg1">
+                          <a:lumMod val="85000"/>
+                        </a:schemeClr>
+                      </a:solidFill>
+                      <a:prstDash val="solid"/>
+                      <a:round/>
+                      <a:headEnd type="none" w="med" len="med"/>
+                      <a:tailEnd type="none" w="med" len="med"/>
+                    </a:lnB>
+                    <a:lnTlToBr w="12700" cmpd="sng">
+                      <a:noFill/>
+                      <a:prstDash val="solid"/>
+                    </a:lnTlToBr>
+                    <a:lnBlToTr w="12700" cmpd="sng">
+                      <a:noFill/>
+                      <a:prstDash val="solid"/>
+                    </a:lnBlToTr>
+                    <a:solidFill>
+                      <a:schemeClr val="bg1">
+                        <a:lumMod val="95000"/>
+                      </a:schemeClr>
+                    </a:solidFill>
+                  </a:tcPr>
+                </a:tc>
+                <a:tc>
+                  <a:txBody>
+                    <a:bodyPr/>
+                    <a:lstStyle/>
+                    <a:p>
+                      <a:pPr algn="l">
+                        <a:lnSpc>
+                          <a:spcPts val="1200"/>
+                        </a:lnSpc>
+                      </a:pPr>
+                      <a:r>
+                        <a:rPr lang="en-US" sz="600" b="0" i="0" dirty="0">
+                          <a:solidFill>
+                            <a:schemeClr val="tx2"/>
+                          </a:solidFill>
+                          <a:latin typeface="Fund Regular" pitchFamily="2" charset="-78"/>
+                          <a:cs typeface="Fund Regular" pitchFamily="2" charset="-78"/>
+                        </a:rPr>
+                        <a:t>NRC</a:t>
+                      </a:r>
+                    </a:p>
+                  </a:txBody>
+                  <a:tcPr marL="36000" marR="36000" marT="0" marB="0" anchor="ctr">
+                    <a:lnL w="12700" cap="flat" cmpd="sng" algn="ctr">
+                      <a:noFill/>
+                      <a:prstDash val="solid"/>
+                      <a:round/>
+                      <a:headEnd type="none" w="med" len="med"/>
+                      <a:tailEnd type="none" w="med" len="med"/>
+                    </a:lnL>
+                    <a:lnR w="12700" cap="flat" cmpd="sng" algn="ctr">
+                      <a:noFill/>
+                      <a:prstDash val="solid"/>
+                      <a:round/>
+                      <a:headEnd type="none" w="med" len="med"/>
+                      <a:tailEnd type="none" w="med" len="med"/>
+                    </a:lnR>
+                    <a:lnT w="3175" cap="flat" cmpd="sng" algn="ctr">
+                      <a:solidFill>
+                        <a:schemeClr val="bg1"/>
+                      </a:solidFill>
+                      <a:prstDash val="solid"/>
+                      <a:round/>
+                      <a:headEnd type="none" w="med" len="med"/>
+                      <a:tailEnd type="none" w="med" len="med"/>
+                    </a:lnT>
+                    <a:lnB w="6350" cap="flat" cmpd="sng" algn="ctr">
+                      <a:solidFill>
+                        <a:schemeClr val="bg1">
+                          <a:lumMod val="85000"/>
+                        </a:schemeClr>
+                      </a:solidFill>
+                      <a:prstDash val="solid"/>
+                      <a:round/>
+                      <a:headEnd type="none" w="med" len="med"/>
+                      <a:tailEnd type="none" w="med" len="med"/>
+                    </a:lnB>
+                    <a:lnTlToBr w="12700" cmpd="sng">
+                      <a:noFill/>
+                      <a:prstDash val="solid"/>
+                    </a:lnTlToBr>
+                    <a:lnBlToTr w="12700" cmpd="sng">
+                      <a:noFill/>
+                      <a:prstDash val="solid"/>
+                    </a:lnBlToTr>
+                    <a:solidFill>
+                      <a:schemeClr val="bg1">
+                        <a:lumMod val="95000"/>
+                      </a:schemeClr>
+                    </a:solidFill>
+                  </a:tcPr>
+                </a:tc>
+                <a:extLst>
+                  <a:ext uri="{0D108BD9-81ED-4DB2-BD59-A6C34878D82A}">
+                    <a16:rowId xmlns:a16="http://schemas.microsoft.com/office/drawing/2014/main" val="2147178351"/>
+                  </a:ext>
+                </a:extLst>
+              </a:tr>
+              <a:tr h="132304">
+                <a:tc>
+                  <a:txBody>
+                    <a:bodyPr/>
+                    <a:lstStyle/>
+                    <a:p>
+                      <a:pPr algn="l">
+                        <a:lnSpc>
+                          <a:spcPts val="1200"/>
+                        </a:lnSpc>
+                      </a:pPr>
+                      <a:r>
+                        <a:rPr lang="en-US" sz="600" b="0" i="0" dirty="0">
+                          <a:solidFill>
+                            <a:schemeClr val="tx1"/>
+                          </a:solidFill>
+                          <a:latin typeface="Fund Light" pitchFamily="2" charset="-78"/>
+                          <a:cs typeface="Fund Light" pitchFamily="2" charset="-78"/>
+                        </a:rPr>
+                        <a:t>Member #1</a:t>
+                      </a:r>
+                    </a:p>
+                  </a:txBody>
+                  <a:tcPr marL="36000" marR="36000" marT="0" marB="0" anchor="ctr">
+                    <a:lnL w="12700" cap="flat" cmpd="sng" algn="ctr">
+                      <a:noFill/>
+                      <a:prstDash val="solid"/>
+                      <a:round/>
+                      <a:headEnd type="none" w="med" len="med"/>
+                      <a:tailEnd type="none" w="med" len="med"/>
+                    </a:lnL>
+                    <a:lnR w="12700" cap="flat" cmpd="sng" algn="ctr">
+                      <a:noFill/>
+                      <a:prstDash val="solid"/>
+                      <a:round/>
+                      <a:headEnd type="none" w="med" len="med"/>
+                      <a:tailEnd type="none" w="med" len="med"/>
+                    </a:lnR>
+                    <a:lnT w="6350" cap="flat" cmpd="sng" algn="ctr">
+                      <a:solidFill>
+                        <a:schemeClr val="bg1">
+                          <a:lumMod val="85000"/>
+                        </a:schemeClr>
+                      </a:solidFill>
+                      <a:prstDash val="solid"/>
+                      <a:round/>
+                      <a:headEnd type="none" w="med" len="med"/>
+                      <a:tailEnd type="none" w="med" len="med"/>
+                    </a:lnT>
+                    <a:lnB w="6350" cap="flat" cmpd="sng" algn="ctr">
+                      <a:solidFill>
+                        <a:schemeClr val="bg1">
+                          <a:lumMod val="85000"/>
+                        </a:schemeClr>
+                      </a:solidFill>
+                      <a:prstDash val="solid"/>
+                      <a:round/>
+                      <a:headEnd type="none" w="med" len="med"/>
+                      <a:tailEnd type="none" w="med" len="med"/>
+                    </a:lnB>
+                    <a:lnTlToBr w="12700" cmpd="sng">
+                      <a:noFill/>
+                      <a:prstDash val="solid"/>
+                    </a:lnTlToBr>
+                    <a:lnBlToTr w="12700" cmpd="sng">
+                      <a:noFill/>
+                      <a:prstDash val="solid"/>
+                    </a:lnBlToTr>
+                    <a:noFill/>
+                  </a:tcPr>
+                </a:tc>
+                <a:tc>
+                  <a:txBody>
+                    <a:bodyPr/>
+                    <a:lstStyle/>
+                    <a:p>
+                      <a:pPr algn="l">
+                        <a:lnSpc>
+                          <a:spcPts val="1200"/>
+                        </a:lnSpc>
+                      </a:pPr>
+                      <a:r>
+                        <a:rPr lang="en-US" sz="600" b="0" i="0" dirty="0">
+                          <a:solidFill>
+                            <a:schemeClr val="tx1"/>
+                          </a:solidFill>
+                          <a:latin typeface="Fund Light" pitchFamily="2" charset="-78"/>
+                          <a:cs typeface="Fund Light" pitchFamily="2" charset="-78"/>
+                        </a:rPr>
+                        <a:t>No</a:t>
+                      </a:r>
+                    </a:p>
+                  </a:txBody>
+                  <a:tcPr marL="36000" marR="36000" marT="0" marB="0" anchor="ctr">
+                    <a:lnL w="12700" cap="flat" cmpd="sng" algn="ctr">
+                      <a:noFill/>
+                      <a:prstDash val="solid"/>
+                      <a:round/>
+                      <a:headEnd type="none" w="med" len="med"/>
+                      <a:tailEnd type="none" w="med" len="med"/>
+                    </a:lnL>
+                    <a:lnR w="12700" cap="flat" cmpd="sng" algn="ctr">
+                      <a:noFill/>
+                      <a:prstDash val="solid"/>
+                      <a:round/>
+                      <a:headEnd type="none" w="med" len="med"/>
+                      <a:tailEnd type="none" w="med" len="med"/>
+                    </a:lnR>
+                    <a:lnT w="6350" cap="flat" cmpd="sng" algn="ctr">
+                      <a:solidFill>
+                        <a:schemeClr val="bg1">
+                          <a:lumMod val="85000"/>
+                        </a:schemeClr>
+                      </a:solidFill>
+                      <a:prstDash val="solid"/>
+                      <a:round/>
+                      <a:headEnd type="none" w="med" len="med"/>
+                      <a:tailEnd type="none" w="med" len="med"/>
+                    </a:lnT>
+                    <a:lnB w="6350" cap="flat" cmpd="sng" algn="ctr">
+                      <a:solidFill>
+                        <a:schemeClr val="bg1">
+                          <a:lumMod val="85000"/>
+                        </a:schemeClr>
+                      </a:solidFill>
+                      <a:prstDash val="solid"/>
+                      <a:round/>
+                      <a:headEnd type="none" w="med" len="med"/>
+                      <a:tailEnd type="none" w="med" len="med"/>
+                    </a:lnB>
+                    <a:lnTlToBr w="12700" cmpd="sng">
+                      <a:noFill/>
+                      <a:prstDash val="solid"/>
+                    </a:lnTlToBr>
+                    <a:lnBlToTr w="12700" cmpd="sng">
+                      <a:noFill/>
+                      <a:prstDash val="solid"/>
+                    </a:lnBlToTr>
+                    <a:noFill/>
+                  </a:tcPr>
+                </a:tc>
+                <a:tc>
+                  <a:txBody>
+                    <a:bodyPr/>
+                    <a:lstStyle/>
+                    <a:p>
+                      <a:pPr algn="l">
+                        <a:lnSpc>
+                          <a:spcPts val="1200"/>
+                        </a:lnSpc>
+                      </a:pPr>
+                      <a:r>
+                        <a:rPr lang="en-US" sz="600" b="0" i="0">
+                          <a:solidFill>
+                            <a:schemeClr val="tx1"/>
+                          </a:solidFill>
+                          <a:latin typeface="Fund Light" pitchFamily="2" charset="-78"/>
+                          <a:cs typeface="Fund Light" pitchFamily="2" charset="-78"/>
+                        </a:rPr>
+                        <a:t>Yes</a:t>
+                      </a:r>
+                      <a:endParaRPr lang="en-US" sz="600" b="0" i="0" dirty="0">
+                        <a:solidFill>
+                          <a:schemeClr val="tx1"/>
+                        </a:solidFill>
+                        <a:latin typeface="Fund Light" pitchFamily="2" charset="-78"/>
+                        <a:cs typeface="Fund Light" pitchFamily="2" charset="-78"/>
+                      </a:endParaRPr>
+                    </a:p>
+                  </a:txBody>
+                  <a:tcPr marL="36000" marR="36000" marT="0" marB="0" anchor="ctr">
+                    <a:lnL w="12700" cap="flat" cmpd="sng" algn="ctr">
+                      <a:noFill/>
+                      <a:prstDash val="solid"/>
+                      <a:round/>
+                      <a:headEnd type="none" w="med" len="med"/>
+                      <a:tailEnd type="none" w="med" len="med"/>
+                    </a:lnL>
+                    <a:lnR w="12700" cap="flat" cmpd="sng" algn="ctr">
+                      <a:noFill/>
+                      <a:prstDash val="solid"/>
+                      <a:round/>
+                      <a:headEnd type="none" w="med" len="med"/>
+                      <a:tailEnd type="none" w="med" len="med"/>
+                    </a:lnR>
+                    <a:lnT w="6350" cap="flat" cmpd="sng" algn="ctr">
+                      <a:solidFill>
+                        <a:schemeClr val="bg1">
+                          <a:lumMod val="85000"/>
+                        </a:schemeClr>
+                      </a:solidFill>
+                      <a:prstDash val="solid"/>
+                      <a:round/>
+                      <a:headEnd type="none" w="med" len="med"/>
+                      <a:tailEnd type="none" w="med" len="med"/>
+                    </a:lnT>
+                    <a:lnB w="6350" cap="flat" cmpd="sng" algn="ctr">
+                      <a:solidFill>
+                        <a:schemeClr val="bg1">
+                          <a:lumMod val="85000"/>
+                        </a:schemeClr>
+                      </a:solidFill>
+                      <a:prstDash val="solid"/>
+                      <a:round/>
+                      <a:headEnd type="none" w="med" len="med"/>
+                      <a:tailEnd type="none" w="med" len="med"/>
+                    </a:lnB>
+                    <a:lnTlToBr w="12700" cmpd="sng">
+                      <a:noFill/>
+                      <a:prstDash val="solid"/>
+                    </a:lnTlToBr>
+                    <a:lnBlToTr w="12700" cmpd="sng">
+                      <a:noFill/>
+                      <a:prstDash val="solid"/>
+                    </a:lnBlToTr>
+                    <a:noFill/>
+                  </a:tcPr>
+                </a:tc>
+                <a:tc>
+                  <a:txBody>
+                    <a:bodyPr/>
+                    <a:lstStyle/>
+                    <a:p>
+                      <a:pPr marL="0" algn="l" defTabSz="914400" rtl="0" eaLnBrk="1" latinLnBrk="0" hangingPunct="1">
+                        <a:lnSpc>
+                          <a:spcPts val="1200"/>
+                        </a:lnSpc>
+                      </a:pPr>
+                      <a:r>
+                        <a:rPr lang="en-US" sz="600" b="0" i="0" kern="1200" dirty="0">
+                          <a:solidFill>
+                            <a:schemeClr val="tx1"/>
+                          </a:solidFill>
+                          <a:latin typeface="Fund Light" pitchFamily="2" charset="-78"/>
+                          <a:ea typeface="+mn-ea"/>
+                          <a:cs typeface="Fund Light" pitchFamily="2" charset="-78"/>
+                        </a:rPr>
+                        <a:t>q</a:t>
+                      </a:r>
+                    </a:p>
+                  </a:txBody>
+                  <a:tcPr marL="36000" marR="36000" marT="0" marB="0" anchor="b">
+                    <a:lnL w="12700" cmpd="sng">
+                      <a:noFill/>
+                    </a:lnL>
+                    <a:lnR w="12700" cap="flat" cmpd="sng" algn="ctr">
+                      <a:noFill/>
+                      <a:prstDash val="solid"/>
+                      <a:round/>
+                      <a:headEnd type="none" w="med" len="med"/>
+                      <a:tailEnd type="none" w="med" len="med"/>
+                    </a:lnR>
+                    <a:lnT w="6350" cap="flat" cmpd="sng" algn="ctr">
+                      <a:solidFill>
+                        <a:schemeClr val="bg1">
+                          <a:lumMod val="85000"/>
+                        </a:schemeClr>
+                      </a:solidFill>
+                      <a:prstDash val="solid"/>
+                      <a:round/>
+                      <a:headEnd type="none" w="med" len="med"/>
+                      <a:tailEnd type="none" w="med" len="med"/>
+                    </a:lnT>
+                    <a:lnB w="6350" cap="flat" cmpd="sng" algn="ctr">
+                      <a:solidFill>
+                        <a:schemeClr val="bg1">
+                          <a:lumMod val="85000"/>
+                        </a:schemeClr>
+                      </a:solidFill>
+                      <a:prstDash val="solid"/>
+                      <a:round/>
+                      <a:headEnd type="none" w="med" len="med"/>
+                      <a:tailEnd type="none" w="med" len="med"/>
+                    </a:lnB>
+                    <a:lnTlToBr w="12700" cmpd="sng">
+                      <a:noFill/>
+                      <a:prstDash val="solid"/>
+                    </a:lnTlToBr>
+                    <a:lnBlToTr w="12700" cmpd="sng">
+                      <a:noFill/>
+                      <a:prstDash val="solid"/>
+                    </a:lnBlToTr>
+                    <a:noFill/>
+                  </a:tcPr>
+                </a:tc>
+                <a:tc>
+                  <a:txBody>
+                    <a:bodyPr/>
+                    <a:lstStyle/>
+                    <a:p>
+                      <a:pPr marL="0" algn="l" defTabSz="914400" rtl="0" eaLnBrk="1" latinLnBrk="0" hangingPunct="1">
+                        <a:lnSpc>
+                          <a:spcPts val="1200"/>
+                        </a:lnSpc>
+                      </a:pPr>
+                      <a:r>
+                        <a:rPr lang="en-US" sz="600" b="0" i="0" kern="1200" dirty="0">
+                          <a:solidFill>
+                            <a:schemeClr val="tx1"/>
+                          </a:solidFill>
+                          <a:latin typeface="Fund Light" pitchFamily="2" charset="-78"/>
+                          <a:ea typeface="+mn-ea"/>
+                          <a:cs typeface="Fund Light" pitchFamily="2" charset="-78"/>
+                        </a:rPr>
+                        <a:t>q</a:t>
+                      </a:r>
+                    </a:p>
+                  </a:txBody>
+                  <a:tcPr marL="36000" marR="36000" marT="0" marB="0" anchor="ctr">
+                    <a:lnL w="12700" cap="flat" cmpd="sng" algn="ctr">
+                      <a:noFill/>
+                      <a:prstDash val="solid"/>
+                      <a:round/>
+                      <a:headEnd type="none" w="med" len="med"/>
+                      <a:tailEnd type="none" w="med" len="med"/>
+                    </a:lnL>
+                    <a:lnR w="12700" cap="flat" cmpd="sng" algn="ctr">
+                      <a:noFill/>
+                      <a:prstDash val="solid"/>
+                      <a:round/>
+                      <a:headEnd type="none" w="med" len="med"/>
+                      <a:tailEnd type="none" w="med" len="med"/>
+                    </a:lnR>
+                    <a:lnT w="6350" cap="flat" cmpd="sng" algn="ctr">
+                      <a:solidFill>
+                        <a:schemeClr val="bg1">
+                          <a:lumMod val="85000"/>
+                        </a:schemeClr>
+                      </a:solidFill>
+                      <a:prstDash val="solid"/>
+                      <a:round/>
+                      <a:headEnd type="none" w="med" len="med"/>
+                      <a:tailEnd type="none" w="med" len="med"/>
+                    </a:lnT>
+                    <a:lnB w="6350" cap="flat" cmpd="sng" algn="ctr">
+                      <a:solidFill>
+                        <a:schemeClr val="bg1">
+                          <a:lumMod val="85000"/>
+                        </a:schemeClr>
+                      </a:solidFill>
+                      <a:prstDash val="solid"/>
+                      <a:round/>
+                      <a:headEnd type="none" w="med" len="med"/>
+                      <a:tailEnd type="none" w="med" len="med"/>
+                    </a:lnB>
+                    <a:lnTlToBr w="12700" cmpd="sng">
+                      <a:noFill/>
+                      <a:prstDash val="solid"/>
+                    </a:lnTlToBr>
+                    <a:lnBlToTr w="12700" cmpd="sng">
+                      <a:noFill/>
+                      <a:prstDash val="solid"/>
+                    </a:lnBlToTr>
+                    <a:noFill/>
+                  </a:tcPr>
+                </a:tc>
+                <a:tc>
+                  <a:txBody>
+                    <a:bodyPr/>
+                    <a:lstStyle/>
+                    <a:p>
+                      <a:pPr marL="0" algn="l" defTabSz="914400" rtl="0" eaLnBrk="1" latinLnBrk="0" hangingPunct="1">
+                        <a:lnSpc>
+                          <a:spcPts val="1200"/>
+                        </a:lnSpc>
+                      </a:pPr>
+                      <a:r>
+                        <a:rPr lang="en-US" sz="600" b="0" i="0" kern="1200" dirty="0">
+                          <a:solidFill>
+                            <a:schemeClr val="tx1"/>
+                          </a:solidFill>
+                          <a:latin typeface="Fund Light" pitchFamily="2" charset="-78"/>
+                          <a:ea typeface="+mn-ea"/>
+                          <a:cs typeface="Fund Light" pitchFamily="2" charset="-78"/>
+                        </a:rPr>
+                        <a:t>q</a:t>
+                      </a:r>
+                    </a:p>
+                  </a:txBody>
+                  <a:tcPr marL="36000" marR="36000" marT="0" marB="0" anchor="ctr">
+                    <a:lnL w="12700" cap="flat" cmpd="sng" algn="ctr">
+                      <a:noFill/>
+                      <a:prstDash val="solid"/>
+                      <a:round/>
+                      <a:headEnd type="none" w="med" len="med"/>
+                      <a:tailEnd type="none" w="med" len="med"/>
+                    </a:lnL>
+                    <a:lnR w="12700" cap="flat" cmpd="sng" algn="ctr">
+                      <a:noFill/>
+                      <a:prstDash val="solid"/>
+                      <a:round/>
+                      <a:headEnd type="none" w="med" len="med"/>
+                      <a:tailEnd type="none" w="med" len="med"/>
+                    </a:lnR>
+                    <a:lnT w="6350" cap="flat" cmpd="sng" algn="ctr">
+                      <a:solidFill>
+                        <a:schemeClr val="bg1">
+                          <a:lumMod val="85000"/>
+                        </a:schemeClr>
+                      </a:solidFill>
+                      <a:prstDash val="solid"/>
+                      <a:round/>
+                      <a:headEnd type="none" w="med" len="med"/>
+                      <a:tailEnd type="none" w="med" len="med"/>
+                    </a:lnT>
+                    <a:lnB w="6350" cap="flat" cmpd="sng" algn="ctr">
+                      <a:solidFill>
+                        <a:schemeClr val="bg1">
+                          <a:lumMod val="85000"/>
+                        </a:schemeClr>
+                      </a:solidFill>
+                      <a:prstDash val="solid"/>
+                      <a:round/>
+                      <a:headEnd type="none" w="med" len="med"/>
+                      <a:tailEnd type="none" w="med" len="med"/>
+                    </a:lnB>
+                    <a:lnTlToBr w="12700" cmpd="sng">
+                      <a:noFill/>
+                      <a:prstDash val="solid"/>
+                    </a:lnTlToBr>
+                    <a:lnBlToTr w="12700" cmpd="sng">
+                      <a:noFill/>
+                      <a:prstDash val="solid"/>
+                    </a:lnBlToTr>
+                    <a:noFill/>
+                  </a:tcPr>
+                </a:tc>
+                <a:tc>
+                  <a:txBody>
+                    <a:bodyPr/>
+                    <a:lstStyle/>
+                    <a:p>
+                      <a:pPr marL="0" algn="l" defTabSz="914400" rtl="0" eaLnBrk="1" latinLnBrk="0" hangingPunct="1">
+                        <a:lnSpc>
+                          <a:spcPts val="1200"/>
+                        </a:lnSpc>
+                      </a:pPr>
+                      <a:r>
+                        <a:rPr lang="en-US" sz="600" b="0" i="0" kern="1200" dirty="0">
+                          <a:solidFill>
+                            <a:schemeClr val="tx1"/>
+                          </a:solidFill>
+                          <a:latin typeface="Fund Light" pitchFamily="2" charset="-78"/>
+                          <a:ea typeface="+mn-ea"/>
+                          <a:cs typeface="Fund Light" pitchFamily="2" charset="-78"/>
+                        </a:rPr>
+                        <a:t>q</a:t>
+                      </a:r>
+                    </a:p>
+                  </a:txBody>
+                  <a:tcPr marL="36000" marR="36000" marT="0" marB="0" anchor="ctr">
+                    <a:lnL w="12700" cap="flat" cmpd="sng" algn="ctr">
+                      <a:noFill/>
+                      <a:prstDash val="solid"/>
+                      <a:round/>
+                      <a:headEnd type="none" w="med" len="med"/>
+                      <a:tailEnd type="none" w="med" len="med"/>
+                    </a:lnL>
+                    <a:lnR w="12700" cap="flat" cmpd="sng" algn="ctr">
+                      <a:noFill/>
+                      <a:prstDash val="solid"/>
+                      <a:round/>
+                      <a:headEnd type="none" w="med" len="med"/>
+                      <a:tailEnd type="none" w="med" len="med"/>
+                    </a:lnR>
+                    <a:lnT w="6350" cap="flat" cmpd="sng" algn="ctr">
+                      <a:solidFill>
+                        <a:schemeClr val="bg1">
+                          <a:lumMod val="85000"/>
+                        </a:schemeClr>
+                      </a:solidFill>
+                      <a:prstDash val="solid"/>
+                      <a:round/>
+                      <a:headEnd type="none" w="med" len="med"/>
+                      <a:tailEnd type="none" w="med" len="med"/>
+                    </a:lnT>
+                    <a:lnB w="6350" cap="flat" cmpd="sng" algn="ctr">
+                      <a:solidFill>
+                        <a:schemeClr val="bg1">
+                          <a:lumMod val="85000"/>
+                        </a:schemeClr>
+                      </a:solidFill>
+                      <a:prstDash val="solid"/>
+                      <a:round/>
+                      <a:headEnd type="none" w="med" len="med"/>
+                      <a:tailEnd type="none" w="med" len="med"/>
+                    </a:lnB>
+                    <a:lnTlToBr w="12700" cmpd="sng">
+                      <a:noFill/>
+                      <a:prstDash val="solid"/>
+                    </a:lnTlToBr>
+                    <a:lnBlToTr w="12700" cmpd="sng">
+                      <a:noFill/>
+                      <a:prstDash val="solid"/>
+                    </a:lnBlToTr>
+                    <a:noFill/>
+                  </a:tcPr>
+                </a:tc>
+                <a:extLst>
+                  <a:ext uri="{0D108BD9-81ED-4DB2-BD59-A6C34878D82A}">
+                    <a16:rowId xmlns:a16="http://schemas.microsoft.com/office/drawing/2014/main" val="1961714469"/>
+                  </a:ext>
+                </a:extLst>
+              </a:tr>
+            </a:tbl>
+          </a:graphicData>
+        </a:graphic>
+      </p:graphicFrame>
       <p:sp>
         <p:nvSpPr>
-          <p:cNvPr id="4" name="Footer Placeholder 3">
+          <p:cNvPr id="2" name="Footer Placeholder 1">
             <a:extLst>
               <a:ext uri="{FF2B5EF4-FFF2-40B4-BE49-F238E27FC236}">
-                <a16:creationId xmlns:a16="http://schemas.microsoft.com/office/drawing/2014/main" id="{704A712B-7D94-412A-AD53-6AE8FF5AB34D}"/>
+                <a16:creationId xmlns:a16="http://schemas.microsoft.com/office/drawing/2014/main" id="{E4A55677-1FD6-40FD-A80C-B7E44566976B}"/>
               </a:ext>
             </a:extLst>
           </p:cNvPr>
@@ -10357,10 +11974,10 @@
       </p:grpSp>
       <p:sp>
         <p:nvSpPr>
-          <p:cNvPr id="6" name="Footer Placeholder 5">
+          <p:cNvPr id="5" name="Footer Placeholder 4">
             <a:extLst>
               <a:ext uri="{FF2B5EF4-FFF2-40B4-BE49-F238E27FC236}">
-                <a16:creationId xmlns:a16="http://schemas.microsoft.com/office/drawing/2014/main" id="{2216E377-ED81-42F2-9E55-156972D6B437}"/>
+                <a16:creationId xmlns:a16="http://schemas.microsoft.com/office/drawing/2014/main" id="{527A73E8-F067-48F1-8C9F-D1E79455538B}"/>
               </a:ext>
             </a:extLst>
           </p:cNvPr>
@@ -11147,7 +12764,7 @@
 </file>
 
 <file path=customXml/itemProps1.xml><?xml version="1.0" encoding="utf-8"?>
-<ds:datastoreItem xmlns:ds="http://schemas.openxmlformats.org/officeDocument/2006/customXml" ds:itemID="{1F932E4C-D55E-4037-A535-9777C851BCE7}">
+<ds:datastoreItem xmlns:ds="http://schemas.openxmlformats.org/officeDocument/2006/customXml" ds:itemID="{4BBA4F4B-83B1-4A04-928D-4E5BAAE29B16}">
   <ds:schemaRefs>
     <ds:schemaRef ds:uri="http://www.w3.org/2001/XMLSchema"/>
     <ds:schemaRef ds:uri="http://www.boldonjames.com/2008/01/sie/internal/label"/>
@@ -11156,7 +12773,7 @@
 </file>
 
 <file path=customXml/itemProps2.xml><?xml version="1.0" encoding="utf-8"?>
-<ds:datastoreItem xmlns:ds="http://schemas.openxmlformats.org/officeDocument/2006/customXml" ds:itemID="{DA1CAF05-4605-4D79-B2CD-2732286DB1E6}">
+<ds:datastoreItem xmlns:ds="http://schemas.openxmlformats.org/officeDocument/2006/customXml" ds:itemID="{36AC9BF8-2F14-4C26-BFEB-10E05DBCEFAB}">
   <ds:schemaRefs>
     <ds:schemaRef ds:uri="http://www.w3.org/2001/XMLSchema"/>
     <ds:schemaRef ds:uri="http://www.boldonjames.com/2016/02/Classifier/internal/wrappedLabelInfo"/>

</xml_diff>